<commit_message>
Updated the sprint 1 powerpoint. Added dataflow for STB
</commit_message>
<xml_diff>
--- a/Sprint1_Documents/Sprint 1 Review.pptx
+++ b/Sprint1_Documents/Sprint 1 Review.pptx
@@ -17,8 +17,8 @@
     <p:sldId id="262" r:id="rId8"/>
     <p:sldId id="263" r:id="rId9"/>
     <p:sldId id="264" r:id="rId10"/>
-    <p:sldId id="265" r:id="rId11"/>
-    <p:sldId id="266" r:id="rId12"/>
+    <p:sldId id="268" r:id="rId11"/>
+    <p:sldId id="269" r:id="rId12"/>
     <p:sldId id="267" r:id="rId13"/>
   </p:sldIdLst>
   <p:sldSz cx="9144000" cy="6858000" type="screen4x3"/>
@@ -203,7 +203,7 @@
           <a:p>
             <a:fld id="{54B4DD35-6E11-43E5-91A4-D3C24AD61D59}" type="datetimeFigureOut">
               <a:rPr lang="en-US" smtClean="0"/>
-              <a:t>10/6/2012</a:t>
+              <a:t>10/8/2012</a:t>
             </a:fld>
             <a:endParaRPr lang="en-US"/>
           </a:p>
@@ -554,7 +554,7 @@
               <a:rPr lang="en-US" smtClean="0"/>
               <a:t>1</a:t>
             </a:fld>
-            <a:endParaRPr lang="en-US"/>
+            <a:endParaRPr lang="en-US" dirty="0"/>
           </a:p>
         </p:txBody>
       </p:sp>
@@ -616,6 +616,102 @@
           <a:lstStyle/>
           <a:p>
             <a:r>
+              <a:rPr lang="en-US" dirty="0" smtClean="0"/>
+              <a:t>Quickly</a:t>
+            </a:r>
+            <a:r>
+              <a:rPr lang="en-US" baseline="0" dirty="0" smtClean="0"/>
+              <a:t> show that we have a backlog, no need to go into </a:t>
+            </a:r>
+            <a:r>
+              <a:rPr lang="en-US" baseline="0" smtClean="0"/>
+              <a:t>great detail here</a:t>
+            </a:r>
+            <a:endParaRPr lang="en-US"/>
+          </a:p>
+        </p:txBody>
+      </p:sp>
+      <p:sp>
+        <p:nvSpPr>
+          <p:cNvPr id="4" name="Slide Number Placeholder 3"/>
+          <p:cNvSpPr>
+            <a:spLocks noGrp="1"/>
+          </p:cNvSpPr>
+          <p:nvPr>
+            <p:ph type="sldNum" sz="quarter" idx="10"/>
+          </p:nvPr>
+        </p:nvSpPr>
+        <p:spPr/>
+        <p:txBody>
+          <a:bodyPr/>
+          <a:lstStyle/>
+          <a:p>
+            <a:fld id="{2196A064-7C2B-4BD1-B717-284E7E6AAF69}" type="slidenum">
+              <a:rPr lang="en-US" smtClean="0"/>
+              <a:t>11</a:t>
+            </a:fld>
+            <a:endParaRPr lang="en-US"/>
+          </a:p>
+        </p:txBody>
+      </p:sp>
+    </p:spTree>
+    <p:extLst>
+      <p:ext uri="{BB962C8B-B14F-4D97-AF65-F5344CB8AC3E}">
+        <p14:creationId xmlns:p14="http://schemas.microsoft.com/office/powerpoint/2010/main" val="542630260"/>
+      </p:ext>
+    </p:extLst>
+  </p:cSld>
+  <p:clrMapOvr>
+    <a:masterClrMapping/>
+  </p:clrMapOvr>
+</p:notes>
+</file>
+
+<file path=ppt/notesSlides/notesSlide11.xml><?xml version="1.0" encoding="utf-8"?>
+<p:notes xmlns:a="http://schemas.openxmlformats.org/drawingml/2006/main" xmlns:r="http://schemas.openxmlformats.org/officeDocument/2006/relationships" xmlns:p="http://schemas.openxmlformats.org/presentationml/2006/main">
+  <p:cSld>
+    <p:spTree>
+      <p:nvGrpSpPr>
+        <p:cNvPr id="1" name=""/>
+        <p:cNvGrpSpPr/>
+        <p:nvPr/>
+      </p:nvGrpSpPr>
+      <p:grpSpPr>
+        <a:xfrm>
+          <a:off x="0" y="0"/>
+          <a:ext cx="0" cy="0"/>
+          <a:chOff x="0" y="0"/>
+          <a:chExt cx="0" cy="0"/>
+        </a:xfrm>
+      </p:grpSpPr>
+      <p:sp>
+        <p:nvSpPr>
+          <p:cNvPr id="2" name="Slide Image Placeholder 1"/>
+          <p:cNvSpPr>
+            <a:spLocks noGrp="1" noRot="1" noChangeAspect="1"/>
+          </p:cNvSpPr>
+          <p:nvPr>
+            <p:ph type="sldImg"/>
+          </p:nvPr>
+        </p:nvSpPr>
+        <p:spPr/>
+      </p:sp>
+      <p:sp>
+        <p:nvSpPr>
+          <p:cNvPr id="3" name="Notes Placeholder 2"/>
+          <p:cNvSpPr>
+            <a:spLocks noGrp="1"/>
+          </p:cNvSpPr>
+          <p:nvPr>
+            <p:ph type="body" idx="1"/>
+          </p:nvPr>
+        </p:nvSpPr>
+        <p:spPr/>
+        <p:txBody>
+          <a:bodyPr/>
+          <a:lstStyle/>
+          <a:p>
+            <a:r>
               <a:rPr lang="en-US" sz="1200" b="0" i="0" kern="1200" dirty="0" smtClean="0">
                 <a:solidFill>
                   <a:schemeClr val="tx1"/>
@@ -650,6 +746,32 @@
                 <a:cs typeface="+mn-cs"/>
               </a:rPr>
               <a:t>)</a:t>
+            </a:r>
+          </a:p>
+          <a:p>
+            <a:r>
+              <a:rPr lang="en-US" sz="1200" b="0" i="0" kern="1200" dirty="0" smtClean="0">
+                <a:solidFill>
+                  <a:schemeClr val="tx1"/>
+                </a:solidFill>
+                <a:effectLst/>
+                <a:latin typeface="+mn-lt"/>
+                <a:ea typeface="+mn-ea"/>
+                <a:cs typeface="+mn-cs"/>
+              </a:rPr>
+              <a:t>David,</a:t>
+            </a:r>
+            <a:r>
+              <a:rPr lang="en-US" sz="1200" b="0" i="0" kern="1200" baseline="0" dirty="0" smtClean="0">
+                <a:solidFill>
+                  <a:schemeClr val="tx1"/>
+                </a:solidFill>
+                <a:effectLst/>
+                <a:latin typeface="+mn-lt"/>
+                <a:ea typeface="+mn-ea"/>
+                <a:cs typeface="+mn-cs"/>
+              </a:rPr>
+              <a:t> Kevin, Marshall</a:t>
             </a:r>
             <a:endParaRPr lang="en-US" dirty="0"/>
           </a:p>
@@ -762,7 +884,7 @@
               <a:rPr lang="en-US" smtClean="0"/>
               <a:t>2</a:t>
             </a:fld>
-            <a:endParaRPr lang="en-US"/>
+            <a:endParaRPr lang="en-US" dirty="0"/>
           </a:p>
         </p:txBody>
       </p:sp>
@@ -825,7 +947,17 @@
           <a:p>
             <a:r>
               <a:rPr lang="en-US" dirty="0" smtClean="0"/>
-              <a:t>David Jarman</a:t>
+              <a:t>Scope – 30</a:t>
+            </a:r>
+            <a:r>
+              <a:rPr lang="en-US" baseline="0" dirty="0" smtClean="0"/>
+              <a:t> seconds</a:t>
+            </a:r>
+          </a:p>
+          <a:p>
+            <a:r>
+              <a:rPr lang="en-US" baseline="0" dirty="0" smtClean="0"/>
+              <a:t>David</a:t>
             </a:r>
             <a:endParaRPr lang="en-US" dirty="0"/>
           </a:p>
@@ -850,7 +982,7 @@
               <a:rPr lang="en-US" smtClean="0"/>
               <a:t>3</a:t>
             </a:fld>
-            <a:endParaRPr lang="en-US"/>
+            <a:endParaRPr lang="en-US" dirty="0"/>
           </a:p>
         </p:txBody>
       </p:sp>
@@ -913,6 +1045,17 @@
           <a:p>
             <a:r>
               <a:rPr lang="en-US" dirty="0" smtClean="0"/>
+              <a:t>User Stories</a:t>
+            </a:r>
+            <a:r>
+              <a:rPr lang="en-US" baseline="0" dirty="0" smtClean="0"/>
+              <a:t>: 1-2 minutes</a:t>
+            </a:r>
+            <a:endParaRPr lang="en-US" dirty="0" smtClean="0"/>
+          </a:p>
+          <a:p>
+            <a:r>
+              <a:rPr lang="en-US" dirty="0" smtClean="0"/>
               <a:t>Kevin</a:t>
             </a:r>
             <a:r>
@@ -942,7 +1085,7 @@
               <a:rPr lang="en-US" smtClean="0"/>
               <a:t>4</a:t>
             </a:fld>
-            <a:endParaRPr lang="en-US"/>
+            <a:endParaRPr lang="en-US" dirty="0"/>
           </a:p>
         </p:txBody>
       </p:sp>
@@ -1030,7 +1173,7 @@
               <a:rPr lang="en-US" smtClean="0"/>
               <a:t>5</a:t>
             </a:fld>
-            <a:endParaRPr lang="en-US"/>
+            <a:endParaRPr lang="en-US" dirty="0"/>
           </a:p>
         </p:txBody>
       </p:sp>
@@ -1118,7 +1261,7 @@
               <a:rPr lang="en-US" smtClean="0"/>
               <a:t>6</a:t>
             </a:fld>
-            <a:endParaRPr lang="en-US"/>
+            <a:endParaRPr lang="en-US" dirty="0"/>
           </a:p>
         </p:txBody>
       </p:sp>
@@ -1180,40 +1323,8 @@
           <a:lstStyle/>
           <a:p>
             <a:r>
-              <a:rPr lang="en-US" sz="1200" b="0" i="0" kern="1200" dirty="0" smtClean="0">
-                <a:solidFill>
-                  <a:schemeClr val="tx1"/>
-                </a:solidFill>
-                <a:effectLst/>
-                <a:latin typeface="+mn-lt"/>
-                <a:ea typeface="+mn-ea"/>
-                <a:cs typeface="+mn-cs"/>
-              </a:rPr>
-              <a:t>Risks, risk analysis, mitigation and </a:t>
-            </a:r>
-            <a:r>
-              <a:rPr lang="en-US" sz="1200" b="0" i="0" kern="1200" dirty="0" err="1" smtClean="0">
-                <a:solidFill>
-                  <a:schemeClr val="tx1"/>
-                </a:solidFill>
-                <a:effectLst/>
-                <a:latin typeface="+mn-lt"/>
-                <a:ea typeface="+mn-ea"/>
-                <a:cs typeface="+mn-cs"/>
-              </a:rPr>
-              <a:t>contigency</a:t>
-            </a:r>
-            <a:r>
-              <a:rPr lang="en-US" sz="1200" b="0" i="0" kern="1200" dirty="0" smtClean="0">
-                <a:solidFill>
-                  <a:schemeClr val="tx1"/>
-                </a:solidFill>
-                <a:effectLst/>
-                <a:latin typeface="+mn-lt"/>
-                <a:ea typeface="+mn-ea"/>
-                <a:cs typeface="+mn-cs"/>
-              </a:rPr>
-              <a:t> plan  (2 min)</a:t>
+              <a:rPr lang="en-US" dirty="0" smtClean="0"/>
+              <a:t>David</a:t>
             </a:r>
             <a:endParaRPr lang="en-US" dirty="0"/>
           </a:p>
@@ -1236,7 +1347,7 @@
           <a:p>
             <a:fld id="{2196A064-7C2B-4BD1-B717-284E7E6AAF69}" type="slidenum">
               <a:rPr lang="en-US" smtClean="0"/>
-              <a:t>9</a:t>
+              <a:t>7</a:t>
             </a:fld>
             <a:endParaRPr lang="en-US"/>
           </a:p>
@@ -1245,7 +1356,7 @@
     </p:spTree>
     <p:extLst>
       <p:ext uri="{BB962C8B-B14F-4D97-AF65-F5344CB8AC3E}">
-        <p14:creationId xmlns:p14="http://schemas.microsoft.com/office/powerpoint/2010/main" val="1966491216"/>
+        <p14:creationId xmlns:p14="http://schemas.microsoft.com/office/powerpoint/2010/main" val="3581750510"/>
       </p:ext>
     </p:extLst>
   </p:cSld>
@@ -1300,16 +1411,8 @@
           <a:lstStyle/>
           <a:p>
             <a:r>
-              <a:rPr lang="en-US" sz="1200" b="0" i="0" kern="1200" dirty="0" smtClean="0">
-                <a:solidFill>
-                  <a:schemeClr val="tx1"/>
-                </a:solidFill>
-                <a:effectLst/>
-                <a:latin typeface="+mn-lt"/>
-                <a:ea typeface="+mn-ea"/>
-                <a:cs typeface="+mn-cs"/>
-              </a:rPr>
-              <a:t>Budget   (1 min) ??</a:t>
+              <a:rPr lang="en-US" dirty="0" smtClean="0"/>
+              <a:t>Marshall + Kevin</a:t>
             </a:r>
             <a:endParaRPr lang="en-US" dirty="0"/>
           </a:p>
@@ -1332,7 +1435,7 @@
           <a:p>
             <a:fld id="{2196A064-7C2B-4BD1-B717-284E7E6AAF69}" type="slidenum">
               <a:rPr lang="en-US" smtClean="0"/>
-              <a:t>10</a:t>
+              <a:t>8</a:t>
             </a:fld>
             <a:endParaRPr lang="en-US"/>
           </a:p>
@@ -1341,7 +1444,7 @@
     </p:spTree>
     <p:extLst>
       <p:ext uri="{BB962C8B-B14F-4D97-AF65-F5344CB8AC3E}">
-        <p14:creationId xmlns:p14="http://schemas.microsoft.com/office/powerpoint/2010/main" val="2169562417"/>
+        <p14:creationId xmlns:p14="http://schemas.microsoft.com/office/powerpoint/2010/main" val="2086731328"/>
       </p:ext>
     </p:extLst>
   </p:cSld>
@@ -1405,19 +1508,7 @@
                 <a:ea typeface="+mn-ea"/>
                 <a:cs typeface="+mn-cs"/>
               </a:rPr>
-              <a:t>Deliverables  (30 </a:t>
-            </a:r>
-            <a:r>
-              <a:rPr lang="en-US" sz="1200" b="0" i="0" kern="1200" dirty="0" err="1" smtClean="0">
-                <a:solidFill>
-                  <a:schemeClr val="tx1"/>
-                </a:solidFill>
-                <a:effectLst/>
-                <a:latin typeface="+mn-lt"/>
-                <a:ea typeface="+mn-ea"/>
-                <a:cs typeface="+mn-cs"/>
-              </a:rPr>
-              <a:t>secs</a:t>
+              <a:t>Risks, risk analysis, mitigation and </a:t>
             </a:r>
             <a:r>
               <a:rPr lang="en-US" sz="1200" b="0" i="0" kern="1200" dirty="0" smtClean="0">
@@ -1429,10 +1520,10 @@
                 <a:ea typeface="+mn-ea"/>
                 <a:cs typeface="+mn-cs"/>
               </a:rPr>
-              <a:t>) –Requirements</a:t>
-            </a:r>
-            <a:r>
-              <a:rPr lang="en-US" sz="1200" b="0" i="0" kern="1200" baseline="0" dirty="0" smtClean="0">
+              <a:t>contingency </a:t>
+            </a:r>
+            <a:r>
+              <a:rPr lang="en-US" sz="1200" b="0" i="0" kern="1200" dirty="0" smtClean="0">
                 <a:solidFill>
                   <a:schemeClr val="tx1"/>
                 </a:solidFill>
@@ -1441,7 +1532,25 @@
                 <a:ea typeface="+mn-ea"/>
                 <a:cs typeface="+mn-cs"/>
               </a:rPr>
-              <a:t> and design document</a:t>
+              <a:t>plan  (2 min</a:t>
+            </a:r>
+            <a:r>
+              <a:rPr lang="en-US" sz="1200" b="0" i="0" kern="1200" dirty="0" smtClean="0">
+                <a:solidFill>
+                  <a:schemeClr val="tx1"/>
+                </a:solidFill>
+                <a:effectLst/>
+                <a:latin typeface="+mn-lt"/>
+                <a:ea typeface="+mn-ea"/>
+                <a:cs typeface="+mn-cs"/>
+              </a:rPr>
+              <a:t>)</a:t>
+            </a:r>
+          </a:p>
+          <a:p>
+            <a:r>
+              <a:rPr lang="en-US" dirty="0" smtClean="0"/>
+              <a:t>David</a:t>
             </a:r>
             <a:endParaRPr lang="en-US" dirty="0"/>
           </a:p>
@@ -1464,7 +1573,7 @@
           <a:p>
             <a:fld id="{2196A064-7C2B-4BD1-B717-284E7E6AAF69}" type="slidenum">
               <a:rPr lang="en-US" smtClean="0"/>
-              <a:t>11</a:t>
+              <a:t>9</a:t>
             </a:fld>
             <a:endParaRPr lang="en-US"/>
           </a:p>
@@ -1473,7 +1582,7 @@
     </p:spTree>
     <p:extLst>
       <p:ext uri="{BB962C8B-B14F-4D97-AF65-F5344CB8AC3E}">
-        <p14:creationId xmlns:p14="http://schemas.microsoft.com/office/powerpoint/2010/main" val="103245772"/>
+        <p14:creationId xmlns:p14="http://schemas.microsoft.com/office/powerpoint/2010/main" val="1966491216"/>
       </p:ext>
     </p:extLst>
   </p:cSld>
@@ -2108,7 +2217,7 @@
           <a:p>
             <a:fld id="{8D64633F-4130-4F4B-BCC3-306A9B157C17}" type="datetimeFigureOut">
               <a:rPr lang="en-US" smtClean="0"/>
-              <a:t>10/6/2012</a:t>
+              <a:t>10/8/2012</a:t>
             </a:fld>
             <a:endParaRPr lang="en-US"/>
           </a:p>
@@ -2304,7 +2413,7 @@
           <a:p>
             <a:fld id="{8D64633F-4130-4F4B-BCC3-306A9B157C17}" type="datetimeFigureOut">
               <a:rPr lang="en-US" smtClean="0"/>
-              <a:t>10/6/2012</a:t>
+              <a:t>10/8/2012</a:t>
             </a:fld>
             <a:endParaRPr lang="en-US"/>
           </a:p>
@@ -2489,7 +2598,7 @@
           <a:p>
             <a:fld id="{8D64633F-4130-4F4B-BCC3-306A9B157C17}" type="datetimeFigureOut">
               <a:rPr lang="en-US" smtClean="0"/>
-              <a:t>10/6/2012</a:t>
+              <a:t>10/8/2012</a:t>
             </a:fld>
             <a:endParaRPr lang="en-US"/>
           </a:p>
@@ -2639,7 +2748,7 @@
           <a:p>
             <a:fld id="{8D64633F-4130-4F4B-BCC3-306A9B157C17}" type="datetimeFigureOut">
               <a:rPr lang="en-US" smtClean="0"/>
-              <a:t>10/6/2012</a:t>
+              <a:t>10/8/2012</a:t>
             </a:fld>
             <a:endParaRPr lang="en-US"/>
           </a:p>
@@ -2894,7 +3003,7 @@
           <a:p>
             <a:fld id="{8D64633F-4130-4F4B-BCC3-306A9B157C17}" type="datetimeFigureOut">
               <a:rPr lang="en-US" smtClean="0"/>
-              <a:t>10/6/2012</a:t>
+              <a:t>10/8/2012</a:t>
             </a:fld>
             <a:endParaRPr lang="en-US"/>
           </a:p>
@@ -3303,7 +3412,7 @@
           <a:p>
             <a:fld id="{8D64633F-4130-4F4B-BCC3-306A9B157C17}" type="datetimeFigureOut">
               <a:rPr lang="en-US" smtClean="0"/>
-              <a:t>10/6/2012</a:t>
+              <a:t>10/8/2012</a:t>
             </a:fld>
             <a:endParaRPr lang="en-US"/>
           </a:p>
@@ -3749,7 +3858,7 @@
           <a:p>
             <a:fld id="{8D64633F-4130-4F4B-BCC3-306A9B157C17}" type="datetimeFigureOut">
               <a:rPr lang="en-US" smtClean="0"/>
-              <a:t>10/6/2012</a:t>
+              <a:t>10/8/2012</a:t>
             </a:fld>
             <a:endParaRPr lang="en-US"/>
           </a:p>
@@ -3850,7 +3959,7 @@
           <a:p>
             <a:fld id="{8D64633F-4130-4F4B-BCC3-306A9B157C17}" type="datetimeFigureOut">
               <a:rPr lang="en-US" smtClean="0"/>
-              <a:t>10/6/2012</a:t>
+              <a:t>10/8/2012</a:t>
             </a:fld>
             <a:endParaRPr lang="en-US"/>
           </a:p>
@@ -3971,7 +4080,7 @@
           <a:p>
             <a:fld id="{8D64633F-4130-4F4B-BCC3-306A9B157C17}" type="datetimeFigureOut">
               <a:rPr lang="en-US" smtClean="0"/>
-              <a:t>10/6/2012</a:t>
+              <a:t>10/8/2012</a:t>
             </a:fld>
             <a:endParaRPr lang="en-US"/>
           </a:p>
@@ -4245,7 +4354,7 @@
           <a:p>
             <a:fld id="{8D64633F-4130-4F4B-BCC3-306A9B157C17}" type="datetimeFigureOut">
               <a:rPr lang="en-US" smtClean="0"/>
-              <a:t>10/6/2012</a:t>
+              <a:t>10/8/2012</a:t>
             </a:fld>
             <a:endParaRPr lang="en-US"/>
           </a:p>
@@ -4450,7 +4559,7 @@
           <a:p>
             <a:fld id="{8D64633F-4130-4F4B-BCC3-306A9B157C17}" type="datetimeFigureOut">
               <a:rPr lang="en-US" smtClean="0"/>
-              <a:t>10/6/2012</a:t>
+              <a:t>10/8/2012</a:t>
             </a:fld>
             <a:endParaRPr lang="en-US"/>
           </a:p>
@@ -5559,7 +5668,7 @@
           <a:p>
             <a:fld id="{8D64633F-4130-4F4B-BCC3-306A9B157C17}" type="datetimeFigureOut">
               <a:rPr lang="en-US" smtClean="0"/>
-              <a:t>10/6/2012</a:t>
+              <a:t>10/8/2012</a:t>
             </a:fld>
             <a:endParaRPr lang="en-US"/>
           </a:p>
@@ -6089,31 +6198,149 @@
         </p:nvSpPr>
         <p:spPr/>
         <p:txBody>
+          <a:bodyPr>
+            <a:normAutofit lnSpcReduction="10000"/>
+          </a:bodyPr>
+          <a:lstStyle/>
+          <a:p>
+            <a:r>
+              <a:rPr lang="en-US" dirty="0" smtClean="0"/>
+              <a:t>Sprint 1: </a:t>
+            </a:r>
+            <a:r>
+              <a:rPr lang="en-US" sz="2400" dirty="0" smtClean="0"/>
+              <a:t>September 19</a:t>
+            </a:r>
+            <a:r>
+              <a:rPr lang="en-US" sz="2400" baseline="30000" dirty="0" smtClean="0"/>
+              <a:t>th</a:t>
+            </a:r>
+            <a:r>
+              <a:rPr lang="en-US" sz="2400" dirty="0" smtClean="0"/>
+              <a:t> – October 3</a:t>
+            </a:r>
+            <a:r>
+              <a:rPr lang="en-US" sz="2400" baseline="30000" dirty="0" smtClean="0"/>
+              <a:t>rd</a:t>
+            </a:r>
+            <a:endParaRPr lang="en-US" sz="2400" dirty="0" smtClean="0"/>
+          </a:p>
+          <a:p>
+            <a:pPr lvl="1"/>
+            <a:r>
+              <a:rPr lang="en-US" dirty="0" smtClean="0"/>
+              <a:t>Deliverables</a:t>
+            </a:r>
+          </a:p>
+          <a:p>
+            <a:pPr lvl="2"/>
+            <a:r>
+              <a:rPr lang="en-US" dirty="0" smtClean="0"/>
+              <a:t>Initial design document</a:t>
+            </a:r>
+          </a:p>
+          <a:p>
+            <a:pPr lvl="2"/>
+            <a:r>
+              <a:rPr lang="en-US" dirty="0" smtClean="0"/>
+              <a:t>Initial requirements document</a:t>
+            </a:r>
+          </a:p>
+          <a:p>
+            <a:pPr lvl="1"/>
+            <a:r>
+              <a:rPr lang="en-US" dirty="0" smtClean="0"/>
+              <a:t>Testing Environment</a:t>
+            </a:r>
+          </a:p>
+          <a:p>
+            <a:pPr lvl="2"/>
+            <a:r>
+              <a:rPr lang="en-US" dirty="0" smtClean="0"/>
+              <a:t>Meeting with STB team from Mitchell</a:t>
+            </a:r>
+          </a:p>
+          <a:p>
+            <a:pPr lvl="2"/>
+            <a:r>
+              <a:rPr lang="en-US" dirty="0" smtClean="0"/>
+              <a:t>Information exchange</a:t>
+            </a:r>
+          </a:p>
+          <a:p>
+            <a:pPr lvl="1"/>
+            <a:r>
+              <a:rPr lang="en-US" dirty="0" smtClean="0"/>
+              <a:t>Research</a:t>
+            </a:r>
+          </a:p>
+          <a:p>
+            <a:pPr lvl="2"/>
+            <a:r>
+              <a:rPr lang="en-US" dirty="0" smtClean="0"/>
+              <a:t>Dynamically load views on STB</a:t>
+            </a:r>
+          </a:p>
+          <a:p>
+            <a:pPr lvl="2"/>
+            <a:r>
+              <a:rPr lang="en-US" dirty="0" smtClean="0"/>
+              <a:t>Sending game state using Protocol Buffers</a:t>
+            </a:r>
+          </a:p>
+          <a:p>
+            <a:r>
+              <a:rPr lang="en-US" dirty="0" smtClean="0"/>
+              <a:t>Sprint 2: </a:t>
+            </a:r>
+            <a:r>
+              <a:rPr lang="en-US" sz="2400" dirty="0" smtClean="0"/>
+              <a:t>October 10</a:t>
+            </a:r>
+            <a:r>
+              <a:rPr lang="en-US" sz="2400" baseline="30000" dirty="0" smtClean="0"/>
+              <a:t>th</a:t>
+            </a:r>
+            <a:r>
+              <a:rPr lang="en-US" sz="2400" dirty="0" smtClean="0"/>
+              <a:t> – October 31</a:t>
+            </a:r>
+            <a:r>
+              <a:rPr lang="en-US" sz="2400" baseline="30000" dirty="0" smtClean="0"/>
+              <a:t>st</a:t>
+            </a:r>
+            <a:r>
+              <a:rPr lang="en-US" sz="2400" dirty="0" smtClean="0"/>
+              <a:t> </a:t>
+            </a:r>
+          </a:p>
+          <a:p>
+            <a:pPr lvl="1"/>
+            <a:r>
+              <a:rPr lang="en-US" dirty="0" smtClean="0"/>
+              <a:t>Begin development</a:t>
+            </a:r>
+          </a:p>
+        </p:txBody>
+      </p:sp>
+      <p:sp>
+        <p:nvSpPr>
+          <p:cNvPr id="3" name="Title 2"/>
+          <p:cNvSpPr>
+            <a:spLocks noGrp="1"/>
+          </p:cNvSpPr>
+          <p:nvPr>
+            <p:ph type="title"/>
+          </p:nvPr>
+        </p:nvSpPr>
+        <p:spPr/>
+        <p:txBody>
           <a:bodyPr/>
           <a:lstStyle/>
           <a:p>
-            <a:endParaRPr lang="en-US"/>
-          </a:p>
-        </p:txBody>
-      </p:sp>
-      <p:sp>
-        <p:nvSpPr>
-          <p:cNvPr id="3" name="Title 2"/>
-          <p:cNvSpPr>
-            <a:spLocks noGrp="1"/>
-          </p:cNvSpPr>
-          <p:nvPr>
-            <p:ph type="title"/>
-          </p:nvPr>
-        </p:nvSpPr>
-        <p:spPr/>
-        <p:txBody>
-          <a:bodyPr/>
-          <a:lstStyle/>
-          <a:p>
-            <a:r>
-              <a:rPr lang="en-US" dirty="0" smtClean="0"/>
-              <a:t>Budget</a:t>
+            <a:r>
+              <a:rPr lang="en-US" dirty="0" smtClean="0"/>
+              <a:t>Sprints</a:t>
             </a:r>
             <a:endParaRPr lang="en-US" dirty="0"/>
           </a:p>
@@ -6122,7 +6349,7 @@
     </p:spTree>
     <p:extLst>
       <p:ext uri="{BB962C8B-B14F-4D97-AF65-F5344CB8AC3E}">
-        <p14:creationId xmlns:p14="http://schemas.microsoft.com/office/powerpoint/2010/main" val="3251292125"/>
+        <p14:creationId xmlns:p14="http://schemas.microsoft.com/office/powerpoint/2010/main" val="1446175581"/>
       </p:ext>
     </p:extLst>
   </p:cSld>
@@ -6168,31 +6395,181 @@
         </p:nvSpPr>
         <p:spPr/>
         <p:txBody>
+          <a:bodyPr>
+            <a:normAutofit fontScale="70000" lnSpcReduction="20000"/>
+          </a:bodyPr>
+          <a:lstStyle/>
+          <a:p>
+            <a:pPr lvl="0"/>
+            <a:r>
+              <a:rPr lang="en-US" dirty="0" err="1"/>
+              <a:t>CmdLink</a:t>
+            </a:r>
+            <a:r>
+              <a:rPr lang="en-US" dirty="0"/>
+              <a:t> Design and Integration</a:t>
+            </a:r>
+          </a:p>
+          <a:p>
+            <a:pPr lvl="0"/>
+            <a:r>
+              <a:rPr lang="en-US" dirty="0"/>
+              <a:t>Server Plugin Interface</a:t>
+            </a:r>
+          </a:p>
+          <a:p>
+            <a:pPr lvl="0"/>
+            <a:r>
+              <a:rPr lang="en-US" dirty="0"/>
+              <a:t>Research: Server operating systems</a:t>
+            </a:r>
+          </a:p>
+          <a:p>
+            <a:pPr lvl="0"/>
+            <a:r>
+              <a:rPr lang="en-US" dirty="0"/>
+              <a:t>Research: Security for the server</a:t>
+            </a:r>
+          </a:p>
+          <a:p>
+            <a:pPr lvl="0"/>
+            <a:r>
+              <a:rPr lang="en-US" dirty="0"/>
+              <a:t>Research: UDP </a:t>
+            </a:r>
+            <a:r>
+              <a:rPr lang="en-US" dirty="0" err="1"/>
+              <a:t>vs</a:t>
+            </a:r>
+            <a:r>
+              <a:rPr lang="en-US" dirty="0"/>
+              <a:t> TCP</a:t>
+            </a:r>
+          </a:p>
+          <a:p>
+            <a:pPr lvl="0"/>
+            <a:r>
+              <a:rPr lang="en-US" dirty="0"/>
+              <a:t>Research QML</a:t>
+            </a:r>
+          </a:p>
+          <a:p>
+            <a:pPr lvl="0"/>
+            <a:r>
+              <a:rPr lang="en-US" dirty="0"/>
+              <a:t>Server Tests</a:t>
+            </a:r>
+          </a:p>
+          <a:p>
+            <a:pPr lvl="0"/>
+            <a:r>
+              <a:rPr lang="en-US" dirty="0"/>
+              <a:t>Server Logic</a:t>
+            </a:r>
+          </a:p>
+          <a:p>
+            <a:pPr lvl="0"/>
+            <a:r>
+              <a:rPr lang="en-US" dirty="0"/>
+              <a:t>Server-Game </a:t>
+            </a:r>
+            <a:r>
+              <a:rPr lang="en-US" dirty="0"/>
+              <a:t>p</a:t>
+            </a:r>
+            <a:r>
+              <a:rPr lang="en-US" dirty="0" smtClean="0"/>
+              <a:t>lug in </a:t>
+            </a:r>
+            <a:r>
+              <a:rPr lang="en-US" dirty="0"/>
+              <a:t>Interface</a:t>
+            </a:r>
+          </a:p>
+          <a:p>
+            <a:pPr lvl="0"/>
+            <a:r>
+              <a:rPr lang="en-US" dirty="0"/>
+              <a:t>Server Communication</a:t>
+            </a:r>
+          </a:p>
+          <a:p>
+            <a:pPr lvl="0"/>
+            <a:r>
+              <a:rPr lang="en-US" dirty="0"/>
+              <a:t>Prove out and implement </a:t>
+            </a:r>
+            <a:r>
+              <a:rPr lang="en-US" dirty="0" err="1"/>
+              <a:t>QUiLoader</a:t>
+            </a:r>
+            <a:endParaRPr lang="en-US" dirty="0"/>
+          </a:p>
+          <a:p>
+            <a:pPr lvl="0"/>
+            <a:r>
+              <a:rPr lang="en-US" dirty="0" smtClean="0"/>
+              <a:t>Build </a:t>
+            </a:r>
+            <a:r>
+              <a:rPr lang="en-US" dirty="0"/>
+              <a:t>Template STB GUI </a:t>
+            </a:r>
+          </a:p>
+          <a:p>
+            <a:pPr lvl="0"/>
+            <a:r>
+              <a:rPr lang="en-US" dirty="0"/>
+              <a:t>Implement Virtual </a:t>
+            </a:r>
+            <a:r>
+              <a:rPr lang="en-US" dirty="0" smtClean="0"/>
+              <a:t>APMax</a:t>
+            </a:r>
+          </a:p>
+          <a:p>
+            <a:pPr lvl="0"/>
+            <a:r>
+              <a:rPr lang="en-US" dirty="0" smtClean="0"/>
+              <a:t>Design </a:t>
+            </a:r>
+            <a:r>
+              <a:rPr lang="en-US" dirty="0" err="1" smtClean="0"/>
+              <a:t>CmdLink</a:t>
+            </a:r>
+            <a:r>
+              <a:rPr lang="en-US" dirty="0" smtClean="0"/>
+              <a:t> message formats</a:t>
+            </a:r>
+          </a:p>
+          <a:p>
+            <a:pPr lvl="0"/>
+            <a:r>
+              <a:rPr lang="en-US" dirty="0" smtClean="0"/>
+              <a:t>Design Protocol Buffer message structure</a:t>
+            </a:r>
+            <a:endParaRPr lang="en-US" dirty="0"/>
+          </a:p>
+        </p:txBody>
+      </p:sp>
+      <p:sp>
+        <p:nvSpPr>
+          <p:cNvPr id="3" name="Title 2"/>
+          <p:cNvSpPr>
+            <a:spLocks noGrp="1"/>
+          </p:cNvSpPr>
+          <p:nvPr>
+            <p:ph type="title"/>
+          </p:nvPr>
+        </p:nvSpPr>
+        <p:spPr/>
+        <p:txBody>
           <a:bodyPr/>
           <a:lstStyle/>
           <a:p>
-            <a:endParaRPr lang="en-US"/>
-          </a:p>
-        </p:txBody>
-      </p:sp>
-      <p:sp>
-        <p:nvSpPr>
-          <p:cNvPr id="3" name="Title 2"/>
-          <p:cNvSpPr>
-            <a:spLocks noGrp="1"/>
-          </p:cNvSpPr>
-          <p:nvPr>
-            <p:ph type="title"/>
-          </p:nvPr>
-        </p:nvSpPr>
-        <p:spPr/>
-        <p:txBody>
-          <a:bodyPr/>
-          <a:lstStyle/>
-          <a:p>
-            <a:r>
-              <a:rPr lang="en-US" dirty="0" smtClean="0"/>
-              <a:t>Deliverables</a:t>
+            <a:r>
+              <a:rPr lang="en-US" dirty="0" smtClean="0"/>
+              <a:t>Backlog Outline</a:t>
             </a:r>
             <a:endParaRPr lang="en-US" dirty="0"/>
           </a:p>
@@ -6201,7 +6578,7 @@
     </p:spTree>
     <p:extLst>
       <p:ext uri="{BB962C8B-B14F-4D97-AF65-F5344CB8AC3E}">
-        <p14:creationId xmlns:p14="http://schemas.microsoft.com/office/powerpoint/2010/main" val="817451162"/>
+        <p14:creationId xmlns:p14="http://schemas.microsoft.com/office/powerpoint/2010/main" val="2409237239"/>
       </p:ext>
     </p:extLst>
   </p:cSld>
@@ -6319,30 +6696,14 @@
           <a:p>
             <a:r>
               <a:rPr lang="en-US" dirty="0" smtClean="0"/>
-              <a:t>Design a template game UI for STBs in an </a:t>
-            </a:r>
-            <a:r>
-              <a:rPr lang="en-US" dirty="0" err="1" smtClean="0"/>
-              <a:t>APMax</a:t>
-            </a:r>
-            <a:r>
-              <a:rPr lang="en-US" dirty="0" smtClean="0"/>
-              <a:t> environment</a:t>
+              <a:t>Design a template game UI for STBs in an APMax environment</a:t>
             </a:r>
             <a:endParaRPr lang="en-US" dirty="0"/>
           </a:p>
           <a:p>
             <a:r>
               <a:rPr lang="en-US" dirty="0" smtClean="0"/>
-              <a:t>Build a virtual </a:t>
-            </a:r>
-            <a:r>
-              <a:rPr lang="en-US" dirty="0" err="1" smtClean="0"/>
-              <a:t>APMax</a:t>
-            </a:r>
-            <a:r>
-              <a:rPr lang="en-US" dirty="0" smtClean="0"/>
-              <a:t> to simulate future communication protocols.</a:t>
+              <a:t>Build a virtual APMax to simulate future communication protocols.</a:t>
             </a:r>
           </a:p>
           <a:p>
@@ -6445,10 +6806,12 @@
             <a:pPr lvl="1"/>
             <a:r>
               <a:rPr lang="en-US" dirty="0" smtClean="0"/>
-              <a:t>Server and games environment will be private</a:t>
-            </a:r>
-          </a:p>
-          <a:p>
+              <a:t>Server and games environment will be </a:t>
+            </a:r>
+            <a:r>
+              <a:rPr lang="en-US" dirty="0" smtClean="0"/>
+              <a:t>privately hosted during development</a:t>
+            </a:r>
             <a:endParaRPr lang="en-US" dirty="0" smtClean="0"/>
           </a:p>
         </p:txBody>
@@ -6576,13 +6939,12 @@
           <a:p>
             <a:r>
               <a:rPr lang="en-US" dirty="0" smtClean="0"/>
-              <a:t>Full unit testing</a:t>
-            </a:r>
-          </a:p>
-          <a:p>
-            <a:endParaRPr lang="en-US" dirty="0" smtClean="0"/>
-          </a:p>
-          <a:p>
+              <a:t>Full unit </a:t>
+            </a:r>
+            <a:r>
+              <a:rPr lang="en-US" dirty="0" smtClean="0"/>
+              <a:t>testing</a:t>
+            </a:r>
             <a:endParaRPr lang="en-US" dirty="0" smtClean="0"/>
           </a:p>
         </p:txBody>
@@ -6664,7 +7026,11 @@
           <a:p>
             <a:r>
               <a:rPr lang="en-US" dirty="0" smtClean="0"/>
-              <a:t>Analysis – STB (client)</a:t>
+              <a:t>Design Analysis </a:t>
+            </a:r>
+            <a:r>
+              <a:rPr lang="en-US" dirty="0" smtClean="0"/>
+              <a:t>– STB (client)</a:t>
             </a:r>
             <a:endParaRPr lang="en-US" dirty="0"/>
           </a:p>
@@ -6772,6 +7138,22 @@
             </a:r>
           </a:p>
           <a:p>
+            <a:pPr lvl="2"/>
+            <a:r>
+              <a:rPr lang="en-US" dirty="0" smtClean="0"/>
+              <a:t>Command Link</a:t>
+            </a:r>
+            <a:endParaRPr lang="en-US" dirty="0" smtClean="0"/>
+          </a:p>
+          <a:p>
+            <a:pPr lvl="2"/>
+            <a:r>
+              <a:rPr lang="en-US" dirty="0" smtClean="0"/>
+              <a:t>Protocol Buffers</a:t>
+            </a:r>
+            <a:endParaRPr lang="en-US" dirty="0" smtClean="0"/>
+          </a:p>
+          <a:p>
             <a:pPr lvl="1"/>
             <a:r>
               <a:rPr lang="en-US" dirty="0" smtClean="0"/>
@@ -6796,7 +7178,11 @@
             <a:pPr lvl="2"/>
             <a:r>
               <a:rPr lang="en-US" dirty="0" smtClean="0"/>
-              <a:t>Card games UI</a:t>
+              <a:t>Card games </a:t>
+            </a:r>
+            <a:r>
+              <a:rPr lang="en-US" dirty="0" smtClean="0"/>
+              <a:t>UI</a:t>
             </a:r>
           </a:p>
         </p:txBody>
@@ -6836,15 +7222,13 @@
             <a:pPr lvl="1"/>
             <a:r>
               <a:rPr lang="en-US" dirty="0"/>
-              <a:t>Games use common communication wrapper</a:t>
-            </a:r>
-          </a:p>
-          <a:p>
-            <a:pPr lvl="2"/>
-            <a:r>
-              <a:rPr lang="en-US" dirty="0"/>
-              <a:t>Similar to implementation #1</a:t>
-            </a:r>
+              <a:t>Games use </a:t>
+            </a:r>
+            <a:r>
+              <a:rPr lang="en-US" dirty="0" smtClean="0"/>
+              <a:t>same communications as Implementation #1</a:t>
+            </a:r>
+            <a:endParaRPr lang="en-US" dirty="0"/>
           </a:p>
           <a:p>
             <a:endParaRPr lang="en-US" dirty="0"/>
@@ -6911,8 +7295,20 @@
           <a:p>
             <a:r>
               <a:rPr lang="en-US" dirty="0" smtClean="0"/>
-              <a:t>Windows server environment</a:t>
-            </a:r>
+              <a:t>Windows server </a:t>
+            </a:r>
+            <a:r>
+              <a:rPr lang="en-US" dirty="0" smtClean="0"/>
+              <a:t>environment</a:t>
+            </a:r>
+          </a:p>
+          <a:p>
+            <a:pPr lvl="1"/>
+            <a:r>
+              <a:rPr lang="en-US" dirty="0" smtClean="0"/>
+              <a:t>Portable to Azure</a:t>
+            </a:r>
+            <a:endParaRPr lang="en-US" dirty="0" smtClean="0"/>
           </a:p>
           <a:p>
             <a:r>
@@ -6941,7 +7337,19 @@
           <a:p>
             <a:r>
               <a:rPr lang="en-US" dirty="0" smtClean="0"/>
-              <a:t>Manages logic for each game played</a:t>
+              <a:t>Manages logic for </a:t>
+            </a:r>
+            <a:r>
+              <a:rPr lang="en-US" dirty="0" smtClean="0"/>
+              <a:t>each multiplayer </a:t>
+            </a:r>
+            <a:r>
+              <a:rPr lang="en-US" dirty="0" smtClean="0"/>
+              <a:t>game </a:t>
+            </a:r>
+            <a:r>
+              <a:rPr lang="en-US" dirty="0" smtClean="0"/>
+              <a:t>instance</a:t>
             </a:r>
             <a:endParaRPr lang="en-US" dirty="0"/>
           </a:p>
@@ -6964,7 +7372,11 @@
           <a:p>
             <a:r>
               <a:rPr lang="en-US" dirty="0" smtClean="0"/>
-              <a:t>Analysis - Server</a:t>
+              <a:t>Design Analysis </a:t>
+            </a:r>
+            <a:r>
+              <a:rPr lang="en-US" dirty="0" smtClean="0"/>
+              <a:t>- Server</a:t>
             </a:r>
             <a:endParaRPr lang="en-US" dirty="0"/>
           </a:p>
@@ -7039,7 +7451,7 @@
           <p:nvPr/>
         </p:nvPicPr>
         <p:blipFill>
-          <a:blip r:embed="rId2">
+          <a:blip r:embed="rId3">
             <a:extLst>
               <a:ext uri="{28A0092B-C50C-407E-A947-70E740481C1C}">
                 <a14:useLocalDpi xmlns:a14="http://schemas.microsoft.com/office/drawing/2010/main" val="0"/>
@@ -7111,7 +7523,9 @@
           </a:xfrm>
         </p:spPr>
         <p:txBody>
-          <a:bodyPr/>
+          <a:bodyPr>
+            <a:normAutofit lnSpcReduction="10000"/>
+          </a:bodyPr>
           <a:lstStyle/>
           <a:p>
             <a:r>
@@ -7133,47 +7547,335 @@
               <a:t>Connects  </a:t>
             </a:r>
             <a:r>
-              <a:rPr lang="en-US" dirty="0" err="1" smtClean="0"/>
-              <a:t>APMaxes</a:t>
+              <a:rPr lang="en-US" dirty="0" smtClean="0"/>
+              <a:t>APMax units</a:t>
+            </a:r>
+          </a:p>
+          <a:p>
+            <a:r>
+              <a:rPr lang="en-US" dirty="0" smtClean="0"/>
+              <a:t>A.I. servers</a:t>
+            </a:r>
+          </a:p>
+          <a:p>
+            <a:pPr lvl="1"/>
+            <a:r>
+              <a:rPr lang="en-US" dirty="0" smtClean="0"/>
+              <a:t>Optional – If one server</a:t>
+            </a:r>
+            <a:br>
+              <a:rPr lang="en-US" dirty="0" smtClean="0"/>
+            </a:br>
+            <a:r>
+              <a:rPr lang="en-US" dirty="0" smtClean="0"/>
+              <a:t>can’t handle all game A.I.</a:t>
             </a:r>
             <a:endParaRPr lang="en-US" dirty="0" smtClean="0"/>
           </a:p>
           <a:p>
             <a:r>
-              <a:rPr lang="en-US" dirty="0" err="1" smtClean="0"/>
+              <a:rPr lang="en-US" dirty="0" smtClean="0"/>
               <a:t>APMax</a:t>
             </a:r>
+          </a:p>
+          <a:p>
+            <a:pPr lvl="1"/>
+            <a:r>
+              <a:rPr lang="en-US" dirty="0" smtClean="0"/>
+              <a:t>Middleware</a:t>
+            </a:r>
+          </a:p>
+          <a:p>
+            <a:pPr lvl="1"/>
+            <a:r>
+              <a:rPr lang="en-US" dirty="0" smtClean="0"/>
+              <a:t>Connects the server</a:t>
+            </a:r>
+            <a:br>
+              <a:rPr lang="en-US" dirty="0" smtClean="0"/>
+            </a:br>
+            <a:r>
+              <a:rPr lang="en-US" dirty="0" smtClean="0"/>
+              <a:t>to each STB</a:t>
+            </a:r>
             <a:endParaRPr lang="en-US" dirty="0" smtClean="0"/>
           </a:p>
           <a:p>
+            <a:r>
+              <a:rPr lang="en-US" dirty="0" smtClean="0"/>
+              <a:t>Client</a:t>
+            </a:r>
+            <a:endParaRPr lang="en-US" dirty="0" smtClean="0"/>
+          </a:p>
+          <a:p>
             <a:pPr lvl="1"/>
             <a:r>
               <a:rPr lang="en-US" dirty="0" smtClean="0"/>
-              <a:t>Middleware</a:t>
-            </a:r>
-          </a:p>
-          <a:p>
-            <a:pPr lvl="1"/>
-            <a:r>
-              <a:rPr lang="en-US" dirty="0" smtClean="0"/>
-              <a:t>Facilitates communication</a:t>
-            </a:r>
-          </a:p>
-          <a:p>
-            <a:r>
-              <a:rPr lang="en-US" dirty="0" smtClean="0"/>
-              <a:t>Client</a:t>
-            </a:r>
-          </a:p>
-          <a:p>
-            <a:pPr lvl="1"/>
-            <a:r>
-              <a:rPr lang="en-US" dirty="0" smtClean="0"/>
-              <a:t>Set Top Box</a:t>
-            </a:r>
-          </a:p>
-        </p:txBody>
-      </p:sp>
+              <a:t>Set Top </a:t>
+            </a:r>
+            <a:r>
+              <a:rPr lang="en-US" dirty="0" smtClean="0"/>
+              <a:t>Bo</a:t>
+            </a:r>
+            <a:r>
+              <a:rPr lang="en-US" dirty="0" smtClean="0"/>
+              <a:t>x</a:t>
+            </a:r>
+          </a:p>
+        </p:txBody>
+      </p:sp>
+      <p:cxnSp>
+        <p:nvCxnSpPr>
+          <p:cNvPr id="6" name="Straight Connector 5"/>
+          <p:cNvCxnSpPr/>
+          <p:nvPr/>
+        </p:nvCxnSpPr>
+        <p:spPr>
+          <a:xfrm>
+            <a:off x="3352800" y="1676400"/>
+            <a:ext cx="2438400" cy="0"/>
+          </a:xfrm>
+          <a:prstGeom prst="line">
+            <a:avLst/>
+          </a:prstGeom>
+        </p:spPr>
+        <p:style>
+          <a:lnRef idx="1">
+            <a:schemeClr val="accent1"/>
+          </a:lnRef>
+          <a:fillRef idx="0">
+            <a:schemeClr val="accent1"/>
+          </a:fillRef>
+          <a:effectRef idx="0">
+            <a:schemeClr val="accent1"/>
+          </a:effectRef>
+          <a:fontRef idx="minor">
+            <a:schemeClr val="tx1"/>
+          </a:fontRef>
+        </p:style>
+      </p:cxnSp>
+      <p:cxnSp>
+        <p:nvCxnSpPr>
+          <p:cNvPr id="9" name="Straight Connector 8"/>
+          <p:cNvCxnSpPr/>
+          <p:nvPr/>
+        </p:nvCxnSpPr>
+        <p:spPr>
+          <a:xfrm>
+            <a:off x="5799364" y="1676400"/>
+            <a:ext cx="0" cy="1600200"/>
+          </a:xfrm>
+          <a:prstGeom prst="line">
+            <a:avLst/>
+          </a:prstGeom>
+        </p:spPr>
+        <p:style>
+          <a:lnRef idx="1">
+            <a:schemeClr val="accent1"/>
+          </a:lnRef>
+          <a:fillRef idx="0">
+            <a:schemeClr val="accent1"/>
+          </a:fillRef>
+          <a:effectRef idx="0">
+            <a:schemeClr val="accent1"/>
+          </a:effectRef>
+          <a:fontRef idx="minor">
+            <a:schemeClr val="tx1"/>
+          </a:fontRef>
+        </p:style>
+      </p:cxnSp>
+      <p:cxnSp>
+        <p:nvCxnSpPr>
+          <p:cNvPr id="11" name="Straight Arrow Connector 10"/>
+          <p:cNvCxnSpPr/>
+          <p:nvPr/>
+        </p:nvCxnSpPr>
+        <p:spPr>
+          <a:xfrm>
+            <a:off x="5791200" y="3276600"/>
+            <a:ext cx="372836" cy="0"/>
+          </a:xfrm>
+          <a:prstGeom prst="straightConnector1">
+            <a:avLst/>
+          </a:prstGeom>
+          <a:ln>
+            <a:tailEnd type="arrow"/>
+          </a:ln>
+        </p:spPr>
+        <p:style>
+          <a:lnRef idx="1">
+            <a:schemeClr val="accent1"/>
+          </a:lnRef>
+          <a:fillRef idx="0">
+            <a:schemeClr val="accent1"/>
+          </a:fillRef>
+          <a:effectRef idx="0">
+            <a:schemeClr val="accent1"/>
+          </a:effectRef>
+          <a:fontRef idx="minor">
+            <a:schemeClr val="tx1"/>
+          </a:fontRef>
+        </p:style>
+      </p:cxnSp>
+      <p:cxnSp>
+        <p:nvCxnSpPr>
+          <p:cNvPr id="18" name="Straight Arrow Connector 17"/>
+          <p:cNvCxnSpPr/>
+          <p:nvPr/>
+        </p:nvCxnSpPr>
+        <p:spPr>
+          <a:xfrm>
+            <a:off x="2819400" y="2819400"/>
+            <a:ext cx="2438400" cy="0"/>
+          </a:xfrm>
+          <a:prstGeom prst="straightConnector1">
+            <a:avLst/>
+          </a:prstGeom>
+          <a:ln>
+            <a:tailEnd type="arrow"/>
+          </a:ln>
+        </p:spPr>
+        <p:style>
+          <a:lnRef idx="1">
+            <a:schemeClr val="accent1"/>
+          </a:lnRef>
+          <a:fillRef idx="0">
+            <a:schemeClr val="accent1"/>
+          </a:fillRef>
+          <a:effectRef idx="0">
+            <a:schemeClr val="accent1"/>
+          </a:effectRef>
+          <a:fontRef idx="minor">
+            <a:schemeClr val="tx1"/>
+          </a:fontRef>
+        </p:style>
+      </p:cxnSp>
+      <p:cxnSp>
+        <p:nvCxnSpPr>
+          <p:cNvPr id="20" name="Straight Connector 19"/>
+          <p:cNvCxnSpPr/>
+          <p:nvPr/>
+        </p:nvCxnSpPr>
+        <p:spPr>
+          <a:xfrm>
+            <a:off x="2057400" y="3886200"/>
+            <a:ext cx="2819400" cy="0"/>
+          </a:xfrm>
+          <a:prstGeom prst="line">
+            <a:avLst/>
+          </a:prstGeom>
+        </p:spPr>
+        <p:style>
+          <a:lnRef idx="1">
+            <a:schemeClr val="accent1"/>
+          </a:lnRef>
+          <a:fillRef idx="0">
+            <a:schemeClr val="accent1"/>
+          </a:fillRef>
+          <a:effectRef idx="0">
+            <a:schemeClr val="accent1"/>
+          </a:effectRef>
+          <a:fontRef idx="minor">
+            <a:schemeClr val="tx1"/>
+          </a:fontRef>
+        </p:style>
+      </p:cxnSp>
+      <p:cxnSp>
+        <p:nvCxnSpPr>
+          <p:cNvPr id="22" name="Straight Arrow Connector 21"/>
+          <p:cNvCxnSpPr/>
+          <p:nvPr/>
+        </p:nvCxnSpPr>
+        <p:spPr>
+          <a:xfrm>
+            <a:off x="4876800" y="3886200"/>
+            <a:ext cx="0" cy="685800"/>
+          </a:xfrm>
+          <a:prstGeom prst="straightConnector1">
+            <a:avLst/>
+          </a:prstGeom>
+          <a:ln>
+            <a:tailEnd type="arrow"/>
+          </a:ln>
+        </p:spPr>
+        <p:style>
+          <a:lnRef idx="1">
+            <a:schemeClr val="accent1"/>
+          </a:lnRef>
+          <a:fillRef idx="0">
+            <a:schemeClr val="accent1"/>
+          </a:fillRef>
+          <a:effectRef idx="0">
+            <a:schemeClr val="accent1"/>
+          </a:effectRef>
+          <a:fontRef idx="minor">
+            <a:schemeClr val="tx1"/>
+          </a:fontRef>
+        </p:style>
+      </p:cxnSp>
+      <p:cxnSp>
+        <p:nvCxnSpPr>
+          <p:cNvPr id="24" name="Straight Connector 23"/>
+          <p:cNvCxnSpPr/>
+          <p:nvPr/>
+        </p:nvCxnSpPr>
+        <p:spPr>
+          <a:xfrm>
+            <a:off x="1905000" y="5334000"/>
+            <a:ext cx="2286000" cy="0"/>
+          </a:xfrm>
+          <a:prstGeom prst="line">
+            <a:avLst/>
+          </a:prstGeom>
+        </p:spPr>
+        <p:style>
+          <a:lnRef idx="1">
+            <a:schemeClr val="accent1"/>
+          </a:lnRef>
+          <a:fillRef idx="0">
+            <a:schemeClr val="accent1"/>
+          </a:fillRef>
+          <a:effectRef idx="0">
+            <a:schemeClr val="accent1"/>
+          </a:effectRef>
+          <a:fontRef idx="minor">
+            <a:schemeClr val="tx1"/>
+          </a:fontRef>
+        </p:style>
+      </p:cxnSp>
+      <p:cxnSp>
+        <p:nvCxnSpPr>
+          <p:cNvPr id="26" name="Straight Arrow Connector 25"/>
+          <p:cNvCxnSpPr/>
+          <p:nvPr/>
+        </p:nvCxnSpPr>
+        <p:spPr>
+          <a:xfrm>
+            <a:off x="4191000" y="5334000"/>
+            <a:ext cx="0" cy="533400"/>
+          </a:xfrm>
+          <a:prstGeom prst="straightConnector1">
+            <a:avLst/>
+          </a:prstGeom>
+          <a:ln>
+            <a:tailEnd type="arrow"/>
+          </a:ln>
+        </p:spPr>
+        <p:style>
+          <a:lnRef idx="1">
+            <a:schemeClr val="accent1"/>
+          </a:lnRef>
+          <a:fillRef idx="0">
+            <a:schemeClr val="accent1"/>
+          </a:fillRef>
+          <a:effectRef idx="0">
+            <a:schemeClr val="accent1"/>
+          </a:effectRef>
+          <a:fontRef idx="minor">
+            <a:schemeClr val="tx1"/>
+          </a:fontRef>
+        </p:style>
+      </p:cxnSp>
     </p:spTree>
     <p:extLst>
       <p:ext uri="{BB962C8B-B14F-4D97-AF65-F5344CB8AC3E}">
@@ -7351,7 +8053,81 @@
           <a:bodyPr/>
           <a:lstStyle/>
           <a:p>
-            <a:endParaRPr lang="en-US"/>
+            <a:r>
+              <a:rPr lang="en-US" dirty="0" smtClean="0"/>
+              <a:t>STB firmware updates during development</a:t>
+            </a:r>
+          </a:p>
+          <a:p>
+            <a:pPr lvl="1"/>
+            <a:r>
+              <a:rPr lang="en-US" dirty="0" smtClean="0"/>
+              <a:t>Previous project</a:t>
+            </a:r>
+          </a:p>
+          <a:p>
+            <a:pPr lvl="1"/>
+            <a:r>
+              <a:rPr lang="en-US" dirty="0" smtClean="0"/>
+              <a:t>Should only affect UI engine on STB</a:t>
+            </a:r>
+          </a:p>
+          <a:p>
+            <a:pPr lvl="1"/>
+            <a:r>
+              <a:rPr lang="en-US" dirty="0" smtClean="0"/>
+              <a:t>Contingency Plan</a:t>
+            </a:r>
+          </a:p>
+          <a:p>
+            <a:pPr lvl="2"/>
+            <a:r>
+              <a:rPr lang="en-US" dirty="0" smtClean="0"/>
+              <a:t>Update the engine as soon as possible</a:t>
+            </a:r>
+            <a:endParaRPr lang="en-US" dirty="0" smtClean="0"/>
+          </a:p>
+          <a:p>
+            <a:r>
+              <a:rPr lang="en-US" dirty="0" smtClean="0"/>
+              <a:t>Changing the game development process</a:t>
+            </a:r>
+          </a:p>
+          <a:p>
+            <a:pPr lvl="1"/>
+            <a:r>
+              <a:rPr lang="en-US" dirty="0" smtClean="0"/>
+              <a:t>Could increase game development time</a:t>
+            </a:r>
+          </a:p>
+          <a:p>
+            <a:pPr lvl="1"/>
+            <a:r>
+              <a:rPr lang="en-US" dirty="0" smtClean="0"/>
+              <a:t>Might make debugging even more difficult</a:t>
+            </a:r>
+          </a:p>
+          <a:p>
+            <a:pPr lvl="1"/>
+            <a:r>
+              <a:rPr lang="en-US" dirty="0" smtClean="0"/>
+              <a:t>Contingency Plan</a:t>
+            </a:r>
+          </a:p>
+          <a:p>
+            <a:pPr lvl="2"/>
+            <a:r>
+              <a:rPr lang="en-US" dirty="0" smtClean="0"/>
+              <a:t>Build an error logger into the client engine</a:t>
+            </a:r>
+          </a:p>
+          <a:p>
+            <a:pPr lvl="2"/>
+            <a:r>
+              <a:rPr lang="en-US" dirty="0" smtClean="0"/>
+              <a:t>Send crash reports to the server</a:t>
+            </a:r>
+            <a:endParaRPr lang="en-US" dirty="0"/>
           </a:p>
         </p:txBody>
       </p:sp>

</xml_diff>

<commit_message>
changed wording for clarity
</commit_message>
<xml_diff>
--- a/Sprint1_Documents/Sprint 1 Review.pptx
+++ b/Sprint1_Documents/Sprint 1 Review.pptx
@@ -1508,43 +1508,7 @@
                 <a:ea typeface="+mn-ea"/>
                 <a:cs typeface="+mn-cs"/>
               </a:rPr>
-              <a:t>Risks, risk analysis, mitigation and </a:t>
-            </a:r>
-            <a:r>
-              <a:rPr lang="en-US" sz="1200" b="0" i="0" kern="1200" dirty="0" smtClean="0">
-                <a:solidFill>
-                  <a:schemeClr val="tx1"/>
-                </a:solidFill>
-                <a:effectLst/>
-                <a:latin typeface="+mn-lt"/>
-                <a:ea typeface="+mn-ea"/>
-                <a:cs typeface="+mn-cs"/>
-              </a:rPr>
-              <a:t>contingency </a:t>
-            </a:r>
-            <a:r>
-              <a:rPr lang="en-US" sz="1200" b="0" i="0" kern="1200" dirty="0" smtClean="0">
-                <a:solidFill>
-                  <a:schemeClr val="tx1"/>
-                </a:solidFill>
-                <a:effectLst/>
-                <a:latin typeface="+mn-lt"/>
-                <a:ea typeface="+mn-ea"/>
-                <a:cs typeface="+mn-cs"/>
-              </a:rPr>
-              <a:t>plan  (2 min</a:t>
-            </a:r>
-            <a:r>
-              <a:rPr lang="en-US" sz="1200" b="0" i="0" kern="1200" dirty="0" smtClean="0">
-                <a:solidFill>
-                  <a:schemeClr val="tx1"/>
-                </a:solidFill>
-                <a:effectLst/>
-                <a:latin typeface="+mn-lt"/>
-                <a:ea typeface="+mn-ea"/>
-                <a:cs typeface="+mn-cs"/>
-              </a:rPr>
-              <a:t>)</a:t>
+              <a:t>Risks, risk analysis, mitigation and contingency plan  (2 min)</a:t>
             </a:r>
           </a:p>
           <a:p>
@@ -6250,8 +6214,9 @@
             <a:pPr lvl="1"/>
             <a:r>
               <a:rPr lang="en-US" dirty="0" smtClean="0"/>
-              <a:t>Testing Environment</a:t>
-            </a:r>
+              <a:t>Environment: Setup and Testing</a:t>
+            </a:r>
+            <a:endParaRPr lang="en-US" dirty="0" smtClean="0"/>
           </a:p>
           <a:p>
             <a:pPr lvl="2"/>
@@ -6471,11 +6436,7 @@
             <a:pPr lvl="0"/>
             <a:r>
               <a:rPr lang="en-US" dirty="0"/>
-              <a:t>Server-Game </a:t>
-            </a:r>
-            <a:r>
-              <a:rPr lang="en-US" dirty="0"/>
-              <a:t>p</a:t>
+              <a:t>Server-Game p</a:t>
             </a:r>
             <a:r>
               <a:rPr lang="en-US" dirty="0" smtClean="0"/>
@@ -6806,13 +6767,8 @@
             <a:pPr lvl="1"/>
             <a:r>
               <a:rPr lang="en-US" dirty="0" smtClean="0"/>
-              <a:t>Server and games environment will be </a:t>
-            </a:r>
-            <a:r>
-              <a:rPr lang="en-US" dirty="0" smtClean="0"/>
-              <a:t>privately hosted during development</a:t>
-            </a:r>
-            <a:endParaRPr lang="en-US" dirty="0" smtClean="0"/>
+              <a:t>Server and games environment will be privately hosted during development</a:t>
+            </a:r>
           </a:p>
         </p:txBody>
       </p:sp>
@@ -6939,13 +6895,8 @@
           <a:p>
             <a:r>
               <a:rPr lang="en-US" dirty="0" smtClean="0"/>
-              <a:t>Full unit </a:t>
-            </a:r>
-            <a:r>
-              <a:rPr lang="en-US" dirty="0" smtClean="0"/>
-              <a:t>testing</a:t>
-            </a:r>
-            <a:endParaRPr lang="en-US" dirty="0" smtClean="0"/>
+              <a:t>Full unit testing</a:t>
+            </a:r>
           </a:p>
         </p:txBody>
       </p:sp>
@@ -7026,11 +6977,7 @@
           <a:p>
             <a:r>
               <a:rPr lang="en-US" dirty="0" smtClean="0"/>
-              <a:t>Design Analysis </a:t>
-            </a:r>
-            <a:r>
-              <a:rPr lang="en-US" dirty="0" smtClean="0"/>
-              <a:t>– STB (client)</a:t>
+              <a:t>Design Analysis – STB (client)</a:t>
             </a:r>
             <a:endParaRPr lang="en-US" dirty="0"/>
           </a:p>
@@ -7143,7 +7090,6 @@
               <a:rPr lang="en-US" dirty="0" smtClean="0"/>
               <a:t>Command Link</a:t>
             </a:r>
-            <a:endParaRPr lang="en-US" dirty="0" smtClean="0"/>
           </a:p>
           <a:p>
             <a:pPr lvl="2"/>
@@ -7151,7 +7097,6 @@
               <a:rPr lang="en-US" dirty="0" smtClean="0"/>
               <a:t>Protocol Buffers</a:t>
             </a:r>
-            <a:endParaRPr lang="en-US" dirty="0" smtClean="0"/>
           </a:p>
           <a:p>
             <a:pPr lvl="1"/>
@@ -7178,11 +7123,7 @@
             <a:pPr lvl="2"/>
             <a:r>
               <a:rPr lang="en-US" dirty="0" smtClean="0"/>
-              <a:t>Card games </a:t>
-            </a:r>
-            <a:r>
-              <a:rPr lang="en-US" dirty="0" smtClean="0"/>
-              <a:t>UI</a:t>
+              <a:t>Card games UI</a:t>
             </a:r>
           </a:p>
         </p:txBody>
@@ -7295,11 +7236,7 @@
           <a:p>
             <a:r>
               <a:rPr lang="en-US" dirty="0" smtClean="0"/>
-              <a:t>Windows server </a:t>
-            </a:r>
-            <a:r>
-              <a:rPr lang="en-US" dirty="0" smtClean="0"/>
-              <a:t>environment</a:t>
+              <a:t>Windows server environment</a:t>
             </a:r>
           </a:p>
           <a:p>
@@ -7308,7 +7245,6 @@
               <a:rPr lang="en-US" dirty="0" smtClean="0"/>
               <a:t>Portable to Azure</a:t>
             </a:r>
-            <a:endParaRPr lang="en-US" dirty="0" smtClean="0"/>
           </a:p>
           <a:p>
             <a:r>
@@ -7337,19 +7273,7 @@
           <a:p>
             <a:r>
               <a:rPr lang="en-US" dirty="0" smtClean="0"/>
-              <a:t>Manages logic for </a:t>
-            </a:r>
-            <a:r>
-              <a:rPr lang="en-US" dirty="0" smtClean="0"/>
-              <a:t>each multiplayer </a:t>
-            </a:r>
-            <a:r>
-              <a:rPr lang="en-US" dirty="0" smtClean="0"/>
-              <a:t>game </a:t>
-            </a:r>
-            <a:r>
-              <a:rPr lang="en-US" dirty="0" smtClean="0"/>
-              <a:t>instance</a:t>
+              <a:t>Manages logic for each multiplayer game instance</a:t>
             </a:r>
             <a:endParaRPr lang="en-US" dirty="0"/>
           </a:p>
@@ -7372,11 +7296,7 @@
           <a:p>
             <a:r>
               <a:rPr lang="en-US" dirty="0" smtClean="0"/>
-              <a:t>Design Analysis </a:t>
-            </a:r>
-            <a:r>
-              <a:rPr lang="en-US" dirty="0" smtClean="0"/>
-              <a:t>- Server</a:t>
+              <a:t>Design Analysis - Server</a:t>
             </a:r>
             <a:endParaRPr lang="en-US" dirty="0"/>
           </a:p>
@@ -7544,11 +7464,7 @@
             <a:pPr lvl="1"/>
             <a:r>
               <a:rPr lang="en-US" dirty="0" smtClean="0"/>
-              <a:t>Connects  </a:t>
-            </a:r>
-            <a:r>
-              <a:rPr lang="en-US" dirty="0" smtClean="0"/>
-              <a:t>APMax units</a:t>
+              <a:t>Connects  APMax units</a:t>
             </a:r>
           </a:p>
           <a:p>
@@ -7570,7 +7486,6 @@
               <a:rPr lang="en-US" dirty="0" smtClean="0"/>
               <a:t>can’t handle all game A.I.</a:t>
             </a:r>
-            <a:endParaRPr lang="en-US" dirty="0" smtClean="0"/>
           </a:p>
           <a:p>
             <a:r>
@@ -7598,28 +7513,18 @@
               <a:rPr lang="en-US" dirty="0" smtClean="0"/>
               <a:t>to each STB</a:t>
             </a:r>
-            <a:endParaRPr lang="en-US" dirty="0" smtClean="0"/>
           </a:p>
           <a:p>
             <a:r>
               <a:rPr lang="en-US" dirty="0" smtClean="0"/>
               <a:t>Client</a:t>
             </a:r>
-            <a:endParaRPr lang="en-US" dirty="0" smtClean="0"/>
           </a:p>
           <a:p>
             <a:pPr lvl="1"/>
             <a:r>
               <a:rPr lang="en-US" dirty="0" smtClean="0"/>
-              <a:t>Set Top </a:t>
-            </a:r>
-            <a:r>
-              <a:rPr lang="en-US" dirty="0" smtClean="0"/>
-              <a:t>Bo</a:t>
-            </a:r>
-            <a:r>
-              <a:rPr lang="en-US" dirty="0" smtClean="0"/>
-              <a:t>x</a:t>
+              <a:t>Set Top Box</a:t>
             </a:r>
           </a:p>
         </p:txBody>
@@ -8085,7 +7990,6 @@
               <a:rPr lang="en-US" dirty="0" smtClean="0"/>
               <a:t>Update the engine as soon as possible</a:t>
             </a:r>
-            <a:endParaRPr lang="en-US" dirty="0" smtClean="0"/>
           </a:p>
           <a:p>
             <a:r>

</xml_diff>

<commit_message>
Added a decision matrix. Updated sprint 1 slides.
Also added data flow for the Set Top Box visio diagram.
</commit_message>
<xml_diff>
--- a/Sprint1_Documents/Sprint 1 Review.pptx
+++ b/Sprint1_Documents/Sprint 1 Review.pptx
@@ -5,7 +5,7 @@
     <p:sldMasterId id="2147483672" r:id="rId1"/>
   </p:sldMasterIdLst>
   <p:notesMasterIdLst>
-    <p:notesMasterId r:id="rId14"/>
+    <p:notesMasterId r:id="rId16"/>
   </p:notesMasterIdLst>
   <p:sldIdLst>
     <p:sldId id="256" r:id="rId2"/>
@@ -13,13 +13,15 @@
     <p:sldId id="261" r:id="rId4"/>
     <p:sldId id="258" r:id="rId5"/>
     <p:sldId id="259" r:id="rId6"/>
-    <p:sldId id="260" r:id="rId7"/>
-    <p:sldId id="262" r:id="rId8"/>
-    <p:sldId id="263" r:id="rId9"/>
-    <p:sldId id="264" r:id="rId10"/>
-    <p:sldId id="268" r:id="rId11"/>
-    <p:sldId id="269" r:id="rId12"/>
-    <p:sldId id="267" r:id="rId13"/>
+    <p:sldId id="270" r:id="rId7"/>
+    <p:sldId id="260" r:id="rId8"/>
+    <p:sldId id="271" r:id="rId9"/>
+    <p:sldId id="262" r:id="rId10"/>
+    <p:sldId id="263" r:id="rId11"/>
+    <p:sldId id="264" r:id="rId12"/>
+    <p:sldId id="268" r:id="rId13"/>
+    <p:sldId id="269" r:id="rId14"/>
+    <p:sldId id="267" r:id="rId15"/>
   </p:sldIdLst>
   <p:sldSz cx="9144000" cy="6858000" type="screen4x3"/>
   <p:notesSz cx="6858000" cy="9144000"/>
@@ -616,18 +618,24 @@
           <a:lstStyle/>
           <a:p>
             <a:r>
-              <a:rPr lang="en-US" dirty="0" smtClean="0"/>
-              <a:t>Quickly</a:t>
-            </a:r>
-            <a:r>
-              <a:rPr lang="en-US" baseline="0" dirty="0" smtClean="0"/>
-              <a:t> show that we have a backlog, no need to go into </a:t>
-            </a:r>
-            <a:r>
-              <a:rPr lang="en-US" baseline="0" smtClean="0"/>
-              <a:t>great detail here</a:t>
-            </a:r>
-            <a:endParaRPr lang="en-US"/>
+              <a:rPr lang="en-US" sz="1200" b="0" i="0" kern="1200" dirty="0" smtClean="0">
+                <a:solidFill>
+                  <a:schemeClr val="tx1"/>
+                </a:solidFill>
+                <a:effectLst/>
+                <a:latin typeface="+mn-lt"/>
+                <a:ea typeface="+mn-ea"/>
+                <a:cs typeface="+mn-cs"/>
+              </a:rPr>
+              <a:t>Risks, risk analysis, mitigation and contingency plan  (2 min)</a:t>
+            </a:r>
+          </a:p>
+          <a:p>
+            <a:r>
+              <a:rPr lang="en-US" dirty="0" smtClean="0"/>
+              <a:t>David</a:t>
+            </a:r>
+            <a:endParaRPr lang="en-US" dirty="0"/>
           </a:p>
         </p:txBody>
       </p:sp>
@@ -657,7 +665,7 @@
     </p:spTree>
     <p:extLst>
       <p:ext uri="{BB962C8B-B14F-4D97-AF65-F5344CB8AC3E}">
-        <p14:creationId xmlns:p14="http://schemas.microsoft.com/office/powerpoint/2010/main" val="542630260"/>
+        <p14:creationId xmlns:p14="http://schemas.microsoft.com/office/powerpoint/2010/main" val="1966491216"/>
       </p:ext>
     </p:extLst>
   </p:cSld>
@@ -711,6 +719,182 @@
           <a:bodyPr/>
           <a:lstStyle/>
           <a:p>
+            <a:endParaRPr lang="en-US" dirty="0"/>
+          </a:p>
+        </p:txBody>
+      </p:sp>
+      <p:sp>
+        <p:nvSpPr>
+          <p:cNvPr id="4" name="Slide Number Placeholder 3"/>
+          <p:cNvSpPr>
+            <a:spLocks noGrp="1"/>
+          </p:cNvSpPr>
+          <p:nvPr>
+            <p:ph type="sldNum" sz="quarter" idx="10"/>
+          </p:nvPr>
+        </p:nvSpPr>
+        <p:spPr/>
+        <p:txBody>
+          <a:bodyPr/>
+          <a:lstStyle/>
+          <a:p>
+            <a:fld id="{2196A064-7C2B-4BD1-B717-284E7E6AAF69}" type="slidenum">
+              <a:rPr lang="en-US" smtClean="0"/>
+              <a:t>12</a:t>
+            </a:fld>
+            <a:endParaRPr lang="en-US"/>
+          </a:p>
+        </p:txBody>
+      </p:sp>
+    </p:spTree>
+    <p:extLst>
+      <p:ext uri="{BB962C8B-B14F-4D97-AF65-F5344CB8AC3E}">
+        <p14:creationId xmlns:p14="http://schemas.microsoft.com/office/powerpoint/2010/main" val="3059345779"/>
+      </p:ext>
+    </p:extLst>
+  </p:cSld>
+  <p:clrMapOvr>
+    <a:masterClrMapping/>
+  </p:clrMapOvr>
+</p:notes>
+</file>
+
+<file path=ppt/notesSlides/notesSlide12.xml><?xml version="1.0" encoding="utf-8"?>
+<p:notes xmlns:a="http://schemas.openxmlformats.org/drawingml/2006/main" xmlns:r="http://schemas.openxmlformats.org/officeDocument/2006/relationships" xmlns:p="http://schemas.openxmlformats.org/presentationml/2006/main">
+  <p:cSld>
+    <p:spTree>
+      <p:nvGrpSpPr>
+        <p:cNvPr id="1" name=""/>
+        <p:cNvGrpSpPr/>
+        <p:nvPr/>
+      </p:nvGrpSpPr>
+      <p:grpSpPr>
+        <a:xfrm>
+          <a:off x="0" y="0"/>
+          <a:ext cx="0" cy="0"/>
+          <a:chOff x="0" y="0"/>
+          <a:chExt cx="0" cy="0"/>
+        </a:xfrm>
+      </p:grpSpPr>
+      <p:sp>
+        <p:nvSpPr>
+          <p:cNvPr id="2" name="Slide Image Placeholder 1"/>
+          <p:cNvSpPr>
+            <a:spLocks noGrp="1" noRot="1" noChangeAspect="1"/>
+          </p:cNvSpPr>
+          <p:nvPr>
+            <p:ph type="sldImg"/>
+          </p:nvPr>
+        </p:nvSpPr>
+        <p:spPr/>
+      </p:sp>
+      <p:sp>
+        <p:nvSpPr>
+          <p:cNvPr id="3" name="Notes Placeholder 2"/>
+          <p:cNvSpPr>
+            <a:spLocks noGrp="1"/>
+          </p:cNvSpPr>
+          <p:nvPr>
+            <p:ph type="body" idx="1"/>
+          </p:nvPr>
+        </p:nvSpPr>
+        <p:spPr/>
+        <p:txBody>
+          <a:bodyPr/>
+          <a:lstStyle/>
+          <a:p>
+            <a:r>
+              <a:rPr lang="en-US" dirty="0" smtClean="0"/>
+              <a:t>Quickly</a:t>
+            </a:r>
+            <a:r>
+              <a:rPr lang="en-US" baseline="0" dirty="0" smtClean="0"/>
+              <a:t> show that we have a backlog, no need to go into great detail here</a:t>
+            </a:r>
+            <a:endParaRPr lang="en-US" dirty="0"/>
+          </a:p>
+        </p:txBody>
+      </p:sp>
+      <p:sp>
+        <p:nvSpPr>
+          <p:cNvPr id="4" name="Slide Number Placeholder 3"/>
+          <p:cNvSpPr>
+            <a:spLocks noGrp="1"/>
+          </p:cNvSpPr>
+          <p:nvPr>
+            <p:ph type="sldNum" sz="quarter" idx="10"/>
+          </p:nvPr>
+        </p:nvSpPr>
+        <p:spPr/>
+        <p:txBody>
+          <a:bodyPr/>
+          <a:lstStyle/>
+          <a:p>
+            <a:fld id="{2196A064-7C2B-4BD1-B717-284E7E6AAF69}" type="slidenum">
+              <a:rPr lang="en-US" smtClean="0"/>
+              <a:t>13</a:t>
+            </a:fld>
+            <a:endParaRPr lang="en-US"/>
+          </a:p>
+        </p:txBody>
+      </p:sp>
+    </p:spTree>
+    <p:extLst>
+      <p:ext uri="{BB962C8B-B14F-4D97-AF65-F5344CB8AC3E}">
+        <p14:creationId xmlns:p14="http://schemas.microsoft.com/office/powerpoint/2010/main" val="542630260"/>
+      </p:ext>
+    </p:extLst>
+  </p:cSld>
+  <p:clrMapOvr>
+    <a:masterClrMapping/>
+  </p:clrMapOvr>
+</p:notes>
+</file>
+
+<file path=ppt/notesSlides/notesSlide13.xml><?xml version="1.0" encoding="utf-8"?>
+<p:notes xmlns:a="http://schemas.openxmlformats.org/drawingml/2006/main" xmlns:r="http://schemas.openxmlformats.org/officeDocument/2006/relationships" xmlns:p="http://schemas.openxmlformats.org/presentationml/2006/main">
+  <p:cSld>
+    <p:spTree>
+      <p:nvGrpSpPr>
+        <p:cNvPr id="1" name=""/>
+        <p:cNvGrpSpPr/>
+        <p:nvPr/>
+      </p:nvGrpSpPr>
+      <p:grpSpPr>
+        <a:xfrm>
+          <a:off x="0" y="0"/>
+          <a:ext cx="0" cy="0"/>
+          <a:chOff x="0" y="0"/>
+          <a:chExt cx="0" cy="0"/>
+        </a:xfrm>
+      </p:grpSpPr>
+      <p:sp>
+        <p:nvSpPr>
+          <p:cNvPr id="2" name="Slide Image Placeholder 1"/>
+          <p:cNvSpPr>
+            <a:spLocks noGrp="1" noRot="1" noChangeAspect="1"/>
+          </p:cNvSpPr>
+          <p:nvPr>
+            <p:ph type="sldImg"/>
+          </p:nvPr>
+        </p:nvSpPr>
+        <p:spPr/>
+      </p:sp>
+      <p:sp>
+        <p:nvSpPr>
+          <p:cNvPr id="3" name="Notes Placeholder 2"/>
+          <p:cNvSpPr>
+            <a:spLocks noGrp="1"/>
+          </p:cNvSpPr>
+          <p:nvPr>
+            <p:ph type="body" idx="1"/>
+          </p:nvPr>
+        </p:nvSpPr>
+        <p:spPr/>
+        <p:txBody>
+          <a:bodyPr/>
+          <a:lstStyle/>
+          <a:p>
             <a:r>
               <a:rPr lang="en-US" sz="1200" b="0" i="0" kern="1200" dirty="0" smtClean="0">
                 <a:solidFill>
@@ -794,7 +978,7 @@
           <a:p>
             <a:fld id="{2196A064-7C2B-4BD1-B717-284E7E6AAF69}" type="slidenum">
               <a:rPr lang="en-US" smtClean="0"/>
-              <a:t>12</a:t>
+              <a:t>14</a:t>
             </a:fld>
             <a:endParaRPr lang="en-US"/>
           </a:p>
@@ -1259,7 +1443,7 @@
           <a:p>
             <a:fld id="{2196A064-7C2B-4BD1-B717-284E7E6AAF69}" type="slidenum">
               <a:rPr lang="en-US" smtClean="0"/>
-              <a:t>6</a:t>
+              <a:t>7</a:t>
             </a:fld>
             <a:endParaRPr lang="en-US" dirty="0"/>
           </a:p>
@@ -1324,7 +1508,39 @@
           <a:p>
             <a:r>
               <a:rPr lang="en-US" dirty="0" smtClean="0"/>
-              <a:t>David</a:t>
+              <a:t>David + Kevin</a:t>
+            </a:r>
+          </a:p>
+          <a:p>
+            <a:r>
+              <a:rPr lang="en-US" dirty="0" smtClean="0"/>
+              <a:t>Game</a:t>
+            </a:r>
+            <a:r>
+              <a:rPr lang="en-US" baseline="0" dirty="0" smtClean="0"/>
+              <a:t> Stats: for each game, show: total # played, total currently playing, date made (in)active, date imported</a:t>
+            </a:r>
+          </a:p>
+          <a:p>
+            <a:r>
+              <a:rPr lang="en-US" baseline="0" dirty="0" smtClean="0"/>
+              <a:t>Server Stats: </a:t>
+            </a:r>
+          </a:p>
+          <a:p>
+            <a:r>
+              <a:rPr lang="en-US" baseline="0" dirty="0" smtClean="0"/>
+              <a:t>Error Log:</a:t>
+            </a:r>
+          </a:p>
+          <a:p>
+            <a:r>
+              <a:rPr lang="en-US" baseline="0" dirty="0" smtClean="0"/>
+              <a:t>Import login: brings up a file dialog so admin can browse to and add a </a:t>
+            </a:r>
+            <a:r>
+              <a:rPr lang="en-US" baseline="0" smtClean="0"/>
+              <a:t>game file.</a:t>
             </a:r>
             <a:endParaRPr lang="en-US" dirty="0"/>
           </a:p>
@@ -1347,16 +1563,16 @@
           <a:p>
             <a:fld id="{2196A064-7C2B-4BD1-B717-284E7E6AAF69}" type="slidenum">
               <a:rPr lang="en-US" smtClean="0"/>
-              <a:t>7</a:t>
+              <a:t>8</a:t>
             </a:fld>
-            <a:endParaRPr lang="en-US"/>
+            <a:endParaRPr lang="en-US" dirty="0"/>
           </a:p>
         </p:txBody>
       </p:sp>
     </p:spTree>
     <p:extLst>
       <p:ext uri="{BB962C8B-B14F-4D97-AF65-F5344CB8AC3E}">
-        <p14:creationId xmlns:p14="http://schemas.microsoft.com/office/powerpoint/2010/main" val="3581750510"/>
+        <p14:creationId xmlns:p14="http://schemas.microsoft.com/office/powerpoint/2010/main" val="4139971806"/>
       </p:ext>
     </p:extLst>
   </p:cSld>
@@ -1412,7 +1628,7 @@
           <a:p>
             <a:r>
               <a:rPr lang="en-US" dirty="0" smtClean="0"/>
-              <a:t>Marshall + Kevin</a:t>
+              <a:t>David</a:t>
             </a:r>
             <a:endParaRPr lang="en-US" dirty="0"/>
           </a:p>
@@ -1435,7 +1651,7 @@
           <a:p>
             <a:fld id="{2196A064-7C2B-4BD1-B717-284E7E6AAF69}" type="slidenum">
               <a:rPr lang="en-US" smtClean="0"/>
-              <a:t>8</a:t>
+              <a:t>9</a:t>
             </a:fld>
             <a:endParaRPr lang="en-US"/>
           </a:p>
@@ -1444,7 +1660,7 @@
     </p:spTree>
     <p:extLst>
       <p:ext uri="{BB962C8B-B14F-4D97-AF65-F5344CB8AC3E}">
-        <p14:creationId xmlns:p14="http://schemas.microsoft.com/office/powerpoint/2010/main" val="2086731328"/>
+        <p14:creationId xmlns:p14="http://schemas.microsoft.com/office/powerpoint/2010/main" val="3581750510"/>
       </p:ext>
     </p:extLst>
   </p:cSld>
@@ -1499,22 +1715,8 @@
           <a:lstStyle/>
           <a:p>
             <a:r>
-              <a:rPr lang="en-US" sz="1200" b="0" i="0" kern="1200" dirty="0" smtClean="0">
-                <a:solidFill>
-                  <a:schemeClr val="tx1"/>
-                </a:solidFill>
-                <a:effectLst/>
-                <a:latin typeface="+mn-lt"/>
-                <a:ea typeface="+mn-ea"/>
-                <a:cs typeface="+mn-cs"/>
-              </a:rPr>
-              <a:t>Risks, risk analysis, mitigation and contingency plan  (2 min)</a:t>
-            </a:r>
-          </a:p>
-          <a:p>
-            <a:r>
-              <a:rPr lang="en-US" dirty="0" smtClean="0"/>
-              <a:t>David</a:t>
+              <a:rPr lang="en-US" dirty="0" smtClean="0"/>
+              <a:t>Marshall + Kevin</a:t>
             </a:r>
             <a:endParaRPr lang="en-US" dirty="0"/>
           </a:p>
@@ -1537,7 +1739,7 @@
           <a:p>
             <a:fld id="{2196A064-7C2B-4BD1-B717-284E7E6AAF69}" type="slidenum">
               <a:rPr lang="en-US" smtClean="0"/>
-              <a:t>9</a:t>
+              <a:t>10</a:t>
             </a:fld>
             <a:endParaRPr lang="en-US"/>
           </a:p>
@@ -1546,7 +1748,7 @@
     </p:spTree>
     <p:extLst>
       <p:ext uri="{BB962C8B-B14F-4D97-AF65-F5344CB8AC3E}">
-        <p14:creationId xmlns:p14="http://schemas.microsoft.com/office/powerpoint/2010/main" val="1966491216"/>
+        <p14:creationId xmlns:p14="http://schemas.microsoft.com/office/powerpoint/2010/main" val="2086731328"/>
       </p:ext>
     </p:extLst>
   </p:cSld>
@@ -6162,150 +6364,77 @@
         </p:nvSpPr>
         <p:spPr/>
         <p:txBody>
+          <a:bodyPr/>
+          <a:lstStyle/>
+          <a:p>
+            <a:r>
+              <a:rPr lang="en-US" dirty="0" smtClean="0"/>
+              <a:t>Set Top Box</a:t>
+            </a:r>
+          </a:p>
+          <a:p>
+            <a:pPr lvl="1"/>
+            <a:r>
+              <a:rPr lang="en-US" dirty="0" smtClean="0"/>
+              <a:t>Low memory</a:t>
+            </a:r>
+          </a:p>
+          <a:p>
+            <a:pPr lvl="1"/>
+            <a:r>
+              <a:rPr lang="en-US" dirty="0" smtClean="0"/>
+              <a:t>Can’t use flash storage</a:t>
+            </a:r>
+          </a:p>
+          <a:p>
+            <a:pPr lvl="1"/>
+            <a:r>
+              <a:rPr lang="en-US" dirty="0" smtClean="0"/>
+              <a:t>Low powered processor</a:t>
+            </a:r>
+          </a:p>
+          <a:p>
+            <a:pPr lvl="1"/>
+            <a:r>
+              <a:rPr lang="en-US" dirty="0" smtClean="0"/>
+              <a:t>Limited bandwidth usage</a:t>
+            </a:r>
+          </a:p>
+          <a:p>
+            <a:r>
+              <a:rPr lang="en-US" dirty="0" smtClean="0"/>
+              <a:t>Server</a:t>
+            </a:r>
+          </a:p>
+          <a:p>
+            <a:pPr lvl="1"/>
+            <a:r>
+              <a:rPr lang="en-US" dirty="0" smtClean="0"/>
+              <a:t>Needs to be scalable to 100s or 1000s of users simultaneously connected</a:t>
+            </a:r>
+          </a:p>
+        </p:txBody>
+      </p:sp>
+      <p:sp>
+        <p:nvSpPr>
+          <p:cNvPr id="3" name="Title 2"/>
+          <p:cNvSpPr>
+            <a:spLocks noGrp="1"/>
+          </p:cNvSpPr>
+          <p:nvPr>
+            <p:ph type="title"/>
+          </p:nvPr>
+        </p:nvSpPr>
+        <p:spPr/>
+        <p:txBody>
           <a:bodyPr>
-            <a:normAutofit lnSpcReduction="10000"/>
+            <a:normAutofit/>
           </a:bodyPr>
           <a:lstStyle/>
           <a:p>
             <a:r>
               <a:rPr lang="en-US" dirty="0" smtClean="0"/>
-              <a:t>Sprint 1: </a:t>
-            </a:r>
-            <a:r>
-              <a:rPr lang="en-US" sz="2400" dirty="0" smtClean="0"/>
-              <a:t>September 19</a:t>
-            </a:r>
-            <a:r>
-              <a:rPr lang="en-US" sz="2400" baseline="30000" dirty="0" smtClean="0"/>
-              <a:t>th</a:t>
-            </a:r>
-            <a:r>
-              <a:rPr lang="en-US" sz="2400" dirty="0" smtClean="0"/>
-              <a:t> – October 3</a:t>
-            </a:r>
-            <a:r>
-              <a:rPr lang="en-US" sz="2400" baseline="30000" dirty="0" smtClean="0"/>
-              <a:t>rd</a:t>
-            </a:r>
-            <a:endParaRPr lang="en-US" sz="2400" dirty="0" smtClean="0"/>
-          </a:p>
-          <a:p>
-            <a:pPr lvl="1"/>
-            <a:r>
-              <a:rPr lang="en-US" dirty="0" smtClean="0"/>
-              <a:t>Deliverables</a:t>
-            </a:r>
-          </a:p>
-          <a:p>
-            <a:pPr lvl="2"/>
-            <a:r>
-              <a:rPr lang="en-US" dirty="0" smtClean="0"/>
-              <a:t>Initial design document</a:t>
-            </a:r>
-          </a:p>
-          <a:p>
-            <a:pPr lvl="2"/>
-            <a:r>
-              <a:rPr lang="en-US" dirty="0" smtClean="0"/>
-              <a:t>Initial requirements document</a:t>
-            </a:r>
-          </a:p>
-          <a:p>
-            <a:pPr lvl="1"/>
-            <a:r>
-              <a:rPr lang="en-US" dirty="0" smtClean="0"/>
-              <a:t>Environment: Setup and Testing</a:t>
-            </a:r>
-            <a:endParaRPr lang="en-US" dirty="0" smtClean="0"/>
-          </a:p>
-          <a:p>
-            <a:pPr lvl="2"/>
-            <a:r>
-              <a:rPr lang="en-US" dirty="0" smtClean="0"/>
-              <a:t>Meeting with STB team from Mitchell</a:t>
-            </a:r>
-          </a:p>
-          <a:p>
-            <a:pPr lvl="2"/>
-            <a:r>
-              <a:rPr lang="en-US" dirty="0" smtClean="0"/>
-              <a:t>Information exchange</a:t>
-            </a:r>
-          </a:p>
-          <a:p>
-            <a:pPr lvl="1"/>
-            <a:r>
-              <a:rPr lang="en-US" dirty="0" smtClean="0"/>
-              <a:t>Research</a:t>
-            </a:r>
-          </a:p>
-          <a:p>
-            <a:pPr lvl="2"/>
-            <a:r>
-              <a:rPr lang="en-US" dirty="0" smtClean="0"/>
-              <a:t>Dynamically load views on STB</a:t>
-            </a:r>
-          </a:p>
-          <a:p>
-            <a:pPr lvl="2"/>
-            <a:r>
-              <a:rPr lang="en-US" dirty="0" smtClean="0"/>
-              <a:t>Sending game state using Protocol Buffers</a:t>
-            </a:r>
-          </a:p>
-          <a:p>
-            <a:r>
-              <a:rPr lang="en-US" dirty="0" smtClean="0"/>
-              <a:t>Sprint 2: </a:t>
-            </a:r>
-            <a:r>
-              <a:rPr lang="en-US" sz="2400" dirty="0" smtClean="0"/>
-              <a:t>October 10</a:t>
-            </a:r>
-            <a:r>
-              <a:rPr lang="en-US" sz="2400" baseline="30000" dirty="0" smtClean="0"/>
-              <a:t>th</a:t>
-            </a:r>
-            <a:r>
-              <a:rPr lang="en-US" sz="2400" dirty="0" smtClean="0"/>
-              <a:t> – October 31</a:t>
-            </a:r>
-            <a:r>
-              <a:rPr lang="en-US" sz="2400" baseline="30000" dirty="0" smtClean="0"/>
-              <a:t>st</a:t>
-            </a:r>
-            <a:r>
-              <a:rPr lang="en-US" sz="2400" dirty="0" smtClean="0"/>
-              <a:t> </a:t>
-            </a:r>
-          </a:p>
-          <a:p>
-            <a:pPr lvl="1"/>
-            <a:r>
-              <a:rPr lang="en-US" dirty="0" smtClean="0"/>
-              <a:t>Begin development</a:t>
-            </a:r>
-          </a:p>
-        </p:txBody>
-      </p:sp>
-      <p:sp>
-        <p:nvSpPr>
-          <p:cNvPr id="3" name="Title 2"/>
-          <p:cNvSpPr>
-            <a:spLocks noGrp="1"/>
-          </p:cNvSpPr>
-          <p:nvPr>
-            <p:ph type="title"/>
-          </p:nvPr>
-        </p:nvSpPr>
-        <p:spPr/>
-        <p:txBody>
-          <a:bodyPr/>
-          <a:lstStyle/>
-          <a:p>
-            <a:r>
-              <a:rPr lang="en-US" dirty="0" smtClean="0"/>
-              <a:t>Sprints</a:t>
+              <a:t>Constraints</a:t>
             </a:r>
             <a:endParaRPr lang="en-US" dirty="0"/>
           </a:p>
@@ -6314,7 +6443,7 @@
     </p:spTree>
     <p:extLst>
       <p:ext uri="{BB962C8B-B14F-4D97-AF65-F5344CB8AC3E}">
-        <p14:creationId xmlns:p14="http://schemas.microsoft.com/office/powerpoint/2010/main" val="1446175581"/>
+        <p14:creationId xmlns:p14="http://schemas.microsoft.com/office/powerpoint/2010/main" val="2063007733"/>
       </p:ext>
     </p:extLst>
   </p:cSld>
@@ -6361,6 +6490,368 @@
         <p:spPr/>
         <p:txBody>
           <a:bodyPr>
+            <a:normAutofit lnSpcReduction="10000"/>
+          </a:bodyPr>
+          <a:lstStyle/>
+          <a:p>
+            <a:r>
+              <a:rPr lang="en-US" dirty="0" smtClean="0"/>
+              <a:t>STB firmware updates during development</a:t>
+            </a:r>
+          </a:p>
+          <a:p>
+            <a:pPr lvl="1"/>
+            <a:r>
+              <a:rPr lang="en-US" dirty="0" smtClean="0"/>
+              <a:t>Previous project</a:t>
+            </a:r>
+          </a:p>
+          <a:p>
+            <a:pPr lvl="1"/>
+            <a:r>
+              <a:rPr lang="en-US" dirty="0" smtClean="0"/>
+              <a:t>Should only affect UI engine on STB</a:t>
+            </a:r>
+          </a:p>
+          <a:p>
+            <a:pPr lvl="1"/>
+            <a:r>
+              <a:rPr lang="en-US" dirty="0" smtClean="0"/>
+              <a:t>Contingency Plan</a:t>
+            </a:r>
+          </a:p>
+          <a:p>
+            <a:pPr lvl="2"/>
+            <a:r>
+              <a:rPr lang="en-US" dirty="0" smtClean="0"/>
+              <a:t>Update the engine as soon as possible</a:t>
+            </a:r>
+          </a:p>
+          <a:p>
+            <a:r>
+              <a:rPr lang="en-US" dirty="0" smtClean="0"/>
+              <a:t>Changing the game development process</a:t>
+            </a:r>
+          </a:p>
+          <a:p>
+            <a:pPr lvl="1"/>
+            <a:r>
+              <a:rPr lang="en-US" dirty="0" smtClean="0"/>
+              <a:t>Could increase game development time</a:t>
+            </a:r>
+          </a:p>
+          <a:p>
+            <a:pPr lvl="1"/>
+            <a:r>
+              <a:rPr lang="en-US" dirty="0" smtClean="0"/>
+              <a:t>Might make debugging even more difficult</a:t>
+            </a:r>
+          </a:p>
+          <a:p>
+            <a:pPr lvl="1"/>
+            <a:r>
+              <a:rPr lang="en-US" dirty="0" smtClean="0"/>
+              <a:t>Contingency Plan</a:t>
+            </a:r>
+          </a:p>
+          <a:p>
+            <a:pPr lvl="2"/>
+            <a:r>
+              <a:rPr lang="en-US" dirty="0" smtClean="0"/>
+              <a:t>Build an error logger into the client engine</a:t>
+            </a:r>
+          </a:p>
+          <a:p>
+            <a:pPr lvl="2"/>
+            <a:r>
+              <a:rPr lang="en-US" dirty="0" smtClean="0"/>
+              <a:t>Send crash reports to the </a:t>
+            </a:r>
+            <a:r>
+              <a:rPr lang="en-US" dirty="0" smtClean="0"/>
+              <a:t>server</a:t>
+            </a:r>
+          </a:p>
+          <a:p>
+            <a:pPr lvl="2"/>
+            <a:r>
+              <a:rPr lang="en-US" dirty="0" smtClean="0"/>
+              <a:t>Port existing games to new model</a:t>
+            </a:r>
+            <a:endParaRPr lang="en-US" dirty="0"/>
+          </a:p>
+        </p:txBody>
+      </p:sp>
+      <p:sp>
+        <p:nvSpPr>
+          <p:cNvPr id="3" name="Title 2"/>
+          <p:cNvSpPr>
+            <a:spLocks noGrp="1"/>
+          </p:cNvSpPr>
+          <p:nvPr>
+            <p:ph type="title"/>
+          </p:nvPr>
+        </p:nvSpPr>
+        <p:spPr/>
+        <p:txBody>
+          <a:bodyPr/>
+          <a:lstStyle/>
+          <a:p>
+            <a:r>
+              <a:rPr lang="en-US" dirty="0" smtClean="0"/>
+              <a:t>Risks</a:t>
+            </a:r>
+            <a:endParaRPr lang="en-US" dirty="0"/>
+          </a:p>
+        </p:txBody>
+      </p:sp>
+    </p:spTree>
+    <p:extLst>
+      <p:ext uri="{BB962C8B-B14F-4D97-AF65-F5344CB8AC3E}">
+        <p14:creationId xmlns:p14="http://schemas.microsoft.com/office/powerpoint/2010/main" val="1092627084"/>
+      </p:ext>
+    </p:extLst>
+  </p:cSld>
+  <p:clrMapOvr>
+    <a:masterClrMapping/>
+  </p:clrMapOvr>
+  <p:timing>
+    <p:tnLst>
+      <p:par>
+        <p:cTn id="1" dur="indefinite" restart="never" nodeType="tmRoot"/>
+      </p:par>
+    </p:tnLst>
+  </p:timing>
+</p:sld>
+</file>
+
+<file path=ppt/slides/slide12.xml><?xml version="1.0" encoding="utf-8"?>
+<p:sld xmlns:a="http://schemas.openxmlformats.org/drawingml/2006/main" xmlns:r="http://schemas.openxmlformats.org/officeDocument/2006/relationships" xmlns:p="http://schemas.openxmlformats.org/presentationml/2006/main">
+  <p:cSld>
+    <p:spTree>
+      <p:nvGrpSpPr>
+        <p:cNvPr id="1" name=""/>
+        <p:cNvGrpSpPr/>
+        <p:nvPr/>
+      </p:nvGrpSpPr>
+      <p:grpSpPr>
+        <a:xfrm>
+          <a:off x="0" y="0"/>
+          <a:ext cx="0" cy="0"/>
+          <a:chOff x="0" y="0"/>
+          <a:chExt cx="0" cy="0"/>
+        </a:xfrm>
+      </p:grpSpPr>
+      <p:sp>
+        <p:nvSpPr>
+          <p:cNvPr id="2" name="Content Placeholder 1"/>
+          <p:cNvSpPr>
+            <a:spLocks noGrp="1"/>
+          </p:cNvSpPr>
+          <p:nvPr>
+            <p:ph idx="1"/>
+          </p:nvPr>
+        </p:nvSpPr>
+        <p:spPr/>
+        <p:txBody>
+          <a:bodyPr>
+            <a:normAutofit lnSpcReduction="10000"/>
+          </a:bodyPr>
+          <a:lstStyle/>
+          <a:p>
+            <a:r>
+              <a:rPr lang="en-US" dirty="0" smtClean="0"/>
+              <a:t>Sprint 1: </a:t>
+            </a:r>
+            <a:r>
+              <a:rPr lang="en-US" sz="2400" dirty="0" smtClean="0"/>
+              <a:t>September 19</a:t>
+            </a:r>
+            <a:r>
+              <a:rPr lang="en-US" sz="2400" baseline="30000" dirty="0" smtClean="0"/>
+              <a:t>th</a:t>
+            </a:r>
+            <a:r>
+              <a:rPr lang="en-US" sz="2400" dirty="0" smtClean="0"/>
+              <a:t> – October 3</a:t>
+            </a:r>
+            <a:r>
+              <a:rPr lang="en-US" sz="2400" baseline="30000" dirty="0" smtClean="0"/>
+              <a:t>rd</a:t>
+            </a:r>
+            <a:endParaRPr lang="en-US" sz="2400" dirty="0" smtClean="0"/>
+          </a:p>
+          <a:p>
+            <a:pPr lvl="1"/>
+            <a:r>
+              <a:rPr lang="en-US" dirty="0" smtClean="0"/>
+              <a:t>Deliverables</a:t>
+            </a:r>
+          </a:p>
+          <a:p>
+            <a:pPr lvl="2"/>
+            <a:r>
+              <a:rPr lang="en-US" dirty="0" smtClean="0"/>
+              <a:t>Initial design document</a:t>
+            </a:r>
+          </a:p>
+          <a:p>
+            <a:pPr lvl="2"/>
+            <a:r>
+              <a:rPr lang="en-US" dirty="0" smtClean="0"/>
+              <a:t>Initial requirements document</a:t>
+            </a:r>
+          </a:p>
+          <a:p>
+            <a:pPr lvl="1"/>
+            <a:r>
+              <a:rPr lang="en-US" dirty="0" smtClean="0"/>
+              <a:t>Environment: Setup and Testing</a:t>
+            </a:r>
+          </a:p>
+          <a:p>
+            <a:pPr lvl="2"/>
+            <a:r>
+              <a:rPr lang="en-US" dirty="0" smtClean="0"/>
+              <a:t>Meeting with STB team from Mitchell</a:t>
+            </a:r>
+          </a:p>
+          <a:p>
+            <a:pPr lvl="2"/>
+            <a:r>
+              <a:rPr lang="en-US" dirty="0" smtClean="0"/>
+              <a:t>Information exchange</a:t>
+            </a:r>
+          </a:p>
+          <a:p>
+            <a:pPr lvl="1"/>
+            <a:r>
+              <a:rPr lang="en-US" dirty="0" smtClean="0"/>
+              <a:t>Research</a:t>
+            </a:r>
+          </a:p>
+          <a:p>
+            <a:pPr lvl="2"/>
+            <a:r>
+              <a:rPr lang="en-US" dirty="0" smtClean="0"/>
+              <a:t>Dynamically load views on STB</a:t>
+            </a:r>
+          </a:p>
+          <a:p>
+            <a:pPr lvl="2"/>
+            <a:r>
+              <a:rPr lang="en-US" dirty="0" smtClean="0"/>
+              <a:t>Sending game state using Protocol Buffers</a:t>
+            </a:r>
+          </a:p>
+          <a:p>
+            <a:r>
+              <a:rPr lang="en-US" dirty="0" smtClean="0"/>
+              <a:t>Sprint 2: </a:t>
+            </a:r>
+            <a:r>
+              <a:rPr lang="en-US" sz="2400" dirty="0" smtClean="0"/>
+              <a:t>October 10</a:t>
+            </a:r>
+            <a:r>
+              <a:rPr lang="en-US" sz="2400" baseline="30000" dirty="0" smtClean="0"/>
+              <a:t>th</a:t>
+            </a:r>
+            <a:r>
+              <a:rPr lang="en-US" sz="2400" dirty="0" smtClean="0"/>
+              <a:t> – October 31</a:t>
+            </a:r>
+            <a:r>
+              <a:rPr lang="en-US" sz="2400" baseline="30000" dirty="0" smtClean="0"/>
+              <a:t>st</a:t>
+            </a:r>
+            <a:r>
+              <a:rPr lang="en-US" sz="2400" dirty="0" smtClean="0"/>
+              <a:t> </a:t>
+            </a:r>
+          </a:p>
+          <a:p>
+            <a:pPr lvl="1"/>
+            <a:r>
+              <a:rPr lang="en-US" dirty="0" smtClean="0"/>
+              <a:t>Begin development</a:t>
+            </a:r>
+          </a:p>
+        </p:txBody>
+      </p:sp>
+      <p:sp>
+        <p:nvSpPr>
+          <p:cNvPr id="3" name="Title 2"/>
+          <p:cNvSpPr>
+            <a:spLocks noGrp="1"/>
+          </p:cNvSpPr>
+          <p:nvPr>
+            <p:ph type="title"/>
+          </p:nvPr>
+        </p:nvSpPr>
+        <p:spPr/>
+        <p:txBody>
+          <a:bodyPr/>
+          <a:lstStyle/>
+          <a:p>
+            <a:r>
+              <a:rPr lang="en-US" dirty="0" smtClean="0"/>
+              <a:t>Sprints</a:t>
+            </a:r>
+            <a:endParaRPr lang="en-US" dirty="0"/>
+          </a:p>
+        </p:txBody>
+      </p:sp>
+    </p:spTree>
+    <p:extLst>
+      <p:ext uri="{BB962C8B-B14F-4D97-AF65-F5344CB8AC3E}">
+        <p14:creationId xmlns:p14="http://schemas.microsoft.com/office/powerpoint/2010/main" val="1446175581"/>
+      </p:ext>
+    </p:extLst>
+  </p:cSld>
+  <p:clrMapOvr>
+    <a:masterClrMapping/>
+  </p:clrMapOvr>
+  <p:timing>
+    <p:tnLst>
+      <p:par>
+        <p:cTn id="1" dur="indefinite" restart="never" nodeType="tmRoot"/>
+      </p:par>
+    </p:tnLst>
+  </p:timing>
+</p:sld>
+</file>
+
+<file path=ppt/slides/slide13.xml><?xml version="1.0" encoding="utf-8"?>
+<p:sld xmlns:a="http://schemas.openxmlformats.org/drawingml/2006/main" xmlns:r="http://schemas.openxmlformats.org/officeDocument/2006/relationships" xmlns:p="http://schemas.openxmlformats.org/presentationml/2006/main">
+  <p:cSld>
+    <p:spTree>
+      <p:nvGrpSpPr>
+        <p:cNvPr id="1" name=""/>
+        <p:cNvGrpSpPr/>
+        <p:nvPr/>
+      </p:nvGrpSpPr>
+      <p:grpSpPr>
+        <a:xfrm>
+          <a:off x="0" y="0"/>
+          <a:ext cx="0" cy="0"/>
+          <a:chOff x="0" y="0"/>
+          <a:chExt cx="0" cy="0"/>
+        </a:xfrm>
+      </p:grpSpPr>
+      <p:sp>
+        <p:nvSpPr>
+          <p:cNvPr id="2" name="Content Placeholder 1"/>
+          <p:cNvSpPr>
+            <a:spLocks noGrp="1"/>
+          </p:cNvSpPr>
+          <p:nvPr>
+            <p:ph idx="1"/>
+          </p:nvPr>
+        </p:nvSpPr>
+        <p:spPr/>
+        <p:txBody>
+          <a:bodyPr>
             <a:normAutofit fontScale="70000" lnSpcReduction="20000"/>
           </a:bodyPr>
           <a:lstStyle/>
@@ -6556,7 +7047,7 @@
 </p:sld>
 </file>
 
-<file path=ppt/slides/slide12.xml><?xml version="1.0" encoding="utf-8"?>
+<file path=ppt/slides/slide14.xml><?xml version="1.0" encoding="utf-8"?>
 <p:sld xmlns:a="http://schemas.openxmlformats.org/drawingml/2006/main" xmlns:r="http://schemas.openxmlformats.org/officeDocument/2006/relationships" xmlns:p="http://schemas.openxmlformats.org/presentationml/2006/main">
   <p:cSld>
     <p:spTree>
@@ -7007,12 +7498,13 @@
             <a:pPr algn="ctr"/>
             <a:r>
               <a:rPr lang="en-US" dirty="0" smtClean="0"/>
-              <a:t>Implementation </a:t>
+              <a:t>Design #</a:t>
             </a:r>
             <a:r>
               <a:rPr lang="en-US" dirty="0"/>
-              <a:t>#1 </a:t>
-            </a:r>
+              <a:t>1</a:t>
+            </a:r>
+            <a:endParaRPr lang="en-US" dirty="0"/>
           </a:p>
           <a:p>
             <a:endParaRPr lang="en-US" dirty="0"/>
@@ -7043,7 +7535,7 @@
             <a:pPr algn="ctr"/>
             <a:r>
               <a:rPr lang="en-US" dirty="0" smtClean="0"/>
-              <a:t>Implementation </a:t>
+              <a:t>Design </a:t>
             </a:r>
             <a:r>
               <a:rPr lang="en-US" dirty="0"/>
@@ -7123,8 +7615,20 @@
             <a:pPr lvl="2"/>
             <a:r>
               <a:rPr lang="en-US" dirty="0" smtClean="0"/>
-              <a:t>Card games UI</a:t>
-            </a:r>
+              <a:t>Card games </a:t>
+            </a:r>
+            <a:r>
+              <a:rPr lang="en-US" dirty="0" smtClean="0"/>
+              <a:t>UI</a:t>
+            </a:r>
+          </a:p>
+          <a:p>
+            <a:pPr lvl="1"/>
+            <a:r>
+              <a:rPr lang="en-US" dirty="0" smtClean="0"/>
+              <a:t>Games implemented using C#</a:t>
+            </a:r>
+            <a:endParaRPr lang="en-US" dirty="0" smtClean="0"/>
           </a:p>
         </p:txBody>
       </p:sp>
@@ -7167,7 +7671,18 @@
             </a:r>
             <a:r>
               <a:rPr lang="en-US" dirty="0" smtClean="0"/>
-              <a:t>same communications as Implementation #1</a:t>
+              <a:t>same communications as Implementation #</a:t>
+            </a:r>
+            <a:r>
+              <a:rPr lang="en-US" dirty="0" smtClean="0"/>
+              <a:t>1</a:t>
+            </a:r>
+          </a:p>
+          <a:p>
+            <a:pPr lvl="1"/>
+            <a:r>
+              <a:rPr lang="en-US" dirty="0" smtClean="0"/>
+              <a:t>Game continued to be created with current environment</a:t>
             </a:r>
             <a:endParaRPr lang="en-US" dirty="0"/>
           </a:p>
@@ -7215,12 +7730,12 @@
       </p:grpSpPr>
       <p:sp>
         <p:nvSpPr>
-          <p:cNvPr id="7" name="Content Placeholder 6"/>
-          <p:cNvSpPr>
-            <a:spLocks noGrp="1"/>
-          </p:cNvSpPr>
-          <p:nvPr>
-            <p:ph idx="1"/>
+          <p:cNvPr id="7" name="Title 6"/>
+          <p:cNvSpPr>
+            <a:spLocks noGrp="1"/>
+          </p:cNvSpPr>
+          <p:nvPr>
+            <p:ph type="title"/>
           </p:nvPr>
         </p:nvSpPr>
         <p:spPr/>
@@ -7230,82 +7745,203 @@
           <a:p>
             <a:r>
               <a:rPr lang="en-US" dirty="0" smtClean="0"/>
-              <a:t>Written in C# under .NET 4.5</a:t>
-            </a:r>
-          </a:p>
-          <a:p>
-            <a:r>
-              <a:rPr lang="en-US" dirty="0" smtClean="0"/>
-              <a:t>Windows server environment</a:t>
+              <a:t>Decision Matrix</a:t>
+            </a:r>
+            <a:endParaRPr lang="en-US" dirty="0"/>
+          </a:p>
+        </p:txBody>
+      </p:sp>
+      <p:sp>
+        <p:nvSpPr>
+          <p:cNvPr id="16" name="Content Placeholder 15"/>
+          <p:cNvSpPr>
+            <a:spLocks noGrp="1"/>
+          </p:cNvSpPr>
+          <p:nvPr>
+            <p:ph idx="1"/>
+          </p:nvPr>
+        </p:nvSpPr>
+        <p:spPr>
+          <a:xfrm>
+            <a:off x="457200" y="1481328"/>
+            <a:ext cx="8229600" cy="2633471"/>
+          </a:xfrm>
+        </p:spPr>
+        <p:txBody>
+          <a:bodyPr>
+            <a:normAutofit fontScale="70000" lnSpcReduction="20000"/>
+          </a:bodyPr>
+          <a:lstStyle/>
+          <a:p>
+            <a:r>
+              <a:rPr lang="en-US" dirty="0" smtClean="0"/>
+              <a:t>Single </a:t>
+            </a:r>
+            <a:r>
+              <a:rPr lang="en-US" dirty="0"/>
+              <a:t>UI Engine</a:t>
             </a:r>
           </a:p>
           <a:p>
             <a:pPr lvl="1"/>
             <a:r>
               <a:rPr lang="en-US" dirty="0" smtClean="0"/>
-              <a:t>Portable to Azure</a:t>
-            </a:r>
-          </a:p>
-          <a:p>
-            <a:r>
-              <a:rPr lang="en-US" dirty="0" smtClean="0"/>
-              <a:t>SQL database</a:t>
-            </a:r>
-          </a:p>
-          <a:p>
-            <a:r>
-              <a:rPr lang="en-US" dirty="0" smtClean="0"/>
-              <a:t>Facilitates communication between clients</a:t>
-            </a:r>
-          </a:p>
-          <a:p>
-            <a:r>
-              <a:rPr lang="en-US" dirty="0" smtClean="0"/>
-              <a:t>Processes AI for virtual players</a:t>
-            </a:r>
-          </a:p>
-          <a:p>
-            <a:r>
-              <a:rPr lang="en-US" dirty="0" smtClean="0"/>
-              <a:t>Deploys game resources to client</a:t>
-            </a:r>
-          </a:p>
-          <a:p>
-            <a:r>
-              <a:rPr lang="en-US" dirty="0" smtClean="0"/>
-              <a:t>Manages logic for each multiplayer game instance</a:t>
+              <a:t>No binaries sent over the network</a:t>
             </a:r>
             <a:endParaRPr lang="en-US" dirty="0"/>
           </a:p>
-        </p:txBody>
-      </p:sp>
-      <p:sp>
-        <p:nvSpPr>
-          <p:cNvPr id="2" name="Title 1"/>
-          <p:cNvSpPr>
-            <a:spLocks noGrp="1"/>
-          </p:cNvSpPr>
-          <p:nvPr>
-            <p:ph type="title"/>
-          </p:nvPr>
-        </p:nvSpPr>
-        <p:spPr/>
-        <p:txBody>
-          <a:bodyPr/>
-          <a:lstStyle/>
-          <a:p>
-            <a:r>
-              <a:rPr lang="en-US" dirty="0" smtClean="0"/>
-              <a:t>Design Analysis - Server</a:t>
-            </a:r>
-            <a:endParaRPr lang="en-US" dirty="0"/>
-          </a:p>
-        </p:txBody>
-      </p:sp>
+          <a:p>
+            <a:pPr lvl="1"/>
+            <a:r>
+              <a:rPr lang="en-US" dirty="0"/>
+              <a:t>Slightly less stable, since it is generic</a:t>
+            </a:r>
+          </a:p>
+          <a:p>
+            <a:pPr lvl="1"/>
+            <a:r>
+              <a:rPr lang="en-US" dirty="0"/>
+              <a:t>Uses significantly less memory</a:t>
+            </a:r>
+          </a:p>
+          <a:p>
+            <a:pPr lvl="1"/>
+            <a:r>
+              <a:rPr lang="en-US" dirty="0"/>
+              <a:t>However, might be much more difficult to implement new </a:t>
+            </a:r>
+            <a:r>
+              <a:rPr lang="en-US" dirty="0" smtClean="0"/>
+              <a:t>games</a:t>
+            </a:r>
+          </a:p>
+          <a:p>
+            <a:r>
+              <a:rPr lang="en-US" dirty="0" smtClean="0"/>
+              <a:t>Individual Game Engine</a:t>
+            </a:r>
+          </a:p>
+          <a:p>
+            <a:pPr lvl="1"/>
+            <a:r>
+              <a:rPr lang="en-US" dirty="0" smtClean="0"/>
+              <a:t>Not binary compatible</a:t>
+            </a:r>
+          </a:p>
+          <a:p>
+            <a:pPr lvl="1"/>
+            <a:r>
+              <a:rPr lang="en-US" dirty="0" smtClean="0"/>
+              <a:t>More stable per game</a:t>
+            </a:r>
+          </a:p>
+          <a:p>
+            <a:pPr lvl="1"/>
+            <a:r>
+              <a:rPr lang="en-US" dirty="0" smtClean="0"/>
+              <a:t>Uses much more network traffic to download binaries</a:t>
+            </a:r>
+          </a:p>
+          <a:p>
+            <a:pPr lvl="1"/>
+            <a:r>
+              <a:rPr lang="en-US" dirty="0" smtClean="0"/>
+              <a:t>Can use current game development environment</a:t>
+            </a:r>
+          </a:p>
+          <a:p>
+            <a:pPr lvl="1"/>
+            <a:endParaRPr lang="en-US" dirty="0" smtClean="0"/>
+          </a:p>
+        </p:txBody>
+      </p:sp>
+      <p:graphicFrame>
+        <p:nvGraphicFramePr>
+          <p:cNvPr id="17" name="Object 16"/>
+          <p:cNvGraphicFramePr>
+            <a:graphicFrameLocks noGrp="1" noChangeAspect="1"/>
+          </p:cNvGraphicFramePr>
+          <p:nvPr>
+            <p:extLst>
+              <p:ext uri="{D42A27DB-BD31-4B8C-83A1-F6EECF244321}">
+                <p14:modId xmlns:p14="http://schemas.microsoft.com/office/powerpoint/2010/main" val="1863238026"/>
+              </p:ext>
+            </p:extLst>
+          </p:nvPr>
+        </p:nvGraphicFramePr>
+        <p:xfrm>
+          <a:off x="457200" y="4114800"/>
+          <a:ext cx="8228013" cy="1584325"/>
+        </p:xfrm>
+        <a:graphic>
+          <a:graphicData uri="http://schemas.openxmlformats.org/presentationml/2006/ole">
+            <mc:AlternateContent xmlns:mc="http://schemas.openxmlformats.org/markup-compatibility/2006">
+              <mc:Choice xmlns:v="urn:schemas-microsoft-com:vml" Requires="v">
+                <p:oleObj spid="_x0000_s1042" name="Worksheet" r:id="rId3" imgW="6134179" imgH="1181100" progId="Excel.Sheet.12">
+                  <p:embed/>
+                </p:oleObj>
+              </mc:Choice>
+              <mc:Fallback>
+                <p:oleObj name="Worksheet" r:id="rId3" imgW="6134179" imgH="1181100" progId="Excel.Sheet.12">
+                  <p:embed/>
+                  <p:pic>
+                    <p:nvPicPr>
+                      <p:cNvPr id="0" name="Content Placeholder 8"/>
+                      <p:cNvPicPr>
+                        <a:picLocks noGrp="1" noChangeAspect="1" noChangeArrowheads="1"/>
+                      </p:cNvPicPr>
+                      <p:nvPr/>
+                    </p:nvPicPr>
+                    <p:blipFill>
+                      <a:blip r:embed="rId4"/>
+                      <a:srcRect/>
+                      <a:stretch>
+                        <a:fillRect/>
+                      </a:stretch>
+                    </p:blipFill>
+                    <p:spPr bwMode="auto">
+                      <a:xfrm>
+                        <a:off x="457200" y="4114800"/>
+                        <a:ext cx="8228013" cy="1584325"/>
+                      </a:xfrm>
+                      <a:prstGeom prst="rect">
+                        <a:avLst/>
+                      </a:prstGeom>
+                      <a:noFill/>
+                      <a:ln>
+                        <a:noFill/>
+                      </a:ln>
+                      <a:extLst>
+                        <a:ext uri="{909E8E84-426E-40DD-AFC4-6F175D3DCCD1}">
+                          <a14:hiddenFill xmlns:a14="http://schemas.microsoft.com/office/drawing/2010/main">
+                            <a:solidFill>
+                              <a:srgbClr val="FFFFFF"/>
+                            </a:solidFill>
+                          </a14:hiddenFill>
+                        </a:ext>
+                        <a:ext uri="{91240B29-F687-4F45-9708-019B960494DF}">
+                          <a14:hiddenLine xmlns:a14="http://schemas.microsoft.com/office/drawing/2010/main" w="9525">
+                            <a:solidFill>
+                              <a:srgbClr val="000000"/>
+                            </a:solidFill>
+                            <a:miter lim="800000"/>
+                            <a:headEnd/>
+                            <a:tailEnd/>
+                          </a14:hiddenLine>
+                        </a:ext>
+                      </a:extLst>
+                    </p:spPr>
+                  </p:pic>
+                </p:oleObj>
+              </mc:Fallback>
+            </mc:AlternateContent>
+          </a:graphicData>
+        </a:graphic>
+      </p:graphicFrame>
     </p:spTree>
     <p:extLst>
       <p:ext uri="{BB962C8B-B14F-4D97-AF65-F5344CB8AC3E}">
-        <p14:creationId xmlns:p14="http://schemas.microsoft.com/office/powerpoint/2010/main" val="3561777257"/>
+        <p14:creationId xmlns:p14="http://schemas.microsoft.com/office/powerpoint/2010/main" val="1692658484"/>
       </p:ext>
     </p:extLst>
   </p:cSld>
@@ -7339,6 +7975,324 @@
           <a:chExt cx="0" cy="0"/>
         </a:xfrm>
       </p:grpSpPr>
+      <p:sp>
+        <p:nvSpPr>
+          <p:cNvPr id="7" name="Content Placeholder 6"/>
+          <p:cNvSpPr>
+            <a:spLocks noGrp="1"/>
+          </p:cNvSpPr>
+          <p:nvPr>
+            <p:ph idx="1"/>
+          </p:nvPr>
+        </p:nvSpPr>
+        <p:spPr/>
+        <p:txBody>
+          <a:bodyPr/>
+          <a:lstStyle/>
+          <a:p>
+            <a:r>
+              <a:rPr lang="en-US" dirty="0" smtClean="0"/>
+              <a:t>Written in C# under .NET 4.5</a:t>
+            </a:r>
+          </a:p>
+          <a:p>
+            <a:r>
+              <a:rPr lang="en-US" dirty="0" smtClean="0"/>
+              <a:t>Windows server environment</a:t>
+            </a:r>
+          </a:p>
+          <a:p>
+            <a:pPr lvl="1"/>
+            <a:r>
+              <a:rPr lang="en-US" dirty="0" smtClean="0"/>
+              <a:t>Portable to Azure</a:t>
+            </a:r>
+          </a:p>
+          <a:p>
+            <a:r>
+              <a:rPr lang="en-US" dirty="0" smtClean="0"/>
+              <a:t>SQL database</a:t>
+            </a:r>
+          </a:p>
+          <a:p>
+            <a:r>
+              <a:rPr lang="en-US" dirty="0" smtClean="0"/>
+              <a:t>Facilitates communication between clients</a:t>
+            </a:r>
+          </a:p>
+          <a:p>
+            <a:r>
+              <a:rPr lang="en-US" dirty="0" smtClean="0"/>
+              <a:t>Processes AI for virtual players</a:t>
+            </a:r>
+          </a:p>
+          <a:p>
+            <a:r>
+              <a:rPr lang="en-US" dirty="0" smtClean="0"/>
+              <a:t>Deploys game resources to client</a:t>
+            </a:r>
+          </a:p>
+          <a:p>
+            <a:r>
+              <a:rPr lang="en-US" dirty="0" smtClean="0"/>
+              <a:t>Manages logic for each multiplayer game instance</a:t>
+            </a:r>
+            <a:endParaRPr lang="en-US" dirty="0"/>
+          </a:p>
+        </p:txBody>
+      </p:sp>
+      <p:sp>
+        <p:nvSpPr>
+          <p:cNvPr id="2" name="Title 1"/>
+          <p:cNvSpPr>
+            <a:spLocks noGrp="1"/>
+          </p:cNvSpPr>
+          <p:nvPr>
+            <p:ph type="title"/>
+          </p:nvPr>
+        </p:nvSpPr>
+        <p:spPr/>
+        <p:txBody>
+          <a:bodyPr/>
+          <a:lstStyle/>
+          <a:p>
+            <a:r>
+              <a:rPr lang="en-US" dirty="0" smtClean="0"/>
+              <a:t>Design Analysis - Server</a:t>
+            </a:r>
+            <a:endParaRPr lang="en-US" dirty="0"/>
+          </a:p>
+        </p:txBody>
+      </p:sp>
+    </p:spTree>
+    <p:extLst>
+      <p:ext uri="{BB962C8B-B14F-4D97-AF65-F5344CB8AC3E}">
+        <p14:creationId xmlns:p14="http://schemas.microsoft.com/office/powerpoint/2010/main" val="3561777257"/>
+      </p:ext>
+    </p:extLst>
+  </p:cSld>
+  <p:clrMapOvr>
+    <a:masterClrMapping/>
+  </p:clrMapOvr>
+  <p:timing>
+    <p:tnLst>
+      <p:par>
+        <p:cTn id="1" dur="indefinite" restart="never" nodeType="tmRoot"/>
+      </p:par>
+    </p:tnLst>
+  </p:timing>
+</p:sld>
+</file>
+
+<file path=ppt/slides/slide8.xml><?xml version="1.0" encoding="utf-8"?>
+<p:sld xmlns:a="http://schemas.openxmlformats.org/drawingml/2006/main" xmlns:r="http://schemas.openxmlformats.org/officeDocument/2006/relationships" xmlns:p="http://schemas.openxmlformats.org/presentationml/2006/main">
+  <p:cSld>
+    <p:spTree>
+      <p:nvGrpSpPr>
+        <p:cNvPr id="1" name=""/>
+        <p:cNvGrpSpPr/>
+        <p:nvPr/>
+      </p:nvGrpSpPr>
+      <p:grpSpPr>
+        <a:xfrm>
+          <a:off x="0" y="0"/>
+          <a:ext cx="0" cy="0"/>
+          <a:chOff x="0" y="0"/>
+          <a:chExt cx="0" cy="0"/>
+        </a:xfrm>
+      </p:grpSpPr>
+      <p:pic>
+        <p:nvPicPr>
+          <p:cNvPr id="3" name="Content Placeholder 2"/>
+          <p:cNvPicPr>
+            <a:picLocks noGrp="1" noChangeAspect="1"/>
+          </p:cNvPicPr>
+          <p:nvPr>
+            <p:ph idx="1"/>
+          </p:nvPr>
+        </p:nvPicPr>
+        <p:blipFill>
+          <a:blip r:embed="rId3">
+            <a:extLst>
+              <a:ext uri="{28A0092B-C50C-407E-A947-70E740481C1C}">
+                <a14:useLocalDpi xmlns:a14="http://schemas.microsoft.com/office/drawing/2010/main" val="0"/>
+              </a:ext>
+            </a:extLst>
+          </a:blip>
+          <a:stretch>
+            <a:fillRect/>
+          </a:stretch>
+        </p:blipFill>
+        <p:spPr>
+          <a:xfrm>
+            <a:off x="1143000" y="1143000"/>
+            <a:ext cx="6934200" cy="5185501"/>
+          </a:xfrm>
+        </p:spPr>
+      </p:pic>
+      <p:sp>
+        <p:nvSpPr>
+          <p:cNvPr id="2" name="Title 1"/>
+          <p:cNvSpPr>
+            <a:spLocks noGrp="1"/>
+          </p:cNvSpPr>
+          <p:nvPr>
+            <p:ph type="title"/>
+          </p:nvPr>
+        </p:nvSpPr>
+        <p:spPr/>
+        <p:txBody>
+          <a:bodyPr/>
+          <a:lstStyle/>
+          <a:p>
+            <a:r>
+              <a:rPr lang="en-US" dirty="0" smtClean="0"/>
+              <a:t>Design Analysis - Server</a:t>
+            </a:r>
+            <a:endParaRPr lang="en-US" dirty="0"/>
+          </a:p>
+        </p:txBody>
+      </p:sp>
+    </p:spTree>
+    <p:extLst>
+      <p:ext uri="{BB962C8B-B14F-4D97-AF65-F5344CB8AC3E}">
+        <p14:creationId xmlns:p14="http://schemas.microsoft.com/office/powerpoint/2010/main" val="2750846494"/>
+      </p:ext>
+    </p:extLst>
+  </p:cSld>
+  <p:clrMapOvr>
+    <a:masterClrMapping/>
+  </p:clrMapOvr>
+  <p:timing>
+    <p:tnLst>
+      <p:par>
+        <p:cTn id="1" dur="indefinite" restart="never" nodeType="tmRoot"/>
+      </p:par>
+    </p:tnLst>
+  </p:timing>
+</p:sld>
+</file>
+
+<file path=ppt/slides/slide9.xml><?xml version="1.0" encoding="utf-8"?>
+<p:sld xmlns:a="http://schemas.openxmlformats.org/drawingml/2006/main" xmlns:r="http://schemas.openxmlformats.org/officeDocument/2006/relationships" xmlns:p="http://schemas.openxmlformats.org/presentationml/2006/main">
+  <p:cSld>
+    <p:spTree>
+      <p:nvGrpSpPr>
+        <p:cNvPr id="1" name=""/>
+        <p:cNvGrpSpPr/>
+        <p:nvPr/>
+      </p:nvGrpSpPr>
+      <p:grpSpPr>
+        <a:xfrm>
+          <a:off x="0" y="0"/>
+          <a:ext cx="0" cy="0"/>
+          <a:chOff x="0" y="0"/>
+          <a:chExt cx="0" cy="0"/>
+        </a:xfrm>
+      </p:grpSpPr>
+      <p:sp>
+        <p:nvSpPr>
+          <p:cNvPr id="7" name="Content Placeholder 6"/>
+          <p:cNvSpPr>
+            <a:spLocks noGrp="1"/>
+          </p:cNvSpPr>
+          <p:nvPr>
+            <p:ph idx="1"/>
+          </p:nvPr>
+        </p:nvSpPr>
+        <p:spPr>
+          <a:xfrm>
+            <a:off x="457200" y="1493837"/>
+            <a:ext cx="8229600" cy="4525963"/>
+          </a:xfrm>
+        </p:spPr>
+        <p:txBody>
+          <a:bodyPr>
+            <a:normAutofit lnSpcReduction="10000"/>
+          </a:bodyPr>
+          <a:lstStyle/>
+          <a:p>
+            <a:r>
+              <a:rPr lang="en-US" dirty="0" smtClean="0"/>
+              <a:t>Central server</a:t>
+            </a:r>
+          </a:p>
+          <a:p>
+            <a:pPr lvl="1"/>
+            <a:r>
+              <a:rPr lang="en-US" dirty="0" smtClean="0"/>
+              <a:t>Hosts game files</a:t>
+            </a:r>
+          </a:p>
+          <a:p>
+            <a:pPr lvl="1"/>
+            <a:r>
+              <a:rPr lang="en-US" dirty="0" smtClean="0"/>
+              <a:t>Connects  APMax units</a:t>
+            </a:r>
+          </a:p>
+          <a:p>
+            <a:r>
+              <a:rPr lang="en-US" dirty="0" smtClean="0"/>
+              <a:t>A.I. servers</a:t>
+            </a:r>
+          </a:p>
+          <a:p>
+            <a:pPr lvl="1"/>
+            <a:r>
+              <a:rPr lang="en-US" dirty="0" smtClean="0"/>
+              <a:t>Optional – If one server</a:t>
+            </a:r>
+            <a:br>
+              <a:rPr lang="en-US" dirty="0" smtClean="0"/>
+            </a:br>
+            <a:r>
+              <a:rPr lang="en-US" dirty="0" smtClean="0"/>
+              <a:t>can’t handle all game A.I.</a:t>
+            </a:r>
+          </a:p>
+          <a:p>
+            <a:r>
+              <a:rPr lang="en-US" dirty="0" smtClean="0"/>
+              <a:t>APMax</a:t>
+            </a:r>
+          </a:p>
+          <a:p>
+            <a:pPr lvl="1"/>
+            <a:r>
+              <a:rPr lang="en-US" dirty="0" smtClean="0"/>
+              <a:t>Middleware</a:t>
+            </a:r>
+          </a:p>
+          <a:p>
+            <a:pPr lvl="1"/>
+            <a:r>
+              <a:rPr lang="en-US" dirty="0" smtClean="0"/>
+              <a:t>Connects the server</a:t>
+            </a:r>
+            <a:br>
+              <a:rPr lang="en-US" dirty="0" smtClean="0"/>
+            </a:br>
+            <a:r>
+              <a:rPr lang="en-US" dirty="0" smtClean="0"/>
+              <a:t>to each STB</a:t>
+            </a:r>
+          </a:p>
+          <a:p>
+            <a:r>
+              <a:rPr lang="en-US" dirty="0" smtClean="0"/>
+              <a:t>Client</a:t>
+            </a:r>
+          </a:p>
+          <a:p>
+            <a:pPr lvl="1"/>
+            <a:r>
+              <a:rPr lang="en-US" dirty="0" smtClean="0"/>
+              <a:t>Set Top Box</a:t>
+            </a:r>
+          </a:p>
+        </p:txBody>
+      </p:sp>
       <p:sp>
         <p:nvSpPr>
           <p:cNvPr id="3" name="Title 2"/>
@@ -7426,109 +8380,6 @@
           </a:extLst>
         </p:spPr>
       </p:pic>
-      <p:sp>
-        <p:nvSpPr>
-          <p:cNvPr id="7" name="Content Placeholder 6"/>
-          <p:cNvSpPr>
-            <a:spLocks noGrp="1"/>
-          </p:cNvSpPr>
-          <p:nvPr>
-            <p:ph idx="1"/>
-          </p:nvPr>
-        </p:nvSpPr>
-        <p:spPr>
-          <a:xfrm>
-            <a:off x="457200" y="1493837"/>
-            <a:ext cx="8229600" cy="4525963"/>
-          </a:xfrm>
-        </p:spPr>
-        <p:txBody>
-          <a:bodyPr>
-            <a:normAutofit lnSpcReduction="10000"/>
-          </a:bodyPr>
-          <a:lstStyle/>
-          <a:p>
-            <a:r>
-              <a:rPr lang="en-US" dirty="0" smtClean="0"/>
-              <a:t>Central server</a:t>
-            </a:r>
-          </a:p>
-          <a:p>
-            <a:pPr lvl="1"/>
-            <a:r>
-              <a:rPr lang="en-US" dirty="0" smtClean="0"/>
-              <a:t>Hosts game files</a:t>
-            </a:r>
-          </a:p>
-          <a:p>
-            <a:pPr lvl="1"/>
-            <a:r>
-              <a:rPr lang="en-US" dirty="0" smtClean="0"/>
-              <a:t>Connects  APMax units</a:t>
-            </a:r>
-          </a:p>
-          <a:p>
-            <a:r>
-              <a:rPr lang="en-US" dirty="0" smtClean="0"/>
-              <a:t>A.I. servers</a:t>
-            </a:r>
-          </a:p>
-          <a:p>
-            <a:pPr lvl="1"/>
-            <a:r>
-              <a:rPr lang="en-US" dirty="0" smtClean="0"/>
-              <a:t>Optional – If one server</a:t>
-            </a:r>
-            <a:br>
-              <a:rPr lang="en-US" dirty="0" smtClean="0"/>
-            </a:br>
-            <a:r>
-              <a:rPr lang="en-US" dirty="0" smtClean="0"/>
-              <a:t>can’t handle all game A.I.</a:t>
-            </a:r>
-          </a:p>
-          <a:p>
-            <a:r>
-              <a:rPr lang="en-US" dirty="0" smtClean="0"/>
-              <a:t>APMax</a:t>
-            </a:r>
-          </a:p>
-          <a:p>
-            <a:pPr lvl="1"/>
-            <a:r>
-              <a:rPr lang="en-US" dirty="0" smtClean="0"/>
-              <a:t>Middleware</a:t>
-            </a:r>
-          </a:p>
-          <a:p>
-            <a:pPr lvl="1"/>
-            <a:r>
-              <a:rPr lang="en-US" dirty="0" smtClean="0"/>
-              <a:t>Connects the server</a:t>
-            </a:r>
-            <a:br>
-              <a:rPr lang="en-US" dirty="0" smtClean="0"/>
-            </a:br>
-            <a:r>
-              <a:rPr lang="en-US" dirty="0" smtClean="0"/>
-              <a:t>to each STB</a:t>
-            </a:r>
-          </a:p>
-          <a:p>
-            <a:r>
-              <a:rPr lang="en-US" dirty="0" smtClean="0"/>
-              <a:t>Client</a:t>
-            </a:r>
-          </a:p>
-          <a:p>
-            <a:pPr lvl="1"/>
-            <a:r>
-              <a:rPr lang="en-US" dirty="0" smtClean="0"/>
-              <a:t>Set Top Box</a:t>
-            </a:r>
-          </a:p>
-        </p:txBody>
-      </p:sp>
       <p:cxnSp>
         <p:nvCxnSpPr>
           <p:cNvPr id="6" name="Straight Connector 5"/>
@@ -7785,283 +8636,6 @@
     <p:extLst>
       <p:ext uri="{BB962C8B-B14F-4D97-AF65-F5344CB8AC3E}">
         <p14:creationId xmlns:p14="http://schemas.microsoft.com/office/powerpoint/2010/main" val="509599109"/>
-      </p:ext>
-    </p:extLst>
-  </p:cSld>
-  <p:clrMapOvr>
-    <a:masterClrMapping/>
-  </p:clrMapOvr>
-  <p:timing>
-    <p:tnLst>
-      <p:par>
-        <p:cTn id="1" dur="indefinite" restart="never" nodeType="tmRoot"/>
-      </p:par>
-    </p:tnLst>
-  </p:timing>
-</p:sld>
-</file>
-
-<file path=ppt/slides/slide8.xml><?xml version="1.0" encoding="utf-8"?>
-<p:sld xmlns:a="http://schemas.openxmlformats.org/drawingml/2006/main" xmlns:r="http://schemas.openxmlformats.org/officeDocument/2006/relationships" xmlns:p="http://schemas.openxmlformats.org/presentationml/2006/main">
-  <p:cSld>
-    <p:spTree>
-      <p:nvGrpSpPr>
-        <p:cNvPr id="1" name=""/>
-        <p:cNvGrpSpPr/>
-        <p:nvPr/>
-      </p:nvGrpSpPr>
-      <p:grpSpPr>
-        <a:xfrm>
-          <a:off x="0" y="0"/>
-          <a:ext cx="0" cy="0"/>
-          <a:chOff x="0" y="0"/>
-          <a:chExt cx="0" cy="0"/>
-        </a:xfrm>
-      </p:grpSpPr>
-      <p:sp>
-        <p:nvSpPr>
-          <p:cNvPr id="2" name="Content Placeholder 1"/>
-          <p:cNvSpPr>
-            <a:spLocks noGrp="1"/>
-          </p:cNvSpPr>
-          <p:nvPr>
-            <p:ph idx="1"/>
-          </p:nvPr>
-        </p:nvSpPr>
-        <p:spPr/>
-        <p:txBody>
-          <a:bodyPr/>
-          <a:lstStyle/>
-          <a:p>
-            <a:r>
-              <a:rPr lang="en-US" dirty="0" smtClean="0"/>
-              <a:t>Set Top Box</a:t>
-            </a:r>
-          </a:p>
-          <a:p>
-            <a:pPr lvl="1"/>
-            <a:r>
-              <a:rPr lang="en-US" dirty="0" smtClean="0"/>
-              <a:t>Low memory</a:t>
-            </a:r>
-          </a:p>
-          <a:p>
-            <a:pPr lvl="1"/>
-            <a:r>
-              <a:rPr lang="en-US" dirty="0" smtClean="0"/>
-              <a:t>Can’t use flash storage</a:t>
-            </a:r>
-          </a:p>
-          <a:p>
-            <a:pPr lvl="1"/>
-            <a:r>
-              <a:rPr lang="en-US" dirty="0" smtClean="0"/>
-              <a:t>Low powered processor</a:t>
-            </a:r>
-          </a:p>
-          <a:p>
-            <a:pPr lvl="1"/>
-            <a:r>
-              <a:rPr lang="en-US" dirty="0" smtClean="0"/>
-              <a:t>Limited bandwidth usage</a:t>
-            </a:r>
-          </a:p>
-          <a:p>
-            <a:r>
-              <a:rPr lang="en-US" dirty="0" smtClean="0"/>
-              <a:t>Server</a:t>
-            </a:r>
-          </a:p>
-          <a:p>
-            <a:pPr lvl="1"/>
-            <a:r>
-              <a:rPr lang="en-US" dirty="0" smtClean="0"/>
-              <a:t>Needs to be scalable to 100s or 1000s of users simultaneously connected</a:t>
-            </a:r>
-          </a:p>
-        </p:txBody>
-      </p:sp>
-      <p:sp>
-        <p:nvSpPr>
-          <p:cNvPr id="3" name="Title 2"/>
-          <p:cNvSpPr>
-            <a:spLocks noGrp="1"/>
-          </p:cNvSpPr>
-          <p:nvPr>
-            <p:ph type="title"/>
-          </p:nvPr>
-        </p:nvSpPr>
-        <p:spPr/>
-        <p:txBody>
-          <a:bodyPr>
-            <a:normAutofit/>
-          </a:bodyPr>
-          <a:lstStyle/>
-          <a:p>
-            <a:r>
-              <a:rPr lang="en-US" dirty="0" smtClean="0"/>
-              <a:t>Constraints</a:t>
-            </a:r>
-            <a:endParaRPr lang="en-US" dirty="0"/>
-          </a:p>
-        </p:txBody>
-      </p:sp>
-    </p:spTree>
-    <p:extLst>
-      <p:ext uri="{BB962C8B-B14F-4D97-AF65-F5344CB8AC3E}">
-        <p14:creationId xmlns:p14="http://schemas.microsoft.com/office/powerpoint/2010/main" val="2063007733"/>
-      </p:ext>
-    </p:extLst>
-  </p:cSld>
-  <p:clrMapOvr>
-    <a:masterClrMapping/>
-  </p:clrMapOvr>
-  <p:timing>
-    <p:tnLst>
-      <p:par>
-        <p:cTn id="1" dur="indefinite" restart="never" nodeType="tmRoot"/>
-      </p:par>
-    </p:tnLst>
-  </p:timing>
-</p:sld>
-</file>
-
-<file path=ppt/slides/slide9.xml><?xml version="1.0" encoding="utf-8"?>
-<p:sld xmlns:a="http://schemas.openxmlformats.org/drawingml/2006/main" xmlns:r="http://schemas.openxmlformats.org/officeDocument/2006/relationships" xmlns:p="http://schemas.openxmlformats.org/presentationml/2006/main">
-  <p:cSld>
-    <p:spTree>
-      <p:nvGrpSpPr>
-        <p:cNvPr id="1" name=""/>
-        <p:cNvGrpSpPr/>
-        <p:nvPr/>
-      </p:nvGrpSpPr>
-      <p:grpSpPr>
-        <a:xfrm>
-          <a:off x="0" y="0"/>
-          <a:ext cx="0" cy="0"/>
-          <a:chOff x="0" y="0"/>
-          <a:chExt cx="0" cy="0"/>
-        </a:xfrm>
-      </p:grpSpPr>
-      <p:sp>
-        <p:nvSpPr>
-          <p:cNvPr id="2" name="Content Placeholder 1"/>
-          <p:cNvSpPr>
-            <a:spLocks noGrp="1"/>
-          </p:cNvSpPr>
-          <p:nvPr>
-            <p:ph idx="1"/>
-          </p:nvPr>
-        </p:nvSpPr>
-        <p:spPr/>
-        <p:txBody>
-          <a:bodyPr/>
-          <a:lstStyle/>
-          <a:p>
-            <a:r>
-              <a:rPr lang="en-US" dirty="0" smtClean="0"/>
-              <a:t>STB firmware updates during development</a:t>
-            </a:r>
-          </a:p>
-          <a:p>
-            <a:pPr lvl="1"/>
-            <a:r>
-              <a:rPr lang="en-US" dirty="0" smtClean="0"/>
-              <a:t>Previous project</a:t>
-            </a:r>
-          </a:p>
-          <a:p>
-            <a:pPr lvl="1"/>
-            <a:r>
-              <a:rPr lang="en-US" dirty="0" smtClean="0"/>
-              <a:t>Should only affect UI engine on STB</a:t>
-            </a:r>
-          </a:p>
-          <a:p>
-            <a:pPr lvl="1"/>
-            <a:r>
-              <a:rPr lang="en-US" dirty="0" smtClean="0"/>
-              <a:t>Contingency Plan</a:t>
-            </a:r>
-          </a:p>
-          <a:p>
-            <a:pPr lvl="2"/>
-            <a:r>
-              <a:rPr lang="en-US" dirty="0" smtClean="0"/>
-              <a:t>Update the engine as soon as possible</a:t>
-            </a:r>
-          </a:p>
-          <a:p>
-            <a:r>
-              <a:rPr lang="en-US" dirty="0" smtClean="0"/>
-              <a:t>Changing the game development process</a:t>
-            </a:r>
-          </a:p>
-          <a:p>
-            <a:pPr lvl="1"/>
-            <a:r>
-              <a:rPr lang="en-US" dirty="0" smtClean="0"/>
-              <a:t>Could increase game development time</a:t>
-            </a:r>
-          </a:p>
-          <a:p>
-            <a:pPr lvl="1"/>
-            <a:r>
-              <a:rPr lang="en-US" dirty="0" smtClean="0"/>
-              <a:t>Might make debugging even more difficult</a:t>
-            </a:r>
-          </a:p>
-          <a:p>
-            <a:pPr lvl="1"/>
-            <a:r>
-              <a:rPr lang="en-US" dirty="0" smtClean="0"/>
-              <a:t>Contingency Plan</a:t>
-            </a:r>
-          </a:p>
-          <a:p>
-            <a:pPr lvl="2"/>
-            <a:r>
-              <a:rPr lang="en-US" dirty="0" smtClean="0"/>
-              <a:t>Build an error logger into the client engine</a:t>
-            </a:r>
-          </a:p>
-          <a:p>
-            <a:pPr lvl="2"/>
-            <a:r>
-              <a:rPr lang="en-US" dirty="0" smtClean="0"/>
-              <a:t>Send crash reports to the server</a:t>
-            </a:r>
-            <a:endParaRPr lang="en-US" dirty="0"/>
-          </a:p>
-        </p:txBody>
-      </p:sp>
-      <p:sp>
-        <p:nvSpPr>
-          <p:cNvPr id="3" name="Title 2"/>
-          <p:cNvSpPr>
-            <a:spLocks noGrp="1"/>
-          </p:cNvSpPr>
-          <p:nvPr>
-            <p:ph type="title"/>
-          </p:nvPr>
-        </p:nvSpPr>
-        <p:spPr/>
-        <p:txBody>
-          <a:bodyPr/>
-          <a:lstStyle/>
-          <a:p>
-            <a:r>
-              <a:rPr lang="en-US" dirty="0" smtClean="0"/>
-              <a:t>Risks</a:t>
-            </a:r>
-            <a:endParaRPr lang="en-US" dirty="0"/>
-          </a:p>
-        </p:txBody>
-      </p:sp>
-    </p:spTree>
-    <p:extLst>
-      <p:ext uri="{BB962C8B-B14F-4D97-AF65-F5344CB8AC3E}">
-        <p14:creationId xmlns:p14="http://schemas.microsoft.com/office/powerpoint/2010/main" val="1092627084"/>
       </p:ext>
     </p:extLst>
   </p:cSld>

</xml_diff>

<commit_message>
Updated slides with testing
Also added assement form form Dr. McGough
</commit_message>
<xml_diff>
--- a/Sprint1_Documents/Sprint 1 Review.pptx
+++ b/Sprint1_Documents/Sprint 1 Review.pptx
@@ -5,7 +5,7 @@
     <p:sldMasterId id="2147483672" r:id="rId1"/>
   </p:sldMasterIdLst>
   <p:notesMasterIdLst>
-    <p:notesMasterId r:id="rId17"/>
+    <p:notesMasterId r:id="rId18"/>
   </p:notesMasterIdLst>
   <p:sldIdLst>
     <p:sldId id="256" r:id="rId2"/>
@@ -18,11 +18,12 @@
     <p:sldId id="260" r:id="rId9"/>
     <p:sldId id="271" r:id="rId10"/>
     <p:sldId id="262" r:id="rId11"/>
-    <p:sldId id="263" r:id="rId12"/>
-    <p:sldId id="264" r:id="rId13"/>
-    <p:sldId id="268" r:id="rId14"/>
-    <p:sldId id="269" r:id="rId15"/>
-    <p:sldId id="267" r:id="rId16"/>
+    <p:sldId id="273" r:id="rId12"/>
+    <p:sldId id="263" r:id="rId13"/>
+    <p:sldId id="264" r:id="rId14"/>
+    <p:sldId id="268" r:id="rId15"/>
+    <p:sldId id="269" r:id="rId16"/>
+    <p:sldId id="267" r:id="rId17"/>
   </p:sldIdLst>
   <p:sldSz cx="9144000" cy="6858000" type="screen4x3"/>
   <p:notesSz cx="6858000" cy="9144000"/>
@@ -619,22 +620,8 @@
           <a:lstStyle/>
           <a:p>
             <a:r>
-              <a:rPr lang="en-US" sz="1200" b="0" i="0" kern="1200" dirty="0" smtClean="0">
-                <a:solidFill>
-                  <a:schemeClr val="tx1"/>
-                </a:solidFill>
-                <a:effectLst/>
-                <a:latin typeface="+mn-lt"/>
-                <a:ea typeface="+mn-ea"/>
-                <a:cs typeface="+mn-cs"/>
-              </a:rPr>
-              <a:t>Risks, risk analysis, mitigation and contingency plan  (2 min)</a:t>
-            </a:r>
-          </a:p>
-          <a:p>
-            <a:r>
-              <a:rPr lang="en-US" dirty="0" smtClean="0"/>
-              <a:t>David</a:t>
+              <a:rPr lang="en-US" dirty="0" smtClean="0"/>
+              <a:t>Marshall + Kevin</a:t>
             </a:r>
             <a:endParaRPr lang="en-US" dirty="0"/>
           </a:p>
@@ -666,7 +653,7 @@
     </p:spTree>
     <p:extLst>
       <p:ext uri="{BB962C8B-B14F-4D97-AF65-F5344CB8AC3E}">
-        <p14:creationId xmlns:p14="http://schemas.microsoft.com/office/powerpoint/2010/main" val="1966491216"/>
+        <p14:creationId xmlns:p14="http://schemas.microsoft.com/office/powerpoint/2010/main" val="2086731328"/>
       </p:ext>
     </p:extLst>
   </p:cSld>
@@ -720,6 +707,24 @@
           <a:bodyPr/>
           <a:lstStyle/>
           <a:p>
+            <a:r>
+              <a:rPr lang="en-US" sz="1200" b="0" i="0" kern="1200" dirty="0" smtClean="0">
+                <a:solidFill>
+                  <a:schemeClr val="tx1"/>
+                </a:solidFill>
+                <a:effectLst/>
+                <a:latin typeface="+mn-lt"/>
+                <a:ea typeface="+mn-ea"/>
+                <a:cs typeface="+mn-cs"/>
+              </a:rPr>
+              <a:t>Risks, risk analysis, mitigation and contingency plan  (2 min)</a:t>
+            </a:r>
+          </a:p>
+          <a:p>
+            <a:r>
+              <a:rPr lang="en-US" dirty="0" smtClean="0"/>
+              <a:t>David</a:t>
+            </a:r>
             <a:endParaRPr lang="en-US" dirty="0"/>
           </a:p>
         </p:txBody>
@@ -750,7 +755,7 @@
     </p:spTree>
     <p:extLst>
       <p:ext uri="{BB962C8B-B14F-4D97-AF65-F5344CB8AC3E}">
-        <p14:creationId xmlns:p14="http://schemas.microsoft.com/office/powerpoint/2010/main" val="3059345779"/>
+        <p14:creationId xmlns:p14="http://schemas.microsoft.com/office/powerpoint/2010/main" val="1966491216"/>
       </p:ext>
     </p:extLst>
   </p:cSld>
@@ -804,14 +809,6 @@
           <a:bodyPr/>
           <a:lstStyle/>
           <a:p>
-            <a:r>
-              <a:rPr lang="en-US" dirty="0" smtClean="0"/>
-              <a:t>Quickly</a:t>
-            </a:r>
-            <a:r>
-              <a:rPr lang="en-US" baseline="0" dirty="0" smtClean="0"/>
-              <a:t> show that we have a backlog, no need to go into great detail here</a:t>
-            </a:r>
             <a:endParaRPr lang="en-US" dirty="0"/>
           </a:p>
         </p:txBody>
@@ -842,7 +839,7 @@
     </p:spTree>
     <p:extLst>
       <p:ext uri="{BB962C8B-B14F-4D97-AF65-F5344CB8AC3E}">
-        <p14:creationId xmlns:p14="http://schemas.microsoft.com/office/powerpoint/2010/main" val="542630260"/>
+        <p14:creationId xmlns:p14="http://schemas.microsoft.com/office/powerpoint/2010/main" val="3059345779"/>
       </p:ext>
     </p:extLst>
   </p:cSld>
@@ -897,6 +894,98 @@
           <a:lstStyle/>
           <a:p>
             <a:r>
+              <a:rPr lang="en-US" dirty="0" smtClean="0"/>
+              <a:t>Quickly</a:t>
+            </a:r>
+            <a:r>
+              <a:rPr lang="en-US" baseline="0" dirty="0" smtClean="0"/>
+              <a:t> show that we have a backlog, no need to go into great detail here</a:t>
+            </a:r>
+            <a:endParaRPr lang="en-US" dirty="0"/>
+          </a:p>
+        </p:txBody>
+      </p:sp>
+      <p:sp>
+        <p:nvSpPr>
+          <p:cNvPr id="4" name="Slide Number Placeholder 3"/>
+          <p:cNvSpPr>
+            <a:spLocks noGrp="1"/>
+          </p:cNvSpPr>
+          <p:nvPr>
+            <p:ph type="sldNum" sz="quarter" idx="10"/>
+          </p:nvPr>
+        </p:nvSpPr>
+        <p:spPr/>
+        <p:txBody>
+          <a:bodyPr/>
+          <a:lstStyle/>
+          <a:p>
+            <a:fld id="{2196A064-7C2B-4BD1-B717-284E7E6AAF69}" type="slidenum">
+              <a:rPr lang="en-US" smtClean="0"/>
+              <a:t>15</a:t>
+            </a:fld>
+            <a:endParaRPr lang="en-US"/>
+          </a:p>
+        </p:txBody>
+      </p:sp>
+    </p:spTree>
+    <p:extLst>
+      <p:ext uri="{BB962C8B-B14F-4D97-AF65-F5344CB8AC3E}">
+        <p14:creationId xmlns:p14="http://schemas.microsoft.com/office/powerpoint/2010/main" val="542630260"/>
+      </p:ext>
+    </p:extLst>
+  </p:cSld>
+  <p:clrMapOvr>
+    <a:masterClrMapping/>
+  </p:clrMapOvr>
+</p:notes>
+</file>
+
+<file path=ppt/notesSlides/notesSlide14.xml><?xml version="1.0" encoding="utf-8"?>
+<p:notes xmlns:a="http://schemas.openxmlformats.org/drawingml/2006/main" xmlns:r="http://schemas.openxmlformats.org/officeDocument/2006/relationships" xmlns:p="http://schemas.openxmlformats.org/presentationml/2006/main">
+  <p:cSld>
+    <p:spTree>
+      <p:nvGrpSpPr>
+        <p:cNvPr id="1" name=""/>
+        <p:cNvGrpSpPr/>
+        <p:nvPr/>
+      </p:nvGrpSpPr>
+      <p:grpSpPr>
+        <a:xfrm>
+          <a:off x="0" y="0"/>
+          <a:ext cx="0" cy="0"/>
+          <a:chOff x="0" y="0"/>
+          <a:chExt cx="0" cy="0"/>
+        </a:xfrm>
+      </p:grpSpPr>
+      <p:sp>
+        <p:nvSpPr>
+          <p:cNvPr id="2" name="Slide Image Placeholder 1"/>
+          <p:cNvSpPr>
+            <a:spLocks noGrp="1" noRot="1" noChangeAspect="1"/>
+          </p:cNvSpPr>
+          <p:nvPr>
+            <p:ph type="sldImg"/>
+          </p:nvPr>
+        </p:nvSpPr>
+        <p:spPr/>
+      </p:sp>
+      <p:sp>
+        <p:nvSpPr>
+          <p:cNvPr id="3" name="Notes Placeholder 2"/>
+          <p:cNvSpPr>
+            <a:spLocks noGrp="1"/>
+          </p:cNvSpPr>
+          <p:nvPr>
+            <p:ph type="body" idx="1"/>
+          </p:nvPr>
+        </p:nvSpPr>
+        <p:spPr/>
+        <p:txBody>
+          <a:bodyPr/>
+          <a:lstStyle/>
+          <a:p>
+            <a:r>
               <a:rPr lang="en-US" sz="1200" b="0" i="0" kern="1200" dirty="0" smtClean="0">
                 <a:solidFill>
                   <a:schemeClr val="tx1"/>
@@ -979,7 +1068,7 @@
           <a:p>
             <a:fld id="{2196A064-7C2B-4BD1-B717-284E7E6AAF69}" type="slidenum">
               <a:rPr lang="en-US" smtClean="0"/>
-              <a:t>15</a:t>
+              <a:t>16</a:t>
             </a:fld>
             <a:endParaRPr lang="en-US"/>
           </a:p>
@@ -1717,8 +1806,8 @@
           <a:lstStyle/>
           <a:p>
             <a:r>
-              <a:rPr lang="en-US" dirty="0" smtClean="0"/>
-              <a:t>Marshall + Kevin</a:t>
+              <a:rPr lang="en-US" smtClean="0"/>
+              <a:t>Kevin</a:t>
             </a:r>
             <a:endParaRPr lang="en-US" dirty="0"/>
           </a:p>
@@ -1750,7 +1839,7 @@
     </p:spTree>
     <p:extLst>
       <p:ext uri="{BB962C8B-B14F-4D97-AF65-F5344CB8AC3E}">
-        <p14:creationId xmlns:p14="http://schemas.microsoft.com/office/powerpoint/2010/main" val="2086731328"/>
+        <p14:creationId xmlns:p14="http://schemas.microsoft.com/office/powerpoint/2010/main" val="444776262"/>
       </p:ext>
     </p:extLst>
   </p:cSld>
@@ -6850,48 +6939,34 @@
           <a:p>
             <a:r>
               <a:rPr lang="en-US" dirty="0" smtClean="0"/>
-              <a:t>Set Top Box</a:t>
+              <a:t>Full unit testing</a:t>
             </a:r>
           </a:p>
           <a:p>
             <a:pPr lvl="1"/>
             <a:r>
               <a:rPr lang="en-US" dirty="0" smtClean="0"/>
-              <a:t>Low memory</a:t>
+              <a:t>Testing Server and STB code</a:t>
+            </a:r>
+          </a:p>
+          <a:p>
+            <a:r>
+              <a:rPr lang="en-US" dirty="0" smtClean="0"/>
+              <a:t>Create a virtual APMax</a:t>
             </a:r>
           </a:p>
           <a:p>
             <a:pPr lvl="1"/>
             <a:r>
               <a:rPr lang="en-US" dirty="0" smtClean="0"/>
-              <a:t>Can’t use flash storage</a:t>
+              <a:t>Used to simulate communication between STB and server</a:t>
             </a:r>
           </a:p>
           <a:p>
             <a:pPr lvl="1"/>
             <a:r>
               <a:rPr lang="en-US" dirty="0" smtClean="0"/>
-              <a:t>Low powered processor</a:t>
-            </a:r>
-          </a:p>
-          <a:p>
-            <a:pPr lvl="1"/>
-            <a:r>
-              <a:rPr lang="en-US" dirty="0" smtClean="0"/>
-              <a:t>Limited bandwidth usage</a:t>
-            </a:r>
-          </a:p>
-          <a:p>
-            <a:r>
-              <a:rPr lang="en-US" dirty="0" smtClean="0"/>
-              <a:t>Server</a:t>
-            </a:r>
-          </a:p>
-          <a:p>
-            <a:pPr lvl="1"/>
-            <a:r>
-              <a:rPr lang="en-US" dirty="0" smtClean="0"/>
-              <a:t>Needs to be scalable to 100s or 1000s of users simultaneously connected</a:t>
+              <a:t>Test new CommandLink messages before going into production</a:t>
             </a:r>
           </a:p>
         </p:txBody>
@@ -6908,14 +6983,12 @@
         </p:nvSpPr>
         <p:spPr/>
         <p:txBody>
-          <a:bodyPr>
-            <a:normAutofit/>
-          </a:bodyPr>
+          <a:bodyPr/>
           <a:lstStyle/>
           <a:p>
             <a:r>
               <a:rPr lang="en-US" dirty="0" smtClean="0"/>
-              <a:t>Constraints</a:t>
+              <a:t>Testing</a:t>
             </a:r>
             <a:endParaRPr lang="en-US" dirty="0"/>
           </a:p>
@@ -6924,7 +6997,7 @@
     </p:spTree>
     <p:extLst>
       <p:ext uri="{BB962C8B-B14F-4D97-AF65-F5344CB8AC3E}">
-        <p14:creationId xmlns:p14="http://schemas.microsoft.com/office/powerpoint/2010/main" val="2063007733"/>
+        <p14:creationId xmlns:p14="http://schemas.microsoft.com/office/powerpoint/2010/main" val="159684043"/>
       </p:ext>
     </p:extLst>
   </p:cSld>
@@ -6970,113 +7043,77 @@
         </p:nvSpPr>
         <p:spPr/>
         <p:txBody>
+          <a:bodyPr/>
+          <a:lstStyle/>
+          <a:p>
+            <a:r>
+              <a:rPr lang="en-US" dirty="0" smtClean="0"/>
+              <a:t>Set Top Box</a:t>
+            </a:r>
+          </a:p>
+          <a:p>
+            <a:pPr lvl="1"/>
+            <a:r>
+              <a:rPr lang="en-US" dirty="0" smtClean="0"/>
+              <a:t>Low memory</a:t>
+            </a:r>
+          </a:p>
+          <a:p>
+            <a:pPr lvl="1"/>
+            <a:r>
+              <a:rPr lang="en-US" dirty="0" smtClean="0"/>
+              <a:t>Can’t use flash storage</a:t>
+            </a:r>
+          </a:p>
+          <a:p>
+            <a:pPr lvl="1"/>
+            <a:r>
+              <a:rPr lang="en-US" dirty="0" smtClean="0"/>
+              <a:t>Low powered processor</a:t>
+            </a:r>
+          </a:p>
+          <a:p>
+            <a:pPr lvl="1"/>
+            <a:r>
+              <a:rPr lang="en-US" dirty="0" smtClean="0"/>
+              <a:t>Limited bandwidth usage</a:t>
+            </a:r>
+          </a:p>
+          <a:p>
+            <a:r>
+              <a:rPr lang="en-US" dirty="0" smtClean="0"/>
+              <a:t>Server</a:t>
+            </a:r>
+          </a:p>
+          <a:p>
+            <a:pPr lvl="1"/>
+            <a:r>
+              <a:rPr lang="en-US" dirty="0" smtClean="0"/>
+              <a:t>Needs to be scalable to 100s or 1000s of users simultaneously connected</a:t>
+            </a:r>
+          </a:p>
+        </p:txBody>
+      </p:sp>
+      <p:sp>
+        <p:nvSpPr>
+          <p:cNvPr id="3" name="Title 2"/>
+          <p:cNvSpPr>
+            <a:spLocks noGrp="1"/>
+          </p:cNvSpPr>
+          <p:nvPr>
+            <p:ph type="title"/>
+          </p:nvPr>
+        </p:nvSpPr>
+        <p:spPr/>
+        <p:txBody>
           <a:bodyPr>
-            <a:normAutofit lnSpcReduction="10000"/>
+            <a:normAutofit/>
           </a:bodyPr>
           <a:lstStyle/>
           <a:p>
             <a:r>
               <a:rPr lang="en-US" dirty="0" smtClean="0"/>
-              <a:t>STB firmware updates during development</a:t>
-            </a:r>
-          </a:p>
-          <a:p>
-            <a:pPr lvl="1"/>
-            <a:r>
-              <a:rPr lang="en-US" dirty="0" smtClean="0"/>
-              <a:t>Previous project</a:t>
-            </a:r>
-          </a:p>
-          <a:p>
-            <a:pPr lvl="1"/>
-            <a:r>
-              <a:rPr lang="en-US" dirty="0" smtClean="0"/>
-              <a:t>Should only affect UI engine on STB</a:t>
-            </a:r>
-          </a:p>
-          <a:p>
-            <a:pPr lvl="1"/>
-            <a:r>
-              <a:rPr lang="en-US" dirty="0" smtClean="0"/>
-              <a:t>Contingency Plan</a:t>
-            </a:r>
-          </a:p>
-          <a:p>
-            <a:pPr lvl="2"/>
-            <a:r>
-              <a:rPr lang="en-US" dirty="0" smtClean="0"/>
-              <a:t>Update the engine as soon as possible</a:t>
-            </a:r>
-          </a:p>
-          <a:p>
-            <a:r>
-              <a:rPr lang="en-US" dirty="0" smtClean="0"/>
-              <a:t>Changing the game development process</a:t>
-            </a:r>
-          </a:p>
-          <a:p>
-            <a:pPr lvl="1"/>
-            <a:r>
-              <a:rPr lang="en-US" dirty="0" smtClean="0"/>
-              <a:t>Could increase game development time</a:t>
-            </a:r>
-          </a:p>
-          <a:p>
-            <a:pPr lvl="1"/>
-            <a:r>
-              <a:rPr lang="en-US" dirty="0" smtClean="0"/>
-              <a:t>Might make debugging even more difficult</a:t>
-            </a:r>
-          </a:p>
-          <a:p>
-            <a:pPr lvl="1"/>
-            <a:r>
-              <a:rPr lang="en-US" dirty="0" smtClean="0"/>
-              <a:t>Contingency Plan</a:t>
-            </a:r>
-          </a:p>
-          <a:p>
-            <a:pPr lvl="2"/>
-            <a:r>
-              <a:rPr lang="en-US" dirty="0" smtClean="0"/>
-              <a:t>Build an error logger into the client engine</a:t>
-            </a:r>
-          </a:p>
-          <a:p>
-            <a:pPr lvl="2"/>
-            <a:r>
-              <a:rPr lang="en-US" dirty="0" smtClean="0"/>
-              <a:t>Send crash reports to the server</a:t>
-            </a:r>
-          </a:p>
-          <a:p>
-            <a:pPr lvl="2"/>
-            <a:r>
-              <a:rPr lang="en-US" dirty="0" smtClean="0"/>
-              <a:t>Port existing games to new model</a:t>
-            </a:r>
-            <a:endParaRPr lang="en-US" dirty="0"/>
-          </a:p>
-        </p:txBody>
-      </p:sp>
-      <p:sp>
-        <p:nvSpPr>
-          <p:cNvPr id="3" name="Title 2"/>
-          <p:cNvSpPr>
-            <a:spLocks noGrp="1"/>
-          </p:cNvSpPr>
-          <p:nvPr>
-            <p:ph type="title"/>
-          </p:nvPr>
-        </p:nvSpPr>
-        <p:spPr/>
-        <p:txBody>
-          <a:bodyPr/>
-          <a:lstStyle/>
-          <a:p>
-            <a:r>
-              <a:rPr lang="en-US" dirty="0" smtClean="0"/>
-              <a:t>Risks</a:t>
+              <a:t>Constraints</a:t>
             </a:r>
             <a:endParaRPr lang="en-US" dirty="0"/>
           </a:p>
@@ -7085,7 +7122,7 @@
     </p:spTree>
     <p:extLst>
       <p:ext uri="{BB962C8B-B14F-4D97-AF65-F5344CB8AC3E}">
-        <p14:creationId xmlns:p14="http://schemas.microsoft.com/office/powerpoint/2010/main" val="1092627084"/>
+        <p14:creationId xmlns:p14="http://schemas.microsoft.com/office/powerpoint/2010/main" val="2063007733"/>
       </p:ext>
     </p:extLst>
   </p:cSld>
@@ -7138,121 +7175,85 @@
           <a:p>
             <a:r>
               <a:rPr lang="en-US" dirty="0" smtClean="0"/>
-              <a:t>Sprint 1: </a:t>
-            </a:r>
-            <a:r>
-              <a:rPr lang="en-US" sz="2400" dirty="0" smtClean="0"/>
-              <a:t>September 19</a:t>
-            </a:r>
-            <a:r>
-              <a:rPr lang="en-US" sz="2400" baseline="30000" dirty="0" smtClean="0"/>
-              <a:t>th</a:t>
-            </a:r>
-            <a:r>
-              <a:rPr lang="en-US" sz="2400" dirty="0" smtClean="0"/>
-              <a:t> – October 3</a:t>
-            </a:r>
-            <a:r>
-              <a:rPr lang="en-US" sz="2400" baseline="30000" dirty="0" smtClean="0"/>
-              <a:t>rd</a:t>
-            </a:r>
-            <a:endParaRPr lang="en-US" sz="2400" dirty="0" smtClean="0"/>
+              <a:t>STB firmware updates during development</a:t>
+            </a:r>
           </a:p>
           <a:p>
             <a:pPr lvl="1"/>
             <a:r>
               <a:rPr lang="en-US" dirty="0" smtClean="0"/>
-              <a:t>Deliverables</a:t>
+              <a:t>Previous project</a:t>
+            </a:r>
+          </a:p>
+          <a:p>
+            <a:pPr lvl="1"/>
+            <a:r>
+              <a:rPr lang="en-US" dirty="0" smtClean="0"/>
+              <a:t>Should only affect UI engine on STB</a:t>
+            </a:r>
+          </a:p>
+          <a:p>
+            <a:pPr lvl="1"/>
+            <a:r>
+              <a:rPr lang="en-US" dirty="0" smtClean="0"/>
+              <a:t>Contingency Plan</a:t>
             </a:r>
           </a:p>
           <a:p>
             <a:pPr lvl="2"/>
             <a:r>
               <a:rPr lang="en-US" dirty="0" smtClean="0"/>
-              <a:t>Initial design document</a:t>
+              <a:t>Update the engine as soon as possible</a:t>
+            </a:r>
+          </a:p>
+          <a:p>
+            <a:r>
+              <a:rPr lang="en-US" dirty="0" smtClean="0"/>
+              <a:t>Changing the game development process</a:t>
+            </a:r>
+          </a:p>
+          <a:p>
+            <a:pPr lvl="1"/>
+            <a:r>
+              <a:rPr lang="en-US" dirty="0" smtClean="0"/>
+              <a:t>Could increase game development time</a:t>
+            </a:r>
+          </a:p>
+          <a:p>
+            <a:pPr lvl="1"/>
+            <a:r>
+              <a:rPr lang="en-US" dirty="0" smtClean="0"/>
+              <a:t>Might make debugging even more difficult</a:t>
+            </a:r>
+          </a:p>
+          <a:p>
+            <a:pPr lvl="1"/>
+            <a:r>
+              <a:rPr lang="en-US" dirty="0" smtClean="0"/>
+              <a:t>Contingency Plan</a:t>
             </a:r>
           </a:p>
           <a:p>
             <a:pPr lvl="2"/>
             <a:r>
               <a:rPr lang="en-US" dirty="0" smtClean="0"/>
-              <a:t>Initial requirements document</a:t>
-            </a:r>
-          </a:p>
-          <a:p>
-            <a:pPr lvl="1"/>
-            <a:r>
-              <a:rPr lang="en-US" dirty="0" smtClean="0"/>
-              <a:t>Environment: Setup and Testing</a:t>
+              <a:t>Build an error logger into the client engine</a:t>
             </a:r>
           </a:p>
           <a:p>
             <a:pPr lvl="2"/>
             <a:r>
               <a:rPr lang="en-US" dirty="0" smtClean="0"/>
-              <a:t>Meeting with STB team from Mitchell</a:t>
+              <a:t>Send crash reports to the server</a:t>
             </a:r>
           </a:p>
           <a:p>
             <a:pPr lvl="2"/>
             <a:r>
               <a:rPr lang="en-US" dirty="0" smtClean="0"/>
-              <a:t>Information exchange</a:t>
-            </a:r>
-          </a:p>
-          <a:p>
-            <a:pPr lvl="1"/>
-            <a:r>
-              <a:rPr lang="en-US" dirty="0" smtClean="0"/>
-              <a:t>Research</a:t>
-            </a:r>
-          </a:p>
-          <a:p>
-            <a:pPr lvl="2"/>
-            <a:r>
-              <a:rPr lang="en-US" dirty="0" smtClean="0"/>
-              <a:t>Dynamically load views on STB</a:t>
-            </a:r>
-          </a:p>
-          <a:p>
-            <a:pPr lvl="2"/>
-            <a:r>
-              <a:rPr lang="en-US" dirty="0" smtClean="0"/>
-              <a:t>Sending game state using Protocol Buffers</a:t>
-            </a:r>
-          </a:p>
-          <a:p>
-            <a:r>
-              <a:rPr lang="en-US" dirty="0" smtClean="0"/>
-              <a:t>Sprint 2: </a:t>
-            </a:r>
-            <a:r>
-              <a:rPr lang="en-US" sz="2400" dirty="0" smtClean="0"/>
-              <a:t>October 10</a:t>
-            </a:r>
-            <a:r>
-              <a:rPr lang="en-US" sz="2400" baseline="30000" dirty="0" smtClean="0"/>
-              <a:t>th</a:t>
-            </a:r>
-            <a:r>
-              <a:rPr lang="en-US" sz="2400" dirty="0" smtClean="0"/>
-              <a:t> – October 31</a:t>
-            </a:r>
-            <a:r>
-              <a:rPr lang="en-US" sz="2400" baseline="30000" dirty="0" smtClean="0"/>
-              <a:t>st</a:t>
-            </a:r>
-            <a:r>
-              <a:rPr lang="en-US" sz="2400" dirty="0" smtClean="0"/>
-              <a:t> </a:t>
-            </a:r>
-          </a:p>
-          <a:p>
-            <a:pPr lvl="1"/>
-            <a:r>
-              <a:rPr lang="en-US" dirty="0" smtClean="0"/>
-              <a:t>Begin development</a:t>
-            </a:r>
+              <a:t>Port existing games to new model</a:t>
+            </a:r>
+            <a:endParaRPr lang="en-US" dirty="0"/>
           </a:p>
         </p:txBody>
       </p:sp>
@@ -7273,7 +7274,7 @@
           <a:p>
             <a:r>
               <a:rPr lang="en-US" dirty="0" smtClean="0"/>
-              <a:t>Sprints</a:t>
+              <a:t>Risks</a:t>
             </a:r>
             <a:endParaRPr lang="en-US" dirty="0"/>
           </a:p>
@@ -7282,7 +7283,7 @@
     </p:spTree>
     <p:extLst>
       <p:ext uri="{BB962C8B-B14F-4D97-AF65-F5344CB8AC3E}">
-        <p14:creationId xmlns:p14="http://schemas.microsoft.com/office/powerpoint/2010/main" val="1446175581"/>
+        <p14:creationId xmlns:p14="http://schemas.microsoft.com/office/powerpoint/2010/main" val="1092627084"/>
       </p:ext>
     </p:extLst>
   </p:cSld>
@@ -7329,6 +7330,203 @@
         <p:spPr/>
         <p:txBody>
           <a:bodyPr>
+            <a:normAutofit lnSpcReduction="10000"/>
+          </a:bodyPr>
+          <a:lstStyle/>
+          <a:p>
+            <a:r>
+              <a:rPr lang="en-US" dirty="0" smtClean="0"/>
+              <a:t>Sprint 1: </a:t>
+            </a:r>
+            <a:r>
+              <a:rPr lang="en-US" sz="2400" dirty="0" smtClean="0"/>
+              <a:t>September 19</a:t>
+            </a:r>
+            <a:r>
+              <a:rPr lang="en-US" sz="2400" baseline="30000" dirty="0" smtClean="0"/>
+              <a:t>th</a:t>
+            </a:r>
+            <a:r>
+              <a:rPr lang="en-US" sz="2400" dirty="0" smtClean="0"/>
+              <a:t> – October 3</a:t>
+            </a:r>
+            <a:r>
+              <a:rPr lang="en-US" sz="2400" baseline="30000" dirty="0" smtClean="0"/>
+              <a:t>rd</a:t>
+            </a:r>
+            <a:endParaRPr lang="en-US" sz="2400" dirty="0" smtClean="0"/>
+          </a:p>
+          <a:p>
+            <a:pPr lvl="1"/>
+            <a:r>
+              <a:rPr lang="en-US" dirty="0" smtClean="0"/>
+              <a:t>Deliverables</a:t>
+            </a:r>
+          </a:p>
+          <a:p>
+            <a:pPr lvl="2"/>
+            <a:r>
+              <a:rPr lang="en-US" dirty="0" smtClean="0"/>
+              <a:t>Initial design document</a:t>
+            </a:r>
+          </a:p>
+          <a:p>
+            <a:pPr lvl="2"/>
+            <a:r>
+              <a:rPr lang="en-US" dirty="0" smtClean="0"/>
+              <a:t>Initial requirements document</a:t>
+            </a:r>
+          </a:p>
+          <a:p>
+            <a:pPr lvl="1"/>
+            <a:r>
+              <a:rPr lang="en-US" dirty="0" smtClean="0"/>
+              <a:t>Environment: Setup and Testing</a:t>
+            </a:r>
+          </a:p>
+          <a:p>
+            <a:pPr lvl="2"/>
+            <a:r>
+              <a:rPr lang="en-US" dirty="0" smtClean="0"/>
+              <a:t>Meeting with STB team from Mitchell</a:t>
+            </a:r>
+          </a:p>
+          <a:p>
+            <a:pPr lvl="2"/>
+            <a:r>
+              <a:rPr lang="en-US" dirty="0" smtClean="0"/>
+              <a:t>Information exchange</a:t>
+            </a:r>
+          </a:p>
+          <a:p>
+            <a:pPr lvl="1"/>
+            <a:r>
+              <a:rPr lang="en-US" dirty="0" smtClean="0"/>
+              <a:t>Research</a:t>
+            </a:r>
+          </a:p>
+          <a:p>
+            <a:pPr lvl="2"/>
+            <a:r>
+              <a:rPr lang="en-US" dirty="0" smtClean="0"/>
+              <a:t>Dynamically load views on STB</a:t>
+            </a:r>
+          </a:p>
+          <a:p>
+            <a:pPr lvl="2"/>
+            <a:r>
+              <a:rPr lang="en-US" dirty="0" smtClean="0"/>
+              <a:t>Sending game state using Protocol Buffers</a:t>
+            </a:r>
+          </a:p>
+          <a:p>
+            <a:r>
+              <a:rPr lang="en-US" dirty="0" smtClean="0"/>
+              <a:t>Sprint 2: </a:t>
+            </a:r>
+            <a:r>
+              <a:rPr lang="en-US" sz="2400" dirty="0" smtClean="0"/>
+              <a:t>October 10</a:t>
+            </a:r>
+            <a:r>
+              <a:rPr lang="en-US" sz="2400" baseline="30000" dirty="0" smtClean="0"/>
+              <a:t>th</a:t>
+            </a:r>
+            <a:r>
+              <a:rPr lang="en-US" sz="2400" dirty="0" smtClean="0"/>
+              <a:t> – October 31</a:t>
+            </a:r>
+            <a:r>
+              <a:rPr lang="en-US" sz="2400" baseline="30000" dirty="0" smtClean="0"/>
+              <a:t>st</a:t>
+            </a:r>
+            <a:r>
+              <a:rPr lang="en-US" sz="2400" dirty="0" smtClean="0"/>
+              <a:t> </a:t>
+            </a:r>
+          </a:p>
+          <a:p>
+            <a:pPr lvl="1"/>
+            <a:r>
+              <a:rPr lang="en-US" dirty="0" smtClean="0"/>
+              <a:t>Begin development</a:t>
+            </a:r>
+          </a:p>
+        </p:txBody>
+      </p:sp>
+      <p:sp>
+        <p:nvSpPr>
+          <p:cNvPr id="3" name="Title 2"/>
+          <p:cNvSpPr>
+            <a:spLocks noGrp="1"/>
+          </p:cNvSpPr>
+          <p:nvPr>
+            <p:ph type="title"/>
+          </p:nvPr>
+        </p:nvSpPr>
+        <p:spPr/>
+        <p:txBody>
+          <a:bodyPr/>
+          <a:lstStyle/>
+          <a:p>
+            <a:r>
+              <a:rPr lang="en-US" dirty="0" smtClean="0"/>
+              <a:t>Sprints</a:t>
+            </a:r>
+            <a:endParaRPr lang="en-US" dirty="0"/>
+          </a:p>
+        </p:txBody>
+      </p:sp>
+    </p:spTree>
+    <p:extLst>
+      <p:ext uri="{BB962C8B-B14F-4D97-AF65-F5344CB8AC3E}">
+        <p14:creationId xmlns:p14="http://schemas.microsoft.com/office/powerpoint/2010/main" val="1446175581"/>
+      </p:ext>
+    </p:extLst>
+  </p:cSld>
+  <p:clrMapOvr>
+    <a:masterClrMapping/>
+  </p:clrMapOvr>
+  <p:timing>
+    <p:tnLst>
+      <p:par>
+        <p:cTn id="1" dur="indefinite" restart="never" nodeType="tmRoot"/>
+      </p:par>
+    </p:tnLst>
+  </p:timing>
+</p:sld>
+</file>
+
+<file path=ppt/slides/slide15.xml><?xml version="1.0" encoding="utf-8"?>
+<p:sld xmlns:a="http://schemas.openxmlformats.org/drawingml/2006/main" xmlns:r="http://schemas.openxmlformats.org/officeDocument/2006/relationships" xmlns:p="http://schemas.openxmlformats.org/presentationml/2006/main">
+  <p:cSld>
+    <p:spTree>
+      <p:nvGrpSpPr>
+        <p:cNvPr id="1" name=""/>
+        <p:cNvGrpSpPr/>
+        <p:nvPr/>
+      </p:nvGrpSpPr>
+      <p:grpSpPr>
+        <a:xfrm>
+          <a:off x="0" y="0"/>
+          <a:ext cx="0" cy="0"/>
+          <a:chOff x="0" y="0"/>
+          <a:chExt cx="0" cy="0"/>
+        </a:xfrm>
+      </p:grpSpPr>
+      <p:sp>
+        <p:nvSpPr>
+          <p:cNvPr id="2" name="Content Placeholder 1"/>
+          <p:cNvSpPr>
+            <a:spLocks noGrp="1"/>
+          </p:cNvSpPr>
+          <p:nvPr>
+            <p:ph idx="1"/>
+          </p:nvPr>
+        </p:nvSpPr>
+        <p:spPr/>
+        <p:txBody>
+          <a:bodyPr>
             <a:normAutofit fontScale="70000" lnSpcReduction="20000"/>
           </a:bodyPr>
           <a:lstStyle/>
@@ -7524,7 +7722,7 @@
 </p:sld>
 </file>
 
-<file path=ppt/slides/slide15.xml><?xml version="1.0" encoding="utf-8"?>
+<file path=ppt/slides/slide16.xml><?xml version="1.0" encoding="utf-8"?>
 <p:sld xmlns:a="http://schemas.openxmlformats.org/drawingml/2006/main" xmlns:r="http://schemas.openxmlformats.org/officeDocument/2006/relationships" xmlns:p="http://schemas.openxmlformats.org/presentationml/2006/main">
   <p:cSld>
     <p:spTree>
@@ -8807,12 +9005,12 @@
           <a:graphicData uri="http://schemas.openxmlformats.org/presentationml/2006/ole">
             <mc:AlternateContent xmlns:mc="http://schemas.openxmlformats.org/markup-compatibility/2006">
               <mc:Choice xmlns:v="urn:schemas-microsoft-com:vml" Requires="v">
-                <p:oleObj spid="_x0000_s1044" name="Worksheet" r:id="rId4" imgW="6134179" imgH="1181100" progId="Excel.Sheet.12">
+                <p:oleObj spid="_x0000_s1049" name="Worksheet" r:id="rId3" imgW="6134179" imgH="1181100" progId="Excel.Sheet.12">
                   <p:embed/>
                 </p:oleObj>
               </mc:Choice>
               <mc:Fallback>
-                <p:oleObj name="Worksheet" r:id="rId4" imgW="6134179" imgH="1181100" progId="Excel.Sheet.12">
+                <p:oleObj name="Worksheet" r:id="rId3" imgW="6134179" imgH="1181100" progId="Excel.Sheet.12">
                   <p:embed/>
                   <p:pic>
                     <p:nvPicPr>
@@ -8823,7 +9021,7 @@
                       <p:nvPr/>
                     </p:nvPicPr>
                     <p:blipFill>
-                      <a:blip r:embed="rId5"/>
+                      <a:blip r:embed="rId4"/>
                       <a:srcRect/>
                       <a:stretch>
                         <a:fillRect/>

</xml_diff>

<commit_message>
Updated slides while rehearsing
</commit_message>
<xml_diff>
--- a/Sprint1_Documents/Sprint 1 Review.pptx
+++ b/Sprint1_Documents/Sprint 1 Review.pptx
@@ -5,7 +5,7 @@
     <p:sldMasterId id="2147483672" r:id="rId1"/>
   </p:sldMasterIdLst>
   <p:notesMasterIdLst>
-    <p:notesMasterId r:id="rId18"/>
+    <p:notesMasterId r:id="rId19"/>
   </p:notesMasterIdLst>
   <p:sldIdLst>
     <p:sldId id="256" r:id="rId2"/>
@@ -15,15 +15,16 @@
     <p:sldId id="272" r:id="rId6"/>
     <p:sldId id="259" r:id="rId7"/>
     <p:sldId id="270" r:id="rId8"/>
-    <p:sldId id="260" r:id="rId9"/>
-    <p:sldId id="271" r:id="rId10"/>
-    <p:sldId id="262" r:id="rId11"/>
-    <p:sldId id="273" r:id="rId12"/>
-    <p:sldId id="263" r:id="rId13"/>
-    <p:sldId id="264" r:id="rId14"/>
-    <p:sldId id="268" r:id="rId15"/>
-    <p:sldId id="269" r:id="rId16"/>
-    <p:sldId id="267" r:id="rId17"/>
+    <p:sldId id="274" r:id="rId9"/>
+    <p:sldId id="260" r:id="rId10"/>
+    <p:sldId id="271" r:id="rId11"/>
+    <p:sldId id="262" r:id="rId12"/>
+    <p:sldId id="273" r:id="rId13"/>
+    <p:sldId id="263" r:id="rId14"/>
+    <p:sldId id="264" r:id="rId15"/>
+    <p:sldId id="268" r:id="rId16"/>
+    <p:sldId id="269" r:id="rId17"/>
+    <p:sldId id="267" r:id="rId18"/>
   </p:sldIdLst>
   <p:sldSz cx="9144000" cy="6858000" type="screen4x3"/>
   <p:notesSz cx="6858000" cy="9144000"/>
@@ -533,7 +534,17 @@
             </a:r>
             <a:r>
               <a:rPr lang="en-US" baseline="0" dirty="0" smtClean="0"/>
-              <a:t> introduces the team, each person introduces themselves</a:t>
+              <a:t> introduces the team, each person introduces </a:t>
+            </a:r>
+            <a:r>
+              <a:rPr lang="en-US" baseline="0" dirty="0" smtClean="0"/>
+              <a:t>themselves</a:t>
+            </a:r>
+          </a:p>
+          <a:p>
+            <a:r>
+              <a:rPr lang="en-US" baseline="0" dirty="0" smtClean="0"/>
+              <a:t>Marshall</a:t>
             </a:r>
             <a:endParaRPr lang="en-US" dirty="0"/>
           </a:p>
@@ -621,7 +632,36 @@
           <a:p>
             <a:r>
               <a:rPr lang="en-US" dirty="0" smtClean="0"/>
-              <a:t>Marshall + Kevin</a:t>
+              <a:t>Kevin</a:t>
+            </a:r>
+            <a:endParaRPr lang="en-US" dirty="0" smtClean="0"/>
+          </a:p>
+          <a:p>
+            <a:r>
+              <a:rPr lang="en-US" dirty="0" smtClean="0"/>
+              <a:t>Game</a:t>
+            </a:r>
+            <a:r>
+              <a:rPr lang="en-US" baseline="0" dirty="0" smtClean="0"/>
+              <a:t> Stats: for each game, show: total # played, total currently playing, date made (in)active, date imported</a:t>
+            </a:r>
+          </a:p>
+          <a:p>
+            <a:r>
+              <a:rPr lang="en-US" baseline="0" dirty="0" smtClean="0"/>
+              <a:t>Server Stats: Total uptime, Server version, total network traffic</a:t>
+            </a:r>
+          </a:p>
+          <a:p>
+            <a:r>
+              <a:rPr lang="en-US" baseline="0" dirty="0" smtClean="0"/>
+              <a:t>Error Log:</a:t>
+            </a:r>
+          </a:p>
+          <a:p>
+            <a:r>
+              <a:rPr lang="en-US" baseline="0" dirty="0" smtClean="0"/>
+              <a:t>Import login: brings up a file dialog so admin can browse to and add a game file.</a:t>
             </a:r>
             <a:endParaRPr lang="en-US" dirty="0"/>
           </a:p>
@@ -644,16 +684,16 @@
           <a:p>
             <a:fld id="{2196A064-7C2B-4BD1-B717-284E7E6AAF69}" type="slidenum">
               <a:rPr lang="en-US" smtClean="0"/>
-              <a:t>12</a:t>
+              <a:t>10</a:t>
             </a:fld>
-            <a:endParaRPr lang="en-US"/>
+            <a:endParaRPr lang="en-US" dirty="0"/>
           </a:p>
         </p:txBody>
       </p:sp>
     </p:spTree>
     <p:extLst>
       <p:ext uri="{BB962C8B-B14F-4D97-AF65-F5344CB8AC3E}">
-        <p14:creationId xmlns:p14="http://schemas.microsoft.com/office/powerpoint/2010/main" val="2086731328"/>
+        <p14:creationId xmlns:p14="http://schemas.microsoft.com/office/powerpoint/2010/main" val="4139971806"/>
       </p:ext>
     </p:extLst>
   </p:cSld>
@@ -708,22 +748,8 @@
           <a:lstStyle/>
           <a:p>
             <a:r>
-              <a:rPr lang="en-US" sz="1200" b="0" i="0" kern="1200" dirty="0" smtClean="0">
-                <a:solidFill>
-                  <a:schemeClr val="tx1"/>
-                </a:solidFill>
-                <a:effectLst/>
-                <a:latin typeface="+mn-lt"/>
-                <a:ea typeface="+mn-ea"/>
-                <a:cs typeface="+mn-cs"/>
-              </a:rPr>
-              <a:t>Risks, risk analysis, mitigation and contingency plan  (2 min)</a:t>
-            </a:r>
-          </a:p>
-          <a:p>
-            <a:r>
-              <a:rPr lang="en-US" dirty="0" smtClean="0"/>
-              <a:t>David</a:t>
+              <a:rPr lang="en-US" dirty="0" smtClean="0"/>
+              <a:t>Kevin</a:t>
             </a:r>
             <a:endParaRPr lang="en-US" dirty="0"/>
           </a:p>
@@ -746,7 +772,7 @@
           <a:p>
             <a:fld id="{2196A064-7C2B-4BD1-B717-284E7E6AAF69}" type="slidenum">
               <a:rPr lang="en-US" smtClean="0"/>
-              <a:t>13</a:t>
+              <a:t>11</a:t>
             </a:fld>
             <a:endParaRPr lang="en-US"/>
           </a:p>
@@ -755,7 +781,7 @@
     </p:spTree>
     <p:extLst>
       <p:ext uri="{BB962C8B-B14F-4D97-AF65-F5344CB8AC3E}">
-        <p14:creationId xmlns:p14="http://schemas.microsoft.com/office/powerpoint/2010/main" val="1966491216"/>
+        <p14:creationId xmlns:p14="http://schemas.microsoft.com/office/powerpoint/2010/main" val="3581750510"/>
       </p:ext>
     </p:extLst>
   </p:cSld>
@@ -809,6 +835,10 @@
           <a:bodyPr/>
           <a:lstStyle/>
           <a:p>
+            <a:r>
+              <a:rPr lang="en-US" dirty="0" smtClean="0"/>
+              <a:t>David</a:t>
+            </a:r>
             <a:endParaRPr lang="en-US" dirty="0"/>
           </a:p>
         </p:txBody>
@@ -830,7 +860,7 @@
           <a:p>
             <a:fld id="{2196A064-7C2B-4BD1-B717-284E7E6AAF69}" type="slidenum">
               <a:rPr lang="en-US" smtClean="0"/>
-              <a:t>14</a:t>
+              <a:t>12</a:t>
             </a:fld>
             <a:endParaRPr lang="en-US"/>
           </a:p>
@@ -839,7 +869,7 @@
     </p:spTree>
     <p:extLst>
       <p:ext uri="{BB962C8B-B14F-4D97-AF65-F5344CB8AC3E}">
-        <p14:creationId xmlns:p14="http://schemas.microsoft.com/office/powerpoint/2010/main" val="3059345779"/>
+        <p14:creationId xmlns:p14="http://schemas.microsoft.com/office/powerpoint/2010/main" val="444776262"/>
       </p:ext>
     </p:extLst>
   </p:cSld>
@@ -895,11 +925,7 @@
           <a:p>
             <a:r>
               <a:rPr lang="en-US" dirty="0" smtClean="0"/>
-              <a:t>Quickly</a:t>
-            </a:r>
-            <a:r>
-              <a:rPr lang="en-US" baseline="0" dirty="0" smtClean="0"/>
-              <a:t> show that we have a backlog, no need to go into great detail here</a:t>
+              <a:t>David</a:t>
             </a:r>
             <a:endParaRPr lang="en-US" dirty="0"/>
           </a:p>
@@ -922,7 +948,7 @@
           <a:p>
             <a:fld id="{2196A064-7C2B-4BD1-B717-284E7E6AAF69}" type="slidenum">
               <a:rPr lang="en-US" smtClean="0"/>
-              <a:t>15</a:t>
+              <a:t>13</a:t>
             </a:fld>
             <a:endParaRPr lang="en-US"/>
           </a:p>
@@ -931,7 +957,7 @@
     </p:spTree>
     <p:extLst>
       <p:ext uri="{BB962C8B-B14F-4D97-AF65-F5344CB8AC3E}">
-        <p14:creationId xmlns:p14="http://schemas.microsoft.com/office/powerpoint/2010/main" val="542630260"/>
+        <p14:creationId xmlns:p14="http://schemas.microsoft.com/office/powerpoint/2010/main" val="2086731328"/>
       </p:ext>
     </p:extLst>
   </p:cSld>
@@ -995,6 +1021,306 @@
                 <a:ea typeface="+mn-ea"/>
                 <a:cs typeface="+mn-cs"/>
               </a:rPr>
+              <a:t>Risks, risk analysis, mitigation and contingency plan  (2 min)</a:t>
+            </a:r>
+          </a:p>
+          <a:p>
+            <a:r>
+              <a:rPr lang="en-US" dirty="0" smtClean="0"/>
+              <a:t>David</a:t>
+            </a:r>
+            <a:endParaRPr lang="en-US" dirty="0"/>
+          </a:p>
+        </p:txBody>
+      </p:sp>
+      <p:sp>
+        <p:nvSpPr>
+          <p:cNvPr id="4" name="Slide Number Placeholder 3"/>
+          <p:cNvSpPr>
+            <a:spLocks noGrp="1"/>
+          </p:cNvSpPr>
+          <p:nvPr>
+            <p:ph type="sldNum" sz="quarter" idx="10"/>
+          </p:nvPr>
+        </p:nvSpPr>
+        <p:spPr/>
+        <p:txBody>
+          <a:bodyPr/>
+          <a:lstStyle/>
+          <a:p>
+            <a:fld id="{2196A064-7C2B-4BD1-B717-284E7E6AAF69}" type="slidenum">
+              <a:rPr lang="en-US" smtClean="0"/>
+              <a:t>14</a:t>
+            </a:fld>
+            <a:endParaRPr lang="en-US"/>
+          </a:p>
+        </p:txBody>
+      </p:sp>
+    </p:spTree>
+    <p:extLst>
+      <p:ext uri="{BB962C8B-B14F-4D97-AF65-F5344CB8AC3E}">
+        <p14:creationId xmlns:p14="http://schemas.microsoft.com/office/powerpoint/2010/main" val="1966491216"/>
+      </p:ext>
+    </p:extLst>
+  </p:cSld>
+  <p:clrMapOvr>
+    <a:masterClrMapping/>
+  </p:clrMapOvr>
+</p:notes>
+</file>
+
+<file path=ppt/notesSlides/notesSlide15.xml><?xml version="1.0" encoding="utf-8"?>
+<p:notes xmlns:a="http://schemas.openxmlformats.org/drawingml/2006/main" xmlns:r="http://schemas.openxmlformats.org/officeDocument/2006/relationships" xmlns:p="http://schemas.openxmlformats.org/presentationml/2006/main">
+  <p:cSld>
+    <p:spTree>
+      <p:nvGrpSpPr>
+        <p:cNvPr id="1" name=""/>
+        <p:cNvGrpSpPr/>
+        <p:nvPr/>
+      </p:nvGrpSpPr>
+      <p:grpSpPr>
+        <a:xfrm>
+          <a:off x="0" y="0"/>
+          <a:ext cx="0" cy="0"/>
+          <a:chOff x="0" y="0"/>
+          <a:chExt cx="0" cy="0"/>
+        </a:xfrm>
+      </p:grpSpPr>
+      <p:sp>
+        <p:nvSpPr>
+          <p:cNvPr id="2" name="Slide Image Placeholder 1"/>
+          <p:cNvSpPr>
+            <a:spLocks noGrp="1" noRot="1" noChangeAspect="1"/>
+          </p:cNvSpPr>
+          <p:nvPr>
+            <p:ph type="sldImg"/>
+          </p:nvPr>
+        </p:nvSpPr>
+        <p:spPr/>
+      </p:sp>
+      <p:sp>
+        <p:nvSpPr>
+          <p:cNvPr id="3" name="Notes Placeholder 2"/>
+          <p:cNvSpPr>
+            <a:spLocks noGrp="1"/>
+          </p:cNvSpPr>
+          <p:nvPr>
+            <p:ph type="body" idx="1"/>
+          </p:nvPr>
+        </p:nvSpPr>
+        <p:spPr/>
+        <p:txBody>
+          <a:bodyPr/>
+          <a:lstStyle/>
+          <a:p>
+            <a:r>
+              <a:rPr lang="en-US" dirty="0" smtClean="0"/>
+              <a:t>Marshall</a:t>
+            </a:r>
+            <a:endParaRPr lang="en-US" dirty="0"/>
+          </a:p>
+        </p:txBody>
+      </p:sp>
+      <p:sp>
+        <p:nvSpPr>
+          <p:cNvPr id="4" name="Slide Number Placeholder 3"/>
+          <p:cNvSpPr>
+            <a:spLocks noGrp="1"/>
+          </p:cNvSpPr>
+          <p:nvPr>
+            <p:ph type="sldNum" sz="quarter" idx="10"/>
+          </p:nvPr>
+        </p:nvSpPr>
+        <p:spPr/>
+        <p:txBody>
+          <a:bodyPr/>
+          <a:lstStyle/>
+          <a:p>
+            <a:fld id="{2196A064-7C2B-4BD1-B717-284E7E6AAF69}" type="slidenum">
+              <a:rPr lang="en-US" smtClean="0"/>
+              <a:t>15</a:t>
+            </a:fld>
+            <a:endParaRPr lang="en-US"/>
+          </a:p>
+        </p:txBody>
+      </p:sp>
+    </p:spTree>
+    <p:extLst>
+      <p:ext uri="{BB962C8B-B14F-4D97-AF65-F5344CB8AC3E}">
+        <p14:creationId xmlns:p14="http://schemas.microsoft.com/office/powerpoint/2010/main" val="3059345779"/>
+      </p:ext>
+    </p:extLst>
+  </p:cSld>
+  <p:clrMapOvr>
+    <a:masterClrMapping/>
+  </p:clrMapOvr>
+</p:notes>
+</file>
+
+<file path=ppt/notesSlides/notesSlide16.xml><?xml version="1.0" encoding="utf-8"?>
+<p:notes xmlns:a="http://schemas.openxmlformats.org/drawingml/2006/main" xmlns:r="http://schemas.openxmlformats.org/officeDocument/2006/relationships" xmlns:p="http://schemas.openxmlformats.org/presentationml/2006/main">
+  <p:cSld>
+    <p:spTree>
+      <p:nvGrpSpPr>
+        <p:cNvPr id="1" name=""/>
+        <p:cNvGrpSpPr/>
+        <p:nvPr/>
+      </p:nvGrpSpPr>
+      <p:grpSpPr>
+        <a:xfrm>
+          <a:off x="0" y="0"/>
+          <a:ext cx="0" cy="0"/>
+          <a:chOff x="0" y="0"/>
+          <a:chExt cx="0" cy="0"/>
+        </a:xfrm>
+      </p:grpSpPr>
+      <p:sp>
+        <p:nvSpPr>
+          <p:cNvPr id="2" name="Slide Image Placeholder 1"/>
+          <p:cNvSpPr>
+            <a:spLocks noGrp="1" noRot="1" noChangeAspect="1"/>
+          </p:cNvSpPr>
+          <p:nvPr>
+            <p:ph type="sldImg"/>
+          </p:nvPr>
+        </p:nvSpPr>
+        <p:spPr/>
+      </p:sp>
+      <p:sp>
+        <p:nvSpPr>
+          <p:cNvPr id="3" name="Notes Placeholder 2"/>
+          <p:cNvSpPr>
+            <a:spLocks noGrp="1"/>
+          </p:cNvSpPr>
+          <p:nvPr>
+            <p:ph type="body" idx="1"/>
+          </p:nvPr>
+        </p:nvSpPr>
+        <p:spPr/>
+        <p:txBody>
+          <a:bodyPr/>
+          <a:lstStyle/>
+          <a:p>
+            <a:r>
+              <a:rPr lang="en-US" dirty="0" smtClean="0"/>
+              <a:t>Quickly</a:t>
+            </a:r>
+            <a:r>
+              <a:rPr lang="en-US" baseline="0" dirty="0" smtClean="0"/>
+              <a:t> </a:t>
+            </a:r>
+            <a:r>
+              <a:rPr lang="en-US" baseline="0" dirty="0" smtClean="0"/>
+              <a:t>show </a:t>
+            </a:r>
+            <a:r>
+              <a:rPr lang="en-US" baseline="0" dirty="0" smtClean="0"/>
+              <a:t>that we have a backlog, no need to go into great detail </a:t>
+            </a:r>
+            <a:r>
+              <a:rPr lang="en-US" baseline="0" dirty="0" smtClean="0"/>
+              <a:t>here</a:t>
+            </a:r>
+          </a:p>
+          <a:p>
+            <a:r>
+              <a:rPr lang="en-US" baseline="0" dirty="0" smtClean="0"/>
+              <a:t>Kevin</a:t>
+            </a:r>
+            <a:endParaRPr lang="en-US" dirty="0"/>
+          </a:p>
+        </p:txBody>
+      </p:sp>
+      <p:sp>
+        <p:nvSpPr>
+          <p:cNvPr id="4" name="Slide Number Placeholder 3"/>
+          <p:cNvSpPr>
+            <a:spLocks noGrp="1"/>
+          </p:cNvSpPr>
+          <p:nvPr>
+            <p:ph type="sldNum" sz="quarter" idx="10"/>
+          </p:nvPr>
+        </p:nvSpPr>
+        <p:spPr/>
+        <p:txBody>
+          <a:bodyPr/>
+          <a:lstStyle/>
+          <a:p>
+            <a:fld id="{2196A064-7C2B-4BD1-B717-284E7E6AAF69}" type="slidenum">
+              <a:rPr lang="en-US" smtClean="0"/>
+              <a:t>16</a:t>
+            </a:fld>
+            <a:endParaRPr lang="en-US"/>
+          </a:p>
+        </p:txBody>
+      </p:sp>
+    </p:spTree>
+    <p:extLst>
+      <p:ext uri="{BB962C8B-B14F-4D97-AF65-F5344CB8AC3E}">
+        <p14:creationId xmlns:p14="http://schemas.microsoft.com/office/powerpoint/2010/main" val="542630260"/>
+      </p:ext>
+    </p:extLst>
+  </p:cSld>
+  <p:clrMapOvr>
+    <a:masterClrMapping/>
+  </p:clrMapOvr>
+</p:notes>
+</file>
+
+<file path=ppt/notesSlides/notesSlide17.xml><?xml version="1.0" encoding="utf-8"?>
+<p:notes xmlns:a="http://schemas.openxmlformats.org/drawingml/2006/main" xmlns:r="http://schemas.openxmlformats.org/officeDocument/2006/relationships" xmlns:p="http://schemas.openxmlformats.org/presentationml/2006/main">
+  <p:cSld>
+    <p:spTree>
+      <p:nvGrpSpPr>
+        <p:cNvPr id="1" name=""/>
+        <p:cNvGrpSpPr/>
+        <p:nvPr/>
+      </p:nvGrpSpPr>
+      <p:grpSpPr>
+        <a:xfrm>
+          <a:off x="0" y="0"/>
+          <a:ext cx="0" cy="0"/>
+          <a:chOff x="0" y="0"/>
+          <a:chExt cx="0" cy="0"/>
+        </a:xfrm>
+      </p:grpSpPr>
+      <p:sp>
+        <p:nvSpPr>
+          <p:cNvPr id="2" name="Slide Image Placeholder 1"/>
+          <p:cNvSpPr>
+            <a:spLocks noGrp="1" noRot="1" noChangeAspect="1"/>
+          </p:cNvSpPr>
+          <p:nvPr>
+            <p:ph type="sldImg"/>
+          </p:nvPr>
+        </p:nvSpPr>
+        <p:spPr/>
+      </p:sp>
+      <p:sp>
+        <p:nvSpPr>
+          <p:cNvPr id="3" name="Notes Placeholder 2"/>
+          <p:cNvSpPr>
+            <a:spLocks noGrp="1"/>
+          </p:cNvSpPr>
+          <p:nvPr>
+            <p:ph type="body" idx="1"/>
+          </p:nvPr>
+        </p:nvSpPr>
+        <p:spPr/>
+        <p:txBody>
+          <a:bodyPr/>
+          <a:lstStyle/>
+          <a:p>
+            <a:r>
+              <a:rPr lang="en-US" sz="1200" b="0" i="0" kern="1200" dirty="0" smtClean="0">
+                <a:solidFill>
+                  <a:schemeClr val="tx1"/>
+                </a:solidFill>
+                <a:effectLst/>
+                <a:latin typeface="+mn-lt"/>
+                <a:ea typeface="+mn-ea"/>
+                <a:cs typeface="+mn-cs"/>
+              </a:rPr>
               <a:t>Questions  (5 </a:t>
             </a:r>
             <a:r>
@@ -1068,7 +1394,7 @@
           <a:p>
             <a:fld id="{2196A064-7C2B-4BD1-B717-284E7E6AAF69}" type="slidenum">
               <a:rPr lang="en-US" smtClean="0"/>
-              <a:t>16</a:t>
+              <a:t>17</a:t>
             </a:fld>
             <a:endParaRPr lang="en-US"/>
           </a:p>
@@ -1336,6 +1662,10 @@
               <a:rPr lang="en-US" baseline="0" dirty="0" smtClean="0"/>
               <a:t> </a:t>
             </a:r>
+            <a:r>
+              <a:rPr lang="en-US" baseline="0" dirty="0" smtClean="0"/>
+              <a:t>– needs refinement</a:t>
+            </a:r>
             <a:endParaRPr lang="en-US" dirty="0"/>
           </a:p>
         </p:txBody>
@@ -1445,16 +1775,16 @@
           <a:p>
             <a:fld id="{2196A064-7C2B-4BD1-B717-284E7E6AAF69}" type="slidenum">
               <a:rPr lang="en-US" smtClean="0"/>
-              <a:t>6</a:t>
+              <a:t>5</a:t>
             </a:fld>
-            <a:endParaRPr lang="en-US" dirty="0"/>
+            <a:endParaRPr lang="en-US"/>
           </a:p>
         </p:txBody>
       </p:sp>
     </p:spTree>
     <p:extLst>
       <p:ext uri="{BB962C8B-B14F-4D97-AF65-F5344CB8AC3E}">
-        <p14:creationId xmlns:p14="http://schemas.microsoft.com/office/powerpoint/2010/main" val="2673879577"/>
+        <p14:creationId xmlns:p14="http://schemas.microsoft.com/office/powerpoint/2010/main" val="1218284398"/>
       </p:ext>
     </p:extLst>
   </p:cSld>
@@ -1510,7 +1840,7 @@
           <a:p>
             <a:r>
               <a:rPr lang="en-US" dirty="0" smtClean="0"/>
-              <a:t>David + Kevin</a:t>
+              <a:t>Marshall</a:t>
             </a:r>
             <a:endParaRPr lang="en-US" dirty="0"/>
           </a:p>
@@ -1533,7 +1863,7 @@
           <a:p>
             <a:fld id="{2196A064-7C2B-4BD1-B717-284E7E6AAF69}" type="slidenum">
               <a:rPr lang="en-US" smtClean="0"/>
-              <a:t>8</a:t>
+              <a:t>6</a:t>
             </a:fld>
             <a:endParaRPr lang="en-US" dirty="0"/>
           </a:p>
@@ -1542,7 +1872,7 @@
     </p:spTree>
     <p:extLst>
       <p:ext uri="{BB962C8B-B14F-4D97-AF65-F5344CB8AC3E}">
-        <p14:creationId xmlns:p14="http://schemas.microsoft.com/office/powerpoint/2010/main" val="4139971806"/>
+        <p14:creationId xmlns:p14="http://schemas.microsoft.com/office/powerpoint/2010/main" val="2673879577"/>
       </p:ext>
     </p:extLst>
   </p:cSld>
@@ -1598,40 +1928,7 @@
           <a:p>
             <a:r>
               <a:rPr lang="en-US" dirty="0" smtClean="0"/>
-              <a:t>David + Kevin</a:t>
-            </a:r>
-          </a:p>
-          <a:p>
-            <a:r>
-              <a:rPr lang="en-US" dirty="0" smtClean="0"/>
-              <a:t>Game</a:t>
-            </a:r>
-            <a:r>
-              <a:rPr lang="en-US" baseline="0" dirty="0" smtClean="0"/>
-              <a:t> Stats: for each game, show: total # played, total currently playing, date made (in)active, date imported</a:t>
-            </a:r>
-          </a:p>
-          <a:p>
-            <a:r>
-              <a:rPr lang="en-US" baseline="0" dirty="0" smtClean="0"/>
-              <a:t>Server Stats: Total uptime, Server version, total </a:t>
-            </a:r>
-            <a:r>
-              <a:rPr lang="en-US" baseline="0" smtClean="0"/>
-              <a:t>network traffic</a:t>
-            </a:r>
-            <a:endParaRPr lang="en-US" baseline="0" dirty="0" smtClean="0"/>
-          </a:p>
-          <a:p>
-            <a:r>
-              <a:rPr lang="en-US" baseline="0" dirty="0" smtClean="0"/>
-              <a:t>Error Log:</a:t>
-            </a:r>
-          </a:p>
-          <a:p>
-            <a:r>
-              <a:rPr lang="en-US" baseline="0" dirty="0" smtClean="0"/>
-              <a:t>Import login: brings up a file dialog so admin can browse to and add a game file.</a:t>
+              <a:t>Marshall</a:t>
             </a:r>
             <a:endParaRPr lang="en-US" dirty="0"/>
           </a:p>
@@ -1654,16 +1951,16 @@
           <a:p>
             <a:fld id="{2196A064-7C2B-4BD1-B717-284E7E6AAF69}" type="slidenum">
               <a:rPr lang="en-US" smtClean="0"/>
-              <a:t>9</a:t>
+              <a:t>7</a:t>
             </a:fld>
-            <a:endParaRPr lang="en-US" dirty="0"/>
+            <a:endParaRPr lang="en-US"/>
           </a:p>
         </p:txBody>
       </p:sp>
     </p:spTree>
     <p:extLst>
       <p:ext uri="{BB962C8B-B14F-4D97-AF65-F5344CB8AC3E}">
-        <p14:creationId xmlns:p14="http://schemas.microsoft.com/office/powerpoint/2010/main" val="4139971806"/>
+        <p14:creationId xmlns:p14="http://schemas.microsoft.com/office/powerpoint/2010/main" val="1117467524"/>
       </p:ext>
     </p:extLst>
   </p:cSld>
@@ -1719,7 +2016,7 @@
           <a:p>
             <a:r>
               <a:rPr lang="en-US" dirty="0" smtClean="0"/>
-              <a:t>David</a:t>
+              <a:t>Marshall</a:t>
             </a:r>
             <a:endParaRPr lang="en-US" dirty="0"/>
           </a:p>
@@ -1742,7 +2039,7 @@
           <a:p>
             <a:fld id="{2196A064-7C2B-4BD1-B717-284E7E6AAF69}" type="slidenum">
               <a:rPr lang="en-US" smtClean="0"/>
-              <a:t>10</a:t>
+              <a:t>8</a:t>
             </a:fld>
             <a:endParaRPr lang="en-US"/>
           </a:p>
@@ -1751,7 +2048,7 @@
     </p:spTree>
     <p:extLst>
       <p:ext uri="{BB962C8B-B14F-4D97-AF65-F5344CB8AC3E}">
-        <p14:creationId xmlns:p14="http://schemas.microsoft.com/office/powerpoint/2010/main" val="3581750510"/>
+        <p14:creationId xmlns:p14="http://schemas.microsoft.com/office/powerpoint/2010/main" val="2991615193"/>
       </p:ext>
     </p:extLst>
   </p:cSld>
@@ -1806,8 +2103,8 @@
           <a:lstStyle/>
           <a:p>
             <a:r>
-              <a:rPr lang="en-US" smtClean="0"/>
-              <a:t>Kevin</a:t>
+              <a:rPr lang="en-US" dirty="0" smtClean="0"/>
+              <a:t>David + Kevin</a:t>
             </a:r>
             <a:endParaRPr lang="en-US" dirty="0"/>
           </a:p>
@@ -1830,16 +2127,16 @@
           <a:p>
             <a:fld id="{2196A064-7C2B-4BD1-B717-284E7E6AAF69}" type="slidenum">
               <a:rPr lang="en-US" smtClean="0"/>
-              <a:t>11</a:t>
+              <a:t>9</a:t>
             </a:fld>
-            <a:endParaRPr lang="en-US"/>
+            <a:endParaRPr lang="en-US" dirty="0"/>
           </a:p>
         </p:txBody>
       </p:sp>
     </p:spTree>
     <p:extLst>
       <p:ext uri="{BB962C8B-B14F-4D97-AF65-F5344CB8AC3E}">
-        <p14:creationId xmlns:p14="http://schemas.microsoft.com/office/powerpoint/2010/main" val="444776262"/>
+        <p14:creationId xmlns:p14="http://schemas.microsoft.com/office/powerpoint/2010/main" val="4139971806"/>
       </p:ext>
     </p:extLst>
   </p:cSld>
@@ -6443,6 +6740,95 @@
           <a:chExt cx="0" cy="0"/>
         </a:xfrm>
       </p:grpSpPr>
+      <p:pic>
+        <p:nvPicPr>
+          <p:cNvPr id="3" name="Content Placeholder 2"/>
+          <p:cNvPicPr>
+            <a:picLocks noGrp="1" noChangeAspect="1"/>
+          </p:cNvPicPr>
+          <p:nvPr>
+            <p:ph idx="1"/>
+          </p:nvPr>
+        </p:nvPicPr>
+        <p:blipFill>
+          <a:blip r:embed="rId3">
+            <a:extLst>
+              <a:ext uri="{28A0092B-C50C-407E-A947-70E740481C1C}">
+                <a14:useLocalDpi xmlns:a14="http://schemas.microsoft.com/office/drawing/2010/main" val="0"/>
+              </a:ext>
+            </a:extLst>
+          </a:blip>
+          <a:stretch>
+            <a:fillRect/>
+          </a:stretch>
+        </p:blipFill>
+        <p:spPr>
+          <a:xfrm>
+            <a:off x="1143000" y="1143000"/>
+            <a:ext cx="6934200" cy="5185501"/>
+          </a:xfrm>
+        </p:spPr>
+      </p:pic>
+      <p:sp>
+        <p:nvSpPr>
+          <p:cNvPr id="2" name="Title 1"/>
+          <p:cNvSpPr>
+            <a:spLocks noGrp="1"/>
+          </p:cNvSpPr>
+          <p:nvPr>
+            <p:ph type="title"/>
+          </p:nvPr>
+        </p:nvSpPr>
+        <p:spPr/>
+        <p:txBody>
+          <a:bodyPr/>
+          <a:lstStyle/>
+          <a:p>
+            <a:r>
+              <a:rPr lang="en-US" dirty="0" smtClean="0"/>
+              <a:t>Design Analysis - Server</a:t>
+            </a:r>
+            <a:endParaRPr lang="en-US" dirty="0"/>
+          </a:p>
+        </p:txBody>
+      </p:sp>
+    </p:spTree>
+    <p:extLst>
+      <p:ext uri="{BB962C8B-B14F-4D97-AF65-F5344CB8AC3E}">
+        <p14:creationId xmlns:p14="http://schemas.microsoft.com/office/powerpoint/2010/main" val="2750846494"/>
+      </p:ext>
+    </p:extLst>
+  </p:cSld>
+  <p:clrMapOvr>
+    <a:masterClrMapping/>
+  </p:clrMapOvr>
+  <p:timing>
+    <p:tnLst>
+      <p:par>
+        <p:cTn id="1" dur="indefinite" restart="never" nodeType="tmRoot"/>
+      </p:par>
+    </p:tnLst>
+  </p:timing>
+</p:sld>
+</file>
+
+<file path=ppt/slides/slide11.xml><?xml version="1.0" encoding="utf-8"?>
+<p:sld xmlns:a="http://schemas.openxmlformats.org/drawingml/2006/main" xmlns:r="http://schemas.openxmlformats.org/officeDocument/2006/relationships" xmlns:p="http://schemas.openxmlformats.org/presentationml/2006/main">
+  <p:cSld>
+    <p:spTree>
+      <p:nvGrpSpPr>
+        <p:cNvPr id="1" name=""/>
+        <p:cNvGrpSpPr/>
+        <p:nvPr/>
+      </p:nvGrpSpPr>
+      <p:grpSpPr>
+        <a:xfrm>
+          <a:off x="0" y="0"/>
+          <a:ext cx="0" cy="0"/>
+          <a:chOff x="0" y="0"/>
+          <a:chExt cx="0" cy="0"/>
+        </a:xfrm>
+      </p:grpSpPr>
       <p:sp>
         <p:nvSpPr>
           <p:cNvPr id="7" name="Content Placeholder 6"/>
@@ -6461,7 +6847,7 @@
         </p:spPr>
         <p:txBody>
           <a:bodyPr>
-            <a:normAutofit lnSpcReduction="10000"/>
+            <a:normAutofit fontScale="92500" lnSpcReduction="10000"/>
           </a:bodyPr>
           <a:lstStyle/>
           <a:p>
@@ -6481,7 +6867,11 @@
             <a:pPr lvl="1"/>
             <a:r>
               <a:rPr lang="en-US" dirty="0" smtClean="0"/>
-              <a:t>Connects  APMax units</a:t>
+              <a:t>Connects </a:t>
+            </a:r>
+            <a:r>
+              <a:rPr lang="en-US" dirty="0" smtClean="0"/>
+              <a:t>APMax units</a:t>
             </a:r>
           </a:p>
           <a:p>
@@ -6494,14 +6884,37 @@
             <a:pPr lvl="1"/>
             <a:r>
               <a:rPr lang="en-US" dirty="0" smtClean="0"/>
-              <a:t>Optional – If one server</a:t>
+              <a:t>Optional – If </a:t>
+            </a:r>
+            <a:r>
+              <a:rPr lang="en-US" dirty="0" smtClean="0"/>
+              <a:t>the </a:t>
             </a:r>
             <a:br>
               <a:rPr lang="en-US" dirty="0" smtClean="0"/>
             </a:br>
             <a:r>
               <a:rPr lang="en-US" dirty="0" smtClean="0"/>
-              <a:t>can’t handle all game A.I.</a:t>
+              <a:t>central server</a:t>
+            </a:r>
+            <a:r>
+              <a:rPr lang="en-US" dirty="0" smtClean="0"/>
+              <a:t> </a:t>
+            </a:r>
+            <a:r>
+              <a:rPr lang="en-US" dirty="0" smtClean="0"/>
+              <a:t>can’t</a:t>
+            </a:r>
+            <a:br>
+              <a:rPr lang="en-US" dirty="0" smtClean="0"/>
+            </a:br>
+            <a:r>
+              <a:rPr lang="en-US" dirty="0" smtClean="0"/>
+              <a:t>handle all game </a:t>
+            </a:r>
+            <a:r>
+              <a:rPr lang="en-US" dirty="0" smtClean="0"/>
+              <a:t>A.I.</a:t>
             </a:r>
           </a:p>
           <a:p>
@@ -6767,7 +7180,7 @@
         </p:nvCxnSpPr>
         <p:spPr>
           <a:xfrm>
-            <a:off x="2057400" y="3886200"/>
+            <a:off x="2057400" y="4038600"/>
             <a:ext cx="2819400" cy="0"/>
           </a:xfrm>
           <a:prstGeom prst="line">
@@ -6797,8 +7210,8 @@
         </p:nvCxnSpPr>
         <p:spPr>
           <a:xfrm>
-            <a:off x="4876800" y="3886200"/>
-            <a:ext cx="0" cy="685800"/>
+            <a:off x="4876800" y="4038600"/>
+            <a:ext cx="0" cy="533400"/>
           </a:xfrm>
           <a:prstGeom prst="straightConnector1">
             <a:avLst/>
@@ -6905,115 +7318,6 @@
 </p:sld>
 </file>
 
-<file path=ppt/slides/slide11.xml><?xml version="1.0" encoding="utf-8"?>
-<p:sld xmlns:a="http://schemas.openxmlformats.org/drawingml/2006/main" xmlns:r="http://schemas.openxmlformats.org/officeDocument/2006/relationships" xmlns:p="http://schemas.openxmlformats.org/presentationml/2006/main">
-  <p:cSld>
-    <p:spTree>
-      <p:nvGrpSpPr>
-        <p:cNvPr id="1" name=""/>
-        <p:cNvGrpSpPr/>
-        <p:nvPr/>
-      </p:nvGrpSpPr>
-      <p:grpSpPr>
-        <a:xfrm>
-          <a:off x="0" y="0"/>
-          <a:ext cx="0" cy="0"/>
-          <a:chOff x="0" y="0"/>
-          <a:chExt cx="0" cy="0"/>
-        </a:xfrm>
-      </p:grpSpPr>
-      <p:sp>
-        <p:nvSpPr>
-          <p:cNvPr id="2" name="Content Placeholder 1"/>
-          <p:cNvSpPr>
-            <a:spLocks noGrp="1"/>
-          </p:cNvSpPr>
-          <p:nvPr>
-            <p:ph idx="1"/>
-          </p:nvPr>
-        </p:nvSpPr>
-        <p:spPr/>
-        <p:txBody>
-          <a:bodyPr/>
-          <a:lstStyle/>
-          <a:p>
-            <a:r>
-              <a:rPr lang="en-US" dirty="0" smtClean="0"/>
-              <a:t>Full unit testing</a:t>
-            </a:r>
-          </a:p>
-          <a:p>
-            <a:pPr lvl="1"/>
-            <a:r>
-              <a:rPr lang="en-US" dirty="0" smtClean="0"/>
-              <a:t>Testing Server and STB code</a:t>
-            </a:r>
-          </a:p>
-          <a:p>
-            <a:r>
-              <a:rPr lang="en-US" dirty="0" smtClean="0"/>
-              <a:t>Create a virtual APMax</a:t>
-            </a:r>
-          </a:p>
-          <a:p>
-            <a:pPr lvl="1"/>
-            <a:r>
-              <a:rPr lang="en-US" dirty="0" smtClean="0"/>
-              <a:t>Used to simulate communication between STB and server</a:t>
-            </a:r>
-          </a:p>
-          <a:p>
-            <a:pPr lvl="1"/>
-            <a:r>
-              <a:rPr lang="en-US" dirty="0" smtClean="0"/>
-              <a:t>Test new CommandLink messages before going into production</a:t>
-            </a:r>
-          </a:p>
-        </p:txBody>
-      </p:sp>
-      <p:sp>
-        <p:nvSpPr>
-          <p:cNvPr id="3" name="Title 2"/>
-          <p:cNvSpPr>
-            <a:spLocks noGrp="1"/>
-          </p:cNvSpPr>
-          <p:nvPr>
-            <p:ph type="title"/>
-          </p:nvPr>
-        </p:nvSpPr>
-        <p:spPr/>
-        <p:txBody>
-          <a:bodyPr/>
-          <a:lstStyle/>
-          <a:p>
-            <a:r>
-              <a:rPr lang="en-US" dirty="0" smtClean="0"/>
-              <a:t>Testing</a:t>
-            </a:r>
-            <a:endParaRPr lang="en-US" dirty="0"/>
-          </a:p>
-        </p:txBody>
-      </p:sp>
-    </p:spTree>
-    <p:extLst>
-      <p:ext uri="{BB962C8B-B14F-4D97-AF65-F5344CB8AC3E}">
-        <p14:creationId xmlns:p14="http://schemas.microsoft.com/office/powerpoint/2010/main" val="159684043"/>
-      </p:ext>
-    </p:extLst>
-  </p:cSld>
-  <p:clrMapOvr>
-    <a:masterClrMapping/>
-  </p:clrMapOvr>
-  <p:timing>
-    <p:tnLst>
-      <p:par>
-        <p:cTn id="1" dur="indefinite" restart="never" nodeType="tmRoot"/>
-      </p:par>
-    </p:tnLst>
-  </p:timing>
-</p:sld>
-</file>
-
 <file path=ppt/slides/slide12.xml><?xml version="1.0" encoding="utf-8"?>
 <p:sld xmlns:a="http://schemas.openxmlformats.org/drawingml/2006/main" xmlns:r="http://schemas.openxmlformats.org/officeDocument/2006/relationships" xmlns:p="http://schemas.openxmlformats.org/presentationml/2006/main">
   <p:cSld>
@@ -7048,48 +7352,34 @@
           <a:p>
             <a:r>
               <a:rPr lang="en-US" dirty="0" smtClean="0"/>
-              <a:t>Set Top Box</a:t>
+              <a:t>Full unit testing</a:t>
             </a:r>
           </a:p>
           <a:p>
             <a:pPr lvl="1"/>
             <a:r>
               <a:rPr lang="en-US" dirty="0" smtClean="0"/>
-              <a:t>Low memory</a:t>
+              <a:t>Testing Server and STB code</a:t>
+            </a:r>
+          </a:p>
+          <a:p>
+            <a:r>
+              <a:rPr lang="en-US" dirty="0" smtClean="0"/>
+              <a:t>Create a virtual APMax</a:t>
             </a:r>
           </a:p>
           <a:p>
             <a:pPr lvl="1"/>
             <a:r>
               <a:rPr lang="en-US" dirty="0" smtClean="0"/>
-              <a:t>Can’t use flash storage</a:t>
+              <a:t>Used to simulate communication between STB and server</a:t>
             </a:r>
           </a:p>
           <a:p>
             <a:pPr lvl="1"/>
             <a:r>
               <a:rPr lang="en-US" dirty="0" smtClean="0"/>
-              <a:t>Low powered processor</a:t>
-            </a:r>
-          </a:p>
-          <a:p>
-            <a:pPr lvl="1"/>
-            <a:r>
-              <a:rPr lang="en-US" dirty="0" smtClean="0"/>
-              <a:t>Limited bandwidth usage</a:t>
-            </a:r>
-          </a:p>
-          <a:p>
-            <a:r>
-              <a:rPr lang="en-US" dirty="0" smtClean="0"/>
-              <a:t>Server</a:t>
-            </a:r>
-          </a:p>
-          <a:p>
-            <a:pPr lvl="1"/>
-            <a:r>
-              <a:rPr lang="en-US" dirty="0" smtClean="0"/>
-              <a:t>Needs to be scalable to 100s or 1000s of users simultaneously connected</a:t>
+              <a:t>Test new CommandLink messages before going into production</a:t>
             </a:r>
           </a:p>
         </p:txBody>
@@ -7106,14 +7396,12 @@
         </p:nvSpPr>
         <p:spPr/>
         <p:txBody>
-          <a:bodyPr>
-            <a:normAutofit/>
-          </a:bodyPr>
+          <a:bodyPr/>
           <a:lstStyle/>
           <a:p>
             <a:r>
               <a:rPr lang="en-US" dirty="0" smtClean="0"/>
-              <a:t>Constraints</a:t>
+              <a:t>Testing</a:t>
             </a:r>
             <a:endParaRPr lang="en-US" dirty="0"/>
           </a:p>
@@ -7122,7 +7410,7 @@
     </p:spTree>
     <p:extLst>
       <p:ext uri="{BB962C8B-B14F-4D97-AF65-F5344CB8AC3E}">
-        <p14:creationId xmlns:p14="http://schemas.microsoft.com/office/powerpoint/2010/main" val="2063007733"/>
+        <p14:creationId xmlns:p14="http://schemas.microsoft.com/office/powerpoint/2010/main" val="159684043"/>
       </p:ext>
     </p:extLst>
   </p:cSld>
@@ -7168,113 +7456,91 @@
         </p:nvSpPr>
         <p:spPr/>
         <p:txBody>
+          <a:bodyPr/>
+          <a:lstStyle/>
+          <a:p>
+            <a:r>
+              <a:rPr lang="en-US" dirty="0" smtClean="0"/>
+              <a:t>Set Top Box</a:t>
+            </a:r>
+          </a:p>
+          <a:p>
+            <a:pPr lvl="1"/>
+            <a:r>
+              <a:rPr lang="en-US" dirty="0" smtClean="0"/>
+              <a:t>Low </a:t>
+            </a:r>
+            <a:r>
+              <a:rPr lang="en-US" dirty="0" smtClean="0"/>
+              <a:t>memory (128MB total, </a:t>
+            </a:r>
+            <a:r>
+              <a:rPr lang="en-US" smtClean="0"/>
+              <a:t>7MB working)</a:t>
+            </a:r>
+            <a:endParaRPr lang="en-US" dirty="0" smtClean="0"/>
+          </a:p>
+          <a:p>
+            <a:pPr lvl="1"/>
+            <a:r>
+              <a:rPr lang="en-US" dirty="0" smtClean="0"/>
+              <a:t>Can’t use flash storage</a:t>
+            </a:r>
+          </a:p>
+          <a:p>
+            <a:pPr lvl="1"/>
+            <a:r>
+              <a:rPr lang="en-US" dirty="0" smtClean="0"/>
+              <a:t>Low powered </a:t>
+            </a:r>
+            <a:r>
+              <a:rPr lang="en-US" dirty="0" smtClean="0"/>
+              <a:t>processor (800Mhz)</a:t>
+            </a:r>
+            <a:endParaRPr lang="en-US" dirty="0" smtClean="0"/>
+          </a:p>
+          <a:p>
+            <a:pPr lvl="1"/>
+            <a:r>
+              <a:rPr lang="en-US" dirty="0" smtClean="0"/>
+              <a:t>Limited bandwidth usage</a:t>
+            </a:r>
+          </a:p>
+          <a:p>
+            <a:r>
+              <a:rPr lang="en-US" dirty="0" smtClean="0"/>
+              <a:t>Server</a:t>
+            </a:r>
+          </a:p>
+          <a:p>
+            <a:pPr lvl="1"/>
+            <a:r>
+              <a:rPr lang="en-US" dirty="0" smtClean="0"/>
+              <a:t>Needs to be scalable to 100s or 1000s of users simultaneously connected</a:t>
+            </a:r>
+          </a:p>
+        </p:txBody>
+      </p:sp>
+      <p:sp>
+        <p:nvSpPr>
+          <p:cNvPr id="3" name="Title 2"/>
+          <p:cNvSpPr>
+            <a:spLocks noGrp="1"/>
+          </p:cNvSpPr>
+          <p:nvPr>
+            <p:ph type="title"/>
+          </p:nvPr>
+        </p:nvSpPr>
+        <p:spPr/>
+        <p:txBody>
           <a:bodyPr>
-            <a:normAutofit lnSpcReduction="10000"/>
+            <a:normAutofit/>
           </a:bodyPr>
           <a:lstStyle/>
           <a:p>
             <a:r>
               <a:rPr lang="en-US" dirty="0" smtClean="0"/>
-              <a:t>STB firmware updates during development</a:t>
-            </a:r>
-          </a:p>
-          <a:p>
-            <a:pPr lvl="1"/>
-            <a:r>
-              <a:rPr lang="en-US" dirty="0" smtClean="0"/>
-              <a:t>Previous project</a:t>
-            </a:r>
-          </a:p>
-          <a:p>
-            <a:pPr lvl="1"/>
-            <a:r>
-              <a:rPr lang="en-US" dirty="0" smtClean="0"/>
-              <a:t>Should only affect UI engine on STB</a:t>
-            </a:r>
-          </a:p>
-          <a:p>
-            <a:pPr lvl="1"/>
-            <a:r>
-              <a:rPr lang="en-US" dirty="0" smtClean="0"/>
-              <a:t>Contingency Plan</a:t>
-            </a:r>
-          </a:p>
-          <a:p>
-            <a:pPr lvl="2"/>
-            <a:r>
-              <a:rPr lang="en-US" dirty="0" smtClean="0"/>
-              <a:t>Update the engine as soon as possible</a:t>
-            </a:r>
-          </a:p>
-          <a:p>
-            <a:r>
-              <a:rPr lang="en-US" dirty="0" smtClean="0"/>
-              <a:t>Changing the game development process</a:t>
-            </a:r>
-          </a:p>
-          <a:p>
-            <a:pPr lvl="1"/>
-            <a:r>
-              <a:rPr lang="en-US" dirty="0" smtClean="0"/>
-              <a:t>Could increase game development time</a:t>
-            </a:r>
-          </a:p>
-          <a:p>
-            <a:pPr lvl="1"/>
-            <a:r>
-              <a:rPr lang="en-US" dirty="0" smtClean="0"/>
-              <a:t>Might make debugging even more difficult</a:t>
-            </a:r>
-          </a:p>
-          <a:p>
-            <a:pPr lvl="1"/>
-            <a:r>
-              <a:rPr lang="en-US" dirty="0" smtClean="0"/>
-              <a:t>Contingency Plan</a:t>
-            </a:r>
-          </a:p>
-          <a:p>
-            <a:pPr lvl="2"/>
-            <a:r>
-              <a:rPr lang="en-US" dirty="0" smtClean="0"/>
-              <a:t>Build an error logger into the client engine</a:t>
-            </a:r>
-          </a:p>
-          <a:p>
-            <a:pPr lvl="2"/>
-            <a:r>
-              <a:rPr lang="en-US" dirty="0" smtClean="0"/>
-              <a:t>Send crash reports to the server</a:t>
-            </a:r>
-          </a:p>
-          <a:p>
-            <a:pPr lvl="2"/>
-            <a:r>
-              <a:rPr lang="en-US" dirty="0" smtClean="0"/>
-              <a:t>Port existing games to new model</a:t>
-            </a:r>
-            <a:endParaRPr lang="en-US" dirty="0"/>
-          </a:p>
-        </p:txBody>
-      </p:sp>
-      <p:sp>
-        <p:nvSpPr>
-          <p:cNvPr id="3" name="Title 2"/>
-          <p:cNvSpPr>
-            <a:spLocks noGrp="1"/>
-          </p:cNvSpPr>
-          <p:nvPr>
-            <p:ph type="title"/>
-          </p:nvPr>
-        </p:nvSpPr>
-        <p:spPr/>
-        <p:txBody>
-          <a:bodyPr/>
-          <a:lstStyle/>
-          <a:p>
-            <a:r>
-              <a:rPr lang="en-US" dirty="0" smtClean="0"/>
-              <a:t>Risks</a:t>
+              <a:t>Constraints</a:t>
             </a:r>
             <a:endParaRPr lang="en-US" dirty="0"/>
           </a:p>
@@ -7283,7 +7549,7 @@
     </p:spTree>
     <p:extLst>
       <p:ext uri="{BB962C8B-B14F-4D97-AF65-F5344CB8AC3E}">
-        <p14:creationId xmlns:p14="http://schemas.microsoft.com/office/powerpoint/2010/main" val="1092627084"/>
+        <p14:creationId xmlns:p14="http://schemas.microsoft.com/office/powerpoint/2010/main" val="2063007733"/>
       </p:ext>
     </p:extLst>
   </p:cSld>
@@ -7330,127 +7596,88 @@
         <p:spPr/>
         <p:txBody>
           <a:bodyPr>
-            <a:normAutofit lnSpcReduction="10000"/>
+            <a:normAutofit/>
           </a:bodyPr>
           <a:lstStyle/>
           <a:p>
             <a:r>
               <a:rPr lang="en-US" dirty="0" smtClean="0"/>
-              <a:t>Sprint 1: </a:t>
-            </a:r>
-            <a:r>
-              <a:rPr lang="en-US" sz="2400" dirty="0" smtClean="0"/>
-              <a:t>September 19</a:t>
-            </a:r>
-            <a:r>
-              <a:rPr lang="en-US" sz="2400" baseline="30000" dirty="0" smtClean="0"/>
-              <a:t>th</a:t>
-            </a:r>
-            <a:r>
-              <a:rPr lang="en-US" sz="2400" dirty="0" smtClean="0"/>
-              <a:t> – October 3</a:t>
-            </a:r>
-            <a:r>
-              <a:rPr lang="en-US" sz="2400" baseline="30000" dirty="0" smtClean="0"/>
-              <a:t>rd</a:t>
-            </a:r>
-            <a:endParaRPr lang="en-US" sz="2400" dirty="0" smtClean="0"/>
+              <a:t>STB firmware updates during development</a:t>
+            </a:r>
           </a:p>
           <a:p>
             <a:pPr lvl="1"/>
             <a:r>
               <a:rPr lang="en-US" dirty="0" smtClean="0"/>
-              <a:t>Deliverables</a:t>
+              <a:t>Previous project</a:t>
+            </a:r>
+          </a:p>
+          <a:p>
+            <a:pPr lvl="1"/>
+            <a:r>
+              <a:rPr lang="en-US" dirty="0" smtClean="0"/>
+              <a:t>Should only affect UI engine on STB</a:t>
+            </a:r>
+          </a:p>
+          <a:p>
+            <a:pPr lvl="1"/>
+            <a:r>
+              <a:rPr lang="en-US" dirty="0" smtClean="0"/>
+              <a:t>Contingency Plan</a:t>
             </a:r>
           </a:p>
           <a:p>
             <a:pPr lvl="2"/>
             <a:r>
               <a:rPr lang="en-US" dirty="0" smtClean="0"/>
-              <a:t>Initial design document</a:t>
+              <a:t>Update the engine as soon as possible</a:t>
+            </a:r>
+          </a:p>
+          <a:p>
+            <a:r>
+              <a:rPr lang="en-US" dirty="0" smtClean="0"/>
+              <a:t>Changing the game development process</a:t>
+            </a:r>
+          </a:p>
+          <a:p>
+            <a:pPr lvl="1"/>
+            <a:r>
+              <a:rPr lang="en-US" dirty="0" smtClean="0"/>
+              <a:t>Could increase game development time</a:t>
+            </a:r>
+          </a:p>
+          <a:p>
+            <a:pPr lvl="1"/>
+            <a:r>
+              <a:rPr lang="en-US" dirty="0" smtClean="0"/>
+              <a:t>Might make debugging even more difficult</a:t>
+            </a:r>
+          </a:p>
+          <a:p>
+            <a:pPr lvl="1"/>
+            <a:r>
+              <a:rPr lang="en-US" dirty="0" smtClean="0"/>
+              <a:t>Contingency Plan</a:t>
             </a:r>
           </a:p>
           <a:p>
             <a:pPr lvl="2"/>
             <a:r>
               <a:rPr lang="en-US" dirty="0" smtClean="0"/>
-              <a:t>Initial requirements document</a:t>
-            </a:r>
-          </a:p>
-          <a:p>
-            <a:pPr lvl="1"/>
-            <a:r>
-              <a:rPr lang="en-US" dirty="0" smtClean="0"/>
-              <a:t>Environment: Setup and Testing</a:t>
+              <a:t>Build an error logger into the client engine</a:t>
             </a:r>
           </a:p>
           <a:p>
             <a:pPr lvl="2"/>
             <a:r>
               <a:rPr lang="en-US" dirty="0" smtClean="0"/>
-              <a:t>Meeting with STB team from Mitchell</a:t>
-            </a:r>
-          </a:p>
-          <a:p>
-            <a:pPr lvl="2"/>
-            <a:r>
-              <a:rPr lang="en-US" dirty="0" smtClean="0"/>
-              <a:t>Information exchange</a:t>
-            </a:r>
-          </a:p>
-          <a:p>
-            <a:pPr lvl="1"/>
-            <a:r>
-              <a:rPr lang="en-US" dirty="0" smtClean="0"/>
-              <a:t>Research</a:t>
-            </a:r>
-          </a:p>
-          <a:p>
-            <a:pPr lvl="2"/>
-            <a:r>
-              <a:rPr lang="en-US" dirty="0" smtClean="0"/>
-              <a:t>Dynamically load views on STB</a:t>
-            </a:r>
-          </a:p>
-          <a:p>
-            <a:pPr lvl="2"/>
-            <a:r>
-              <a:rPr lang="en-US" dirty="0" smtClean="0"/>
-              <a:t>Sending game state using Protocol Buffers</a:t>
-            </a:r>
-          </a:p>
-          <a:p>
-            <a:r>
-              <a:rPr lang="en-US" dirty="0" smtClean="0"/>
-              <a:t>Sprint 2: </a:t>
-            </a:r>
-            <a:r>
-              <a:rPr lang="en-US" sz="2400" dirty="0" smtClean="0"/>
-              <a:t>October 10</a:t>
-            </a:r>
-            <a:r>
-              <a:rPr lang="en-US" sz="2400" baseline="30000" dirty="0" smtClean="0"/>
-              <a:t>th</a:t>
-            </a:r>
-            <a:r>
-              <a:rPr lang="en-US" sz="2400" dirty="0" smtClean="0"/>
-              <a:t> – October 31</a:t>
-            </a:r>
-            <a:r>
-              <a:rPr lang="en-US" sz="2400" baseline="30000" dirty="0" smtClean="0"/>
-              <a:t>st</a:t>
-            </a:r>
-            <a:r>
-              <a:rPr lang="en-US" sz="2400" dirty="0" smtClean="0"/>
-              <a:t> </a:t>
-            </a:r>
-          </a:p>
-          <a:p>
-            <a:pPr lvl="1"/>
-            <a:r>
-              <a:rPr lang="en-US" dirty="0" smtClean="0"/>
-              <a:t>Begin development</a:t>
-            </a:r>
+              <a:t>Send crash reports to the </a:t>
+            </a:r>
+            <a:r>
+              <a:rPr lang="en-US" dirty="0" smtClean="0"/>
+              <a:t>server</a:t>
+            </a:r>
+            <a:endParaRPr lang="en-US" dirty="0" smtClean="0"/>
           </a:p>
         </p:txBody>
       </p:sp>
@@ -7471,7 +7698,7 @@
           <a:p>
             <a:r>
               <a:rPr lang="en-US" dirty="0" smtClean="0"/>
-              <a:t>Sprints</a:t>
+              <a:t>Risks</a:t>
             </a:r>
             <a:endParaRPr lang="en-US" dirty="0"/>
           </a:p>
@@ -7480,7 +7707,7 @@
     </p:spTree>
     <p:extLst>
       <p:ext uri="{BB962C8B-B14F-4D97-AF65-F5344CB8AC3E}">
-        <p14:creationId xmlns:p14="http://schemas.microsoft.com/office/powerpoint/2010/main" val="1446175581"/>
+        <p14:creationId xmlns:p14="http://schemas.microsoft.com/office/powerpoint/2010/main" val="1092627084"/>
       </p:ext>
     </p:extLst>
   </p:cSld>
@@ -7527,6 +7754,207 @@
         <p:spPr/>
         <p:txBody>
           <a:bodyPr>
+            <a:normAutofit lnSpcReduction="10000"/>
+          </a:bodyPr>
+          <a:lstStyle/>
+          <a:p>
+            <a:r>
+              <a:rPr lang="en-US" dirty="0" smtClean="0"/>
+              <a:t>Sprint 1: </a:t>
+            </a:r>
+            <a:r>
+              <a:rPr lang="en-US" sz="2400" dirty="0" smtClean="0"/>
+              <a:t>September 19</a:t>
+            </a:r>
+            <a:r>
+              <a:rPr lang="en-US" sz="2400" baseline="30000" dirty="0" smtClean="0"/>
+              <a:t>th</a:t>
+            </a:r>
+            <a:r>
+              <a:rPr lang="en-US" sz="2400" dirty="0" smtClean="0"/>
+              <a:t> – October 3</a:t>
+            </a:r>
+            <a:r>
+              <a:rPr lang="en-US" sz="2400" baseline="30000" dirty="0" smtClean="0"/>
+              <a:t>rd</a:t>
+            </a:r>
+            <a:endParaRPr lang="en-US" sz="2400" dirty="0" smtClean="0"/>
+          </a:p>
+          <a:p>
+            <a:pPr lvl="1"/>
+            <a:r>
+              <a:rPr lang="en-US" dirty="0" smtClean="0"/>
+              <a:t>Deliverables</a:t>
+            </a:r>
+          </a:p>
+          <a:p>
+            <a:pPr lvl="2"/>
+            <a:r>
+              <a:rPr lang="en-US" dirty="0" smtClean="0"/>
+              <a:t>Initial design document</a:t>
+            </a:r>
+          </a:p>
+          <a:p>
+            <a:pPr lvl="2"/>
+            <a:r>
+              <a:rPr lang="en-US" dirty="0" smtClean="0"/>
+              <a:t>Initial requirements document</a:t>
+            </a:r>
+          </a:p>
+          <a:p>
+            <a:pPr lvl="1"/>
+            <a:r>
+              <a:rPr lang="en-US" dirty="0" smtClean="0"/>
+              <a:t>Environment: Setup and Testing</a:t>
+            </a:r>
+          </a:p>
+          <a:p>
+            <a:pPr lvl="2"/>
+            <a:r>
+              <a:rPr lang="en-US" dirty="0" smtClean="0"/>
+              <a:t>Meeting with STB team from Mitchell</a:t>
+            </a:r>
+          </a:p>
+          <a:p>
+            <a:pPr lvl="2"/>
+            <a:r>
+              <a:rPr lang="en-US" dirty="0" smtClean="0"/>
+              <a:t>Information exchange</a:t>
+            </a:r>
+          </a:p>
+          <a:p>
+            <a:pPr lvl="1"/>
+            <a:r>
+              <a:rPr lang="en-US" dirty="0" smtClean="0"/>
+              <a:t>Research</a:t>
+            </a:r>
+          </a:p>
+          <a:p>
+            <a:pPr lvl="2"/>
+            <a:r>
+              <a:rPr lang="en-US" dirty="0" smtClean="0"/>
+              <a:t>Dynamically load views on STB</a:t>
+            </a:r>
+          </a:p>
+          <a:p>
+            <a:pPr lvl="2"/>
+            <a:r>
+              <a:rPr lang="en-US" dirty="0" smtClean="0"/>
+              <a:t>Sending game state using Protocol Buffers</a:t>
+            </a:r>
+          </a:p>
+          <a:p>
+            <a:r>
+              <a:rPr lang="en-US" dirty="0" smtClean="0"/>
+              <a:t>Sprint 2: </a:t>
+            </a:r>
+            <a:r>
+              <a:rPr lang="en-US" sz="2400" dirty="0" smtClean="0"/>
+              <a:t>October 10</a:t>
+            </a:r>
+            <a:r>
+              <a:rPr lang="en-US" sz="2400" baseline="30000" dirty="0" smtClean="0"/>
+              <a:t>th</a:t>
+            </a:r>
+            <a:r>
+              <a:rPr lang="en-US" sz="2400" dirty="0" smtClean="0"/>
+              <a:t> – October 31</a:t>
+            </a:r>
+            <a:r>
+              <a:rPr lang="en-US" sz="2400" baseline="30000" dirty="0" smtClean="0"/>
+              <a:t>st</a:t>
+            </a:r>
+            <a:r>
+              <a:rPr lang="en-US" sz="2400" dirty="0" smtClean="0"/>
+              <a:t> </a:t>
+            </a:r>
+          </a:p>
+          <a:p>
+            <a:pPr lvl="1"/>
+            <a:r>
+              <a:rPr lang="en-US" dirty="0" smtClean="0"/>
+              <a:t>Initial </a:t>
+            </a:r>
+            <a:r>
+              <a:rPr lang="en-US" dirty="0" smtClean="0"/>
+              <a:t>development</a:t>
+            </a:r>
+          </a:p>
+        </p:txBody>
+      </p:sp>
+      <p:sp>
+        <p:nvSpPr>
+          <p:cNvPr id="3" name="Title 2"/>
+          <p:cNvSpPr>
+            <a:spLocks noGrp="1"/>
+          </p:cNvSpPr>
+          <p:nvPr>
+            <p:ph type="title"/>
+          </p:nvPr>
+        </p:nvSpPr>
+        <p:spPr/>
+        <p:txBody>
+          <a:bodyPr/>
+          <a:lstStyle/>
+          <a:p>
+            <a:r>
+              <a:rPr lang="en-US" dirty="0" smtClean="0"/>
+              <a:t>Sprints</a:t>
+            </a:r>
+            <a:endParaRPr lang="en-US" dirty="0"/>
+          </a:p>
+        </p:txBody>
+      </p:sp>
+    </p:spTree>
+    <p:extLst>
+      <p:ext uri="{BB962C8B-B14F-4D97-AF65-F5344CB8AC3E}">
+        <p14:creationId xmlns:p14="http://schemas.microsoft.com/office/powerpoint/2010/main" val="1446175581"/>
+      </p:ext>
+    </p:extLst>
+  </p:cSld>
+  <p:clrMapOvr>
+    <a:masterClrMapping/>
+  </p:clrMapOvr>
+  <p:timing>
+    <p:tnLst>
+      <p:par>
+        <p:cTn id="1" dur="indefinite" restart="never" nodeType="tmRoot"/>
+      </p:par>
+    </p:tnLst>
+  </p:timing>
+</p:sld>
+</file>
+
+<file path=ppt/slides/slide16.xml><?xml version="1.0" encoding="utf-8"?>
+<p:sld xmlns:a="http://schemas.openxmlformats.org/drawingml/2006/main" xmlns:r="http://schemas.openxmlformats.org/officeDocument/2006/relationships" xmlns:p="http://schemas.openxmlformats.org/presentationml/2006/main">
+  <p:cSld>
+    <p:spTree>
+      <p:nvGrpSpPr>
+        <p:cNvPr id="1" name=""/>
+        <p:cNvGrpSpPr/>
+        <p:nvPr/>
+      </p:nvGrpSpPr>
+      <p:grpSpPr>
+        <a:xfrm>
+          <a:off x="0" y="0"/>
+          <a:ext cx="0" cy="0"/>
+          <a:chOff x="0" y="0"/>
+          <a:chExt cx="0" cy="0"/>
+        </a:xfrm>
+      </p:grpSpPr>
+      <p:sp>
+        <p:nvSpPr>
+          <p:cNvPr id="2" name="Content Placeholder 1"/>
+          <p:cNvSpPr>
+            <a:spLocks noGrp="1"/>
+          </p:cNvSpPr>
+          <p:nvPr>
+            <p:ph idx="1"/>
+          </p:nvPr>
+        </p:nvSpPr>
+        <p:spPr/>
+        <p:txBody>
+          <a:bodyPr>
             <a:normAutofit fontScale="70000" lnSpcReduction="20000"/>
           </a:bodyPr>
           <a:lstStyle/>
@@ -7722,7 +8150,7 @@
 </p:sld>
 </file>
 
-<file path=ppt/slides/slide16.xml><?xml version="1.0" encoding="utf-8"?>
+<file path=ppt/slides/slide17.xml><?xml version="1.0" encoding="utf-8"?>
 <p:sld xmlns:a="http://schemas.openxmlformats.org/drawingml/2006/main" xmlns:r="http://schemas.openxmlformats.org/officeDocument/2006/relationships" xmlns:p="http://schemas.openxmlformats.org/presentationml/2006/main">
   <p:cSld>
     <p:spTree>
@@ -8023,7 +8451,11 @@
           <a:p>
             <a:r>
               <a:rPr lang="en-US" dirty="0" smtClean="0"/>
-              <a:t>Client server architecture to host and deliver “plug-in” games</a:t>
+              <a:t>Client-server </a:t>
+            </a:r>
+            <a:r>
+              <a:rPr lang="en-US" dirty="0" smtClean="0"/>
+              <a:t>architecture to host and deliver “plug-in” games</a:t>
             </a:r>
           </a:p>
           <a:p>
@@ -8033,12 +8465,21 @@
             </a:r>
             <a:r>
               <a:rPr lang="en-US" dirty="0"/>
-              <a:t>S</a:t>
-            </a:r>
-            <a:r>
-              <a:rPr lang="en-US" dirty="0" smtClean="0"/>
-              <a:t>ingle Player</a:t>
-            </a:r>
+              <a:t>s</a:t>
+            </a:r>
+            <a:r>
+              <a:rPr lang="en-US" dirty="0" smtClean="0"/>
+              <a:t>ingle </a:t>
+            </a:r>
+            <a:r>
+              <a:rPr lang="en-US" dirty="0"/>
+              <a:t>p</a:t>
+            </a:r>
+            <a:r>
+              <a:rPr lang="en-US" dirty="0" smtClean="0"/>
+              <a:t>layer</a:t>
+            </a:r>
+            <a:endParaRPr lang="en-US" dirty="0" smtClean="0"/>
           </a:p>
           <a:p>
             <a:r>
@@ -8160,7 +8601,7 @@
           </p:nvPr>
         </p:nvPicPr>
         <p:blipFill>
-          <a:blip r:embed="rId2">
+          <a:blip r:embed="rId3">
             <a:extLst>
               <a:ext uri="{28A0092B-C50C-407E-A947-70E740481C1C}">
                 <a14:useLocalDpi xmlns:a14="http://schemas.microsoft.com/office/drawing/2010/main" val="0"/>
@@ -8697,33 +9138,130 @@
         <p:spPr/>
         <p:txBody>
           <a:bodyPr>
+            <a:normAutofit lnSpcReduction="10000"/>
+          </a:bodyPr>
+          <a:lstStyle/>
+          <a:p>
+            <a:r>
+              <a:rPr lang="en-US" dirty="0" smtClean="0"/>
+              <a:t>Base game framework</a:t>
+            </a:r>
+          </a:p>
+          <a:p>
+            <a:pPr lvl="1"/>
+            <a:r>
+              <a:rPr lang="en-US" dirty="0" smtClean="0"/>
+              <a:t>Communications</a:t>
+            </a:r>
+          </a:p>
+          <a:p>
+            <a:pPr lvl="2"/>
+            <a:r>
+              <a:rPr lang="en-US" dirty="0" smtClean="0"/>
+              <a:t>Command Link</a:t>
+            </a:r>
+          </a:p>
+          <a:p>
+            <a:pPr lvl="2"/>
+            <a:r>
+              <a:rPr lang="en-US" dirty="0" smtClean="0"/>
+              <a:t>Protocol Buffers</a:t>
+            </a:r>
+          </a:p>
+          <a:p>
+            <a:pPr lvl="1"/>
+            <a:r>
+              <a:rPr lang="en-US" dirty="0" smtClean="0"/>
+              <a:t>Two generic </a:t>
+            </a:r>
+            <a:r>
+              <a:rPr lang="en-US" dirty="0" smtClean="0"/>
+              <a:t>game UI engines</a:t>
+            </a:r>
+          </a:p>
+          <a:p>
+            <a:pPr lvl="2"/>
+            <a:r>
+              <a:rPr lang="en-US" dirty="0" smtClean="0"/>
+              <a:t>Board games UI</a:t>
+            </a:r>
+          </a:p>
+          <a:p>
+            <a:pPr lvl="2"/>
+            <a:r>
+              <a:rPr lang="en-US" dirty="0" smtClean="0"/>
+              <a:t>Card games </a:t>
+            </a:r>
+            <a:r>
+              <a:rPr lang="en-US" dirty="0" smtClean="0"/>
+              <a:t>UI</a:t>
+            </a:r>
+          </a:p>
+          <a:p>
+            <a:pPr lvl="1"/>
+            <a:r>
+              <a:rPr lang="en-US" dirty="0" smtClean="0"/>
+              <a:t>Only uses gamestate to update UI</a:t>
+            </a:r>
+          </a:p>
+          <a:p>
+            <a:pPr lvl="1"/>
+            <a:r>
+              <a:rPr lang="en-US" dirty="0" smtClean="0"/>
+              <a:t>No code sent over network</a:t>
+            </a:r>
+          </a:p>
+        </p:txBody>
+      </p:sp>
+      <p:sp>
+        <p:nvSpPr>
+          <p:cNvPr id="9" name="Content Placeholder 8"/>
+          <p:cNvSpPr>
+            <a:spLocks noGrp="1"/>
+          </p:cNvSpPr>
+          <p:nvPr>
+            <p:ph sz="quarter" idx="4"/>
+          </p:nvPr>
+        </p:nvSpPr>
+        <p:spPr/>
+        <p:txBody>
+          <a:bodyPr>
             <a:normAutofit/>
           </a:bodyPr>
           <a:lstStyle/>
           <a:p>
             <a:r>
               <a:rPr lang="en-US" dirty="0" smtClean="0"/>
-              <a:t>Base game framework</a:t>
-            </a:r>
+              <a:t>Per </a:t>
+            </a:r>
+            <a:r>
+              <a:rPr lang="en-US" dirty="0"/>
+              <a:t>game </a:t>
+            </a:r>
+            <a:r>
+              <a:rPr lang="en-US" dirty="0" smtClean="0"/>
+              <a:t>framework</a:t>
+            </a:r>
+            <a:endParaRPr lang="en-US" dirty="0"/>
           </a:p>
           <a:p>
             <a:pPr lvl="1"/>
             <a:r>
-              <a:rPr lang="en-US" dirty="0" smtClean="0"/>
+              <a:rPr lang="en-US" dirty="0"/>
               <a:t>Communications</a:t>
             </a:r>
           </a:p>
           <a:p>
             <a:pPr lvl="2"/>
             <a:r>
-              <a:rPr lang="en-US" dirty="0" smtClean="0"/>
+              <a:rPr lang="en-US" dirty="0"/>
               <a:t>Command Link</a:t>
             </a:r>
           </a:p>
           <a:p>
             <a:pPr lvl="2"/>
             <a:r>
-              <a:rPr lang="en-US" dirty="0" smtClean="0"/>
+              <a:rPr lang="en-US" dirty="0"/>
               <a:t>Protocol Buffers</a:t>
             </a:r>
           </a:p>
@@ -8731,90 +9269,23 @@
             <a:pPr lvl="1"/>
             <a:r>
               <a:rPr lang="en-US" dirty="0" smtClean="0"/>
-              <a:t>Debug Log</a:t>
+              <a:t>Each </a:t>
+            </a:r>
+            <a:r>
+              <a:rPr lang="en-US" dirty="0"/>
+              <a:t>game contains its own UI </a:t>
+            </a:r>
+            <a:r>
+              <a:rPr lang="en-US" dirty="0" smtClean="0"/>
+              <a:t>engine</a:t>
             </a:r>
           </a:p>
           <a:p>
             <a:pPr lvl="1"/>
             <a:r>
               <a:rPr lang="en-US" dirty="0" smtClean="0"/>
-              <a:t>Two game UI engines</a:t>
-            </a:r>
-          </a:p>
-          <a:p>
-            <a:pPr lvl="2"/>
-            <a:r>
-              <a:rPr lang="en-US" dirty="0" smtClean="0"/>
-              <a:t>Board games UI</a:t>
-            </a:r>
-          </a:p>
-          <a:p>
-            <a:pPr lvl="2"/>
-            <a:r>
-              <a:rPr lang="en-US" dirty="0" smtClean="0"/>
-              <a:t>Card games UI</a:t>
-            </a:r>
-          </a:p>
-          <a:p>
-            <a:pPr lvl="1"/>
-            <a:r>
-              <a:rPr lang="en-US" dirty="0" smtClean="0"/>
-              <a:t>Games implemented using C#</a:t>
-            </a:r>
-          </a:p>
-        </p:txBody>
-      </p:sp>
-      <p:sp>
-        <p:nvSpPr>
-          <p:cNvPr id="9" name="Content Placeholder 8"/>
-          <p:cNvSpPr>
-            <a:spLocks noGrp="1"/>
-          </p:cNvSpPr>
-          <p:nvPr>
-            <p:ph sz="quarter" idx="4"/>
-          </p:nvPr>
-        </p:nvSpPr>
-        <p:spPr/>
-        <p:txBody>
-          <a:bodyPr/>
-          <a:lstStyle/>
-          <a:p>
-            <a:r>
-              <a:rPr lang="en-US" dirty="0" smtClean="0"/>
-              <a:t>Individual </a:t>
-            </a:r>
-            <a:r>
-              <a:rPr lang="en-US" dirty="0"/>
-              <a:t>game framework</a:t>
-            </a:r>
-          </a:p>
-          <a:p>
-            <a:pPr lvl="1"/>
-            <a:r>
-              <a:rPr lang="en-US" dirty="0"/>
-              <a:t>Each game contains its own UI engine</a:t>
-            </a:r>
-          </a:p>
-          <a:p>
-            <a:pPr lvl="1"/>
-            <a:r>
-              <a:rPr lang="en-US" dirty="0"/>
-              <a:t>Games use </a:t>
-            </a:r>
-            <a:r>
-              <a:rPr lang="en-US" dirty="0" smtClean="0"/>
-              <a:t>same communications as Implementation #1</a:t>
-            </a:r>
-          </a:p>
-          <a:p>
-            <a:pPr lvl="1"/>
-            <a:r>
-              <a:rPr lang="en-US" dirty="0" smtClean="0"/>
-              <a:t>Game continued to be created with current environment</a:t>
-            </a:r>
-            <a:endParaRPr lang="en-US" dirty="0"/>
-          </a:p>
-          <a:p>
+              <a:t>Sends a binary plugin to each STB</a:t>
+            </a:r>
             <a:endParaRPr lang="en-US" dirty="0"/>
           </a:p>
         </p:txBody>
@@ -8921,8 +9392,12 @@
           <a:p>
             <a:pPr lvl="1"/>
             <a:r>
+              <a:rPr lang="en-US" dirty="0" smtClean="0"/>
+              <a:t>Potentially less </a:t>
+            </a:r>
+            <a:r>
               <a:rPr lang="en-US" dirty="0"/>
-              <a:t>Slightly less stable, since it is generic</a:t>
+              <a:t>stable, since it is generic</a:t>
             </a:r>
           </a:p>
           <a:p>
@@ -8960,7 +9435,15 @@
             <a:pPr lvl="1"/>
             <a:r>
               <a:rPr lang="en-US" dirty="0" smtClean="0"/>
-              <a:t>More stable per game</a:t>
+              <a:t>Ideally m</a:t>
+            </a:r>
+            <a:r>
+              <a:rPr lang="en-US" dirty="0" smtClean="0"/>
+              <a:t>ore </a:t>
+            </a:r>
+            <a:r>
+              <a:rPr lang="en-US" dirty="0" smtClean="0"/>
+              <a:t>stable per game</a:t>
             </a:r>
           </a:p>
           <a:p>
@@ -8992,7 +9475,7 @@
           <p:nvPr>
             <p:extLst>
               <p:ext uri="{D42A27DB-BD31-4B8C-83A1-F6EECF244321}">
-                <p14:modId xmlns:p14="http://schemas.microsoft.com/office/powerpoint/2010/main" val="1863238026"/>
+                <p14:modId xmlns:p14="http://schemas.microsoft.com/office/powerpoint/2010/main" val="3613842038"/>
               </p:ext>
             </p:extLst>
           </p:nvPr>
@@ -9005,12 +9488,12 @@
           <a:graphicData uri="http://schemas.openxmlformats.org/presentationml/2006/ole">
             <mc:AlternateContent xmlns:mc="http://schemas.openxmlformats.org/markup-compatibility/2006">
               <mc:Choice xmlns:v="urn:schemas-microsoft-com:vml" Requires="v">
-                <p:oleObj spid="_x0000_s1049" name="Worksheet" r:id="rId3" imgW="6134179" imgH="1181100" progId="Excel.Sheet.12">
+                <p:oleObj spid="_x0000_s1084" name="Worksheet" r:id="rId4" imgW="6134179" imgH="1181100" progId="Excel.Sheet.12">
                   <p:embed/>
                 </p:oleObj>
               </mc:Choice>
               <mc:Fallback>
-                <p:oleObj name="Worksheet" r:id="rId3" imgW="6134179" imgH="1181100" progId="Excel.Sheet.12">
+                <p:oleObj name="Worksheet" r:id="rId4" imgW="6134179" imgH="1181100" progId="Excel.Sheet.12">
                   <p:embed/>
                   <p:pic>
                     <p:nvPicPr>
@@ -9021,7 +9504,7 @@
                       <p:nvPr/>
                     </p:nvPicPr>
                     <p:blipFill>
-                      <a:blip r:embed="rId4"/>
+                      <a:blip r:embed="rId5"/>
                       <a:srcRect/>
                       <a:stretch>
                         <a:fillRect/>
@@ -9105,7 +9588,7 @@
       </p:grpSpPr>
       <p:sp>
         <p:nvSpPr>
-          <p:cNvPr id="7" name="Content Placeholder 6"/>
+          <p:cNvPr id="2" name="Content Placeholder 1"/>
           <p:cNvSpPr>
             <a:spLocks noGrp="1"/>
           </p:cNvSpPr>
@@ -9118,60 +9601,13 @@
           <a:bodyPr/>
           <a:lstStyle/>
           <a:p>
-            <a:r>
-              <a:rPr lang="en-US" dirty="0" smtClean="0"/>
-              <a:t>Written in C# under .NET 4.5</a:t>
-            </a:r>
-          </a:p>
-          <a:p>
-            <a:r>
-              <a:rPr lang="en-US" dirty="0" smtClean="0"/>
-              <a:t>Windows server environment</a:t>
-            </a:r>
-          </a:p>
-          <a:p>
-            <a:pPr lvl="1"/>
-            <a:r>
-              <a:rPr lang="en-US" dirty="0" smtClean="0"/>
-              <a:t>Portable to Azure</a:t>
-            </a:r>
-          </a:p>
-          <a:p>
-            <a:r>
-              <a:rPr lang="en-US" dirty="0" smtClean="0"/>
-              <a:t>SQL database</a:t>
-            </a:r>
-          </a:p>
-          <a:p>
-            <a:r>
-              <a:rPr lang="en-US" dirty="0" smtClean="0"/>
-              <a:t>Facilitates communication between clients</a:t>
-            </a:r>
-          </a:p>
-          <a:p>
-            <a:r>
-              <a:rPr lang="en-US" dirty="0" smtClean="0"/>
-              <a:t>Processes AI for virtual players</a:t>
-            </a:r>
-          </a:p>
-          <a:p>
-            <a:r>
-              <a:rPr lang="en-US" dirty="0" smtClean="0"/>
-              <a:t>Deploys game resources to client</a:t>
-            </a:r>
-          </a:p>
-          <a:p>
-            <a:r>
-              <a:rPr lang="en-US" dirty="0" smtClean="0"/>
-              <a:t>Manages logic for each multiplayer game instance</a:t>
-            </a:r>
-            <a:endParaRPr lang="en-US" dirty="0"/>
-          </a:p>
-        </p:txBody>
-      </p:sp>
-      <p:sp>
-        <p:nvSpPr>
-          <p:cNvPr id="2" name="Title 1"/>
+            <a:endParaRPr lang="en-US"/>
+          </a:p>
+        </p:txBody>
+      </p:sp>
+      <p:sp>
+        <p:nvSpPr>
+          <p:cNvPr id="3" name="Title 2"/>
           <p:cNvSpPr>
             <a:spLocks noGrp="1"/>
           </p:cNvSpPr>
@@ -9186,7 +9622,7 @@
           <a:p>
             <a:r>
               <a:rPr lang="en-US" dirty="0" smtClean="0"/>
-              <a:t>Design Analysis - Server</a:t>
+              <a:t>STB Prototype Video</a:t>
             </a:r>
             <a:endParaRPr lang="en-US" dirty="0"/>
           </a:p>
@@ -9195,7 +9631,7 @@
     </p:spTree>
     <p:extLst>
       <p:ext uri="{BB962C8B-B14F-4D97-AF65-F5344CB8AC3E}">
-        <p14:creationId xmlns:p14="http://schemas.microsoft.com/office/powerpoint/2010/main" val="3561777257"/>
+        <p14:creationId xmlns:p14="http://schemas.microsoft.com/office/powerpoint/2010/main" val="2254636584"/>
       </p:ext>
     </p:extLst>
   </p:cSld>
@@ -9229,35 +9665,84 @@
           <a:chExt cx="0" cy="0"/>
         </a:xfrm>
       </p:grpSpPr>
-      <p:pic>
-        <p:nvPicPr>
-          <p:cNvPr id="3" name="Content Placeholder 2"/>
-          <p:cNvPicPr>
-            <a:picLocks noGrp="1" noChangeAspect="1"/>
-          </p:cNvPicPr>
+      <p:sp>
+        <p:nvSpPr>
+          <p:cNvPr id="7" name="Content Placeholder 6"/>
+          <p:cNvSpPr>
+            <a:spLocks noGrp="1"/>
+          </p:cNvSpPr>
           <p:nvPr>
             <p:ph idx="1"/>
           </p:nvPr>
-        </p:nvPicPr>
-        <p:blipFill>
-          <a:blip r:embed="rId3">
-            <a:extLst>
-              <a:ext uri="{28A0092B-C50C-407E-A947-70E740481C1C}">
-                <a14:useLocalDpi xmlns:a14="http://schemas.microsoft.com/office/drawing/2010/main" val="0"/>
-              </a:ext>
-            </a:extLst>
-          </a:blip>
-          <a:stretch>
-            <a:fillRect/>
-          </a:stretch>
-        </p:blipFill>
-        <p:spPr>
-          <a:xfrm>
-            <a:off x="1143000" y="1143000"/>
-            <a:ext cx="6934200" cy="5185501"/>
-          </a:xfrm>
-        </p:spPr>
-      </p:pic>
+        </p:nvSpPr>
+        <p:spPr/>
+        <p:txBody>
+          <a:bodyPr>
+            <a:normAutofit lnSpcReduction="10000"/>
+          </a:bodyPr>
+          <a:lstStyle/>
+          <a:p>
+            <a:r>
+              <a:rPr lang="en-US" dirty="0" smtClean="0"/>
+              <a:t>Written in C# under .NET 4.5</a:t>
+            </a:r>
+          </a:p>
+          <a:p>
+            <a:r>
+              <a:rPr lang="en-US" dirty="0" smtClean="0"/>
+              <a:t>Windows server environment</a:t>
+            </a:r>
+          </a:p>
+          <a:p>
+            <a:pPr lvl="1"/>
+            <a:r>
+              <a:rPr lang="en-US" dirty="0" smtClean="0"/>
+              <a:t>Portable to Azure</a:t>
+            </a:r>
+          </a:p>
+          <a:p>
+            <a:r>
+              <a:rPr lang="en-US" dirty="0" smtClean="0"/>
+              <a:t>SQL database</a:t>
+            </a:r>
+          </a:p>
+          <a:p>
+            <a:r>
+              <a:rPr lang="en-US" dirty="0" smtClean="0"/>
+              <a:t>Facilitates communication between clients</a:t>
+            </a:r>
+          </a:p>
+          <a:p>
+            <a:r>
+              <a:rPr lang="en-US" dirty="0" smtClean="0"/>
+              <a:t>Processes AI for virtual players</a:t>
+            </a:r>
+          </a:p>
+          <a:p>
+            <a:r>
+              <a:rPr lang="en-US" dirty="0" smtClean="0"/>
+              <a:t>Deploys game resources to client</a:t>
+            </a:r>
+          </a:p>
+          <a:p>
+            <a:r>
+              <a:rPr lang="en-US" dirty="0" smtClean="0"/>
+              <a:t>Manages logic for each multiplayer game </a:t>
+            </a:r>
+            <a:r>
+              <a:rPr lang="en-US" dirty="0" smtClean="0"/>
+              <a:t>instance</a:t>
+            </a:r>
+          </a:p>
+          <a:p>
+            <a:r>
+              <a:rPr lang="en-US" dirty="0" smtClean="0"/>
+              <a:t>Error Log to view game crash reports</a:t>
+            </a:r>
+            <a:endParaRPr lang="en-US" dirty="0"/>
+          </a:p>
+        </p:txBody>
+      </p:sp>
       <p:sp>
         <p:nvSpPr>
           <p:cNvPr id="2" name="Title 1"/>
@@ -9284,7 +9769,7 @@
     </p:spTree>
     <p:extLst>
       <p:ext uri="{BB962C8B-B14F-4D97-AF65-F5344CB8AC3E}">
-        <p14:creationId xmlns:p14="http://schemas.microsoft.com/office/powerpoint/2010/main" val="2750846494"/>
+        <p14:creationId xmlns:p14="http://schemas.microsoft.com/office/powerpoint/2010/main" val="3561777257"/>
       </p:ext>
     </p:extLst>
   </p:cSld>

</xml_diff>

<commit_message>
Changed some wording in the presentation
</commit_message>
<xml_diff>
--- a/Sprint1_Documents/Sprint 1 Review.pptx
+++ b/Sprint1_Documents/Sprint 1 Review.pptx
@@ -208,7 +208,7 @@
           <a:p>
             <a:fld id="{54B4DD35-6E11-43E5-91A4-D3C24AD61D59}" type="datetimeFigureOut">
               <a:rPr lang="en-US" smtClean="0"/>
-              <a:t>10/8/2012</a:t>
+              <a:t>10/9/2012</a:t>
             </a:fld>
             <a:endParaRPr lang="en-US"/>
           </a:p>
@@ -534,11 +534,7 @@
             </a:r>
             <a:r>
               <a:rPr lang="en-US" baseline="0" dirty="0" smtClean="0"/>
-              <a:t> introduces the team, each person introduces </a:t>
-            </a:r>
-            <a:r>
-              <a:rPr lang="en-US" baseline="0" dirty="0" smtClean="0"/>
-              <a:t>themselves</a:t>
+              <a:t> introduces the team, each person introduces themselves</a:t>
             </a:r>
           </a:p>
           <a:p>
@@ -634,7 +630,6 @@
               <a:rPr lang="en-US" dirty="0" smtClean="0"/>
               <a:t>Kevin</a:t>
             </a:r>
-            <a:endParaRPr lang="en-US" dirty="0" smtClean="0"/>
           </a:p>
           <a:p>
             <a:r>
@@ -1207,19 +1202,7 @@
             </a:r>
             <a:r>
               <a:rPr lang="en-US" baseline="0" dirty="0" smtClean="0"/>
-              <a:t> </a:t>
-            </a:r>
-            <a:r>
-              <a:rPr lang="en-US" baseline="0" dirty="0" smtClean="0"/>
-              <a:t>show </a:t>
-            </a:r>
-            <a:r>
-              <a:rPr lang="en-US" baseline="0" dirty="0" smtClean="0"/>
-              <a:t>that we have a backlog, no need to go into great detail </a:t>
-            </a:r>
-            <a:r>
-              <a:rPr lang="en-US" baseline="0" dirty="0" smtClean="0"/>
-              <a:t>here</a:t>
+              <a:t> show that we have a backlog, no need to go into great detail here</a:t>
             </a:r>
           </a:p>
           <a:p>
@@ -1660,11 +1643,7 @@
             </a:r>
             <a:r>
               <a:rPr lang="en-US" baseline="0" dirty="0" smtClean="0"/>
-              <a:t> </a:t>
-            </a:r>
-            <a:r>
-              <a:rPr lang="en-US" baseline="0" dirty="0" smtClean="0"/>
-              <a:t>– needs refinement</a:t>
+              <a:t> – needs refinement</a:t>
             </a:r>
             <a:endParaRPr lang="en-US" dirty="0"/>
           </a:p>
@@ -2771,7 +2750,7 @@
           <a:p>
             <a:fld id="{8D64633F-4130-4F4B-BCC3-306A9B157C17}" type="datetimeFigureOut">
               <a:rPr lang="en-US" smtClean="0"/>
-              <a:t>10/8/2012</a:t>
+              <a:t>10/9/2012</a:t>
             </a:fld>
             <a:endParaRPr lang="en-US"/>
           </a:p>
@@ -2967,7 +2946,7 @@
           <a:p>
             <a:fld id="{8D64633F-4130-4F4B-BCC3-306A9B157C17}" type="datetimeFigureOut">
               <a:rPr lang="en-US" smtClean="0"/>
-              <a:t>10/8/2012</a:t>
+              <a:t>10/9/2012</a:t>
             </a:fld>
             <a:endParaRPr lang="en-US"/>
           </a:p>
@@ -3152,7 +3131,7 @@
           <a:p>
             <a:fld id="{8D64633F-4130-4F4B-BCC3-306A9B157C17}" type="datetimeFigureOut">
               <a:rPr lang="en-US" smtClean="0"/>
-              <a:t>10/8/2012</a:t>
+              <a:t>10/9/2012</a:t>
             </a:fld>
             <a:endParaRPr lang="en-US"/>
           </a:p>
@@ -3302,7 +3281,7 @@
           <a:p>
             <a:fld id="{8D64633F-4130-4F4B-BCC3-306A9B157C17}" type="datetimeFigureOut">
               <a:rPr lang="en-US" smtClean="0"/>
-              <a:t>10/8/2012</a:t>
+              <a:t>10/9/2012</a:t>
             </a:fld>
             <a:endParaRPr lang="en-US"/>
           </a:p>
@@ -3557,7 +3536,7 @@
           <a:p>
             <a:fld id="{8D64633F-4130-4F4B-BCC3-306A9B157C17}" type="datetimeFigureOut">
               <a:rPr lang="en-US" smtClean="0"/>
-              <a:t>10/8/2012</a:t>
+              <a:t>10/9/2012</a:t>
             </a:fld>
             <a:endParaRPr lang="en-US"/>
           </a:p>
@@ -3966,7 +3945,7 @@
           <a:p>
             <a:fld id="{8D64633F-4130-4F4B-BCC3-306A9B157C17}" type="datetimeFigureOut">
               <a:rPr lang="en-US" smtClean="0"/>
-              <a:t>10/8/2012</a:t>
+              <a:t>10/9/2012</a:t>
             </a:fld>
             <a:endParaRPr lang="en-US"/>
           </a:p>
@@ -4412,7 +4391,7 @@
           <a:p>
             <a:fld id="{8D64633F-4130-4F4B-BCC3-306A9B157C17}" type="datetimeFigureOut">
               <a:rPr lang="en-US" smtClean="0"/>
-              <a:t>10/8/2012</a:t>
+              <a:t>10/9/2012</a:t>
             </a:fld>
             <a:endParaRPr lang="en-US"/>
           </a:p>
@@ -4513,7 +4492,7 @@
           <a:p>
             <a:fld id="{8D64633F-4130-4F4B-BCC3-306A9B157C17}" type="datetimeFigureOut">
               <a:rPr lang="en-US" smtClean="0"/>
-              <a:t>10/8/2012</a:t>
+              <a:t>10/9/2012</a:t>
             </a:fld>
             <a:endParaRPr lang="en-US"/>
           </a:p>
@@ -4634,7 +4613,7 @@
           <a:p>
             <a:fld id="{8D64633F-4130-4F4B-BCC3-306A9B157C17}" type="datetimeFigureOut">
               <a:rPr lang="en-US" smtClean="0"/>
-              <a:t>10/8/2012</a:t>
+              <a:t>10/9/2012</a:t>
             </a:fld>
             <a:endParaRPr lang="en-US"/>
           </a:p>
@@ -4908,7 +4887,7 @@
           <a:p>
             <a:fld id="{8D64633F-4130-4F4B-BCC3-306A9B157C17}" type="datetimeFigureOut">
               <a:rPr lang="en-US" smtClean="0"/>
-              <a:t>10/8/2012</a:t>
+              <a:t>10/9/2012</a:t>
             </a:fld>
             <a:endParaRPr lang="en-US"/>
           </a:p>
@@ -5113,7 +5092,7 @@
           <a:p>
             <a:fld id="{8D64633F-4130-4F4B-BCC3-306A9B157C17}" type="datetimeFigureOut">
               <a:rPr lang="en-US" smtClean="0"/>
-              <a:t>10/8/2012</a:t>
+              <a:t>10/9/2012</a:t>
             </a:fld>
             <a:endParaRPr lang="en-US"/>
           </a:p>
@@ -6222,7 +6201,7 @@
           <a:p>
             <a:fld id="{8D64633F-4130-4F4B-BCC3-306A9B157C17}" type="datetimeFigureOut">
               <a:rPr lang="en-US" smtClean="0"/>
-              <a:t>10/8/2012</a:t>
+              <a:t>10/9/2012</a:t>
             </a:fld>
             <a:endParaRPr lang="en-US"/>
           </a:p>
@@ -6867,11 +6846,7 @@
             <a:pPr lvl="1"/>
             <a:r>
               <a:rPr lang="en-US" dirty="0" smtClean="0"/>
-              <a:t>Connects </a:t>
-            </a:r>
-            <a:r>
-              <a:rPr lang="en-US" dirty="0" smtClean="0"/>
-              <a:t>APMax units</a:t>
+              <a:t>Connects APMax units</a:t>
             </a:r>
           </a:p>
           <a:p>
@@ -6884,37 +6859,21 @@
             <a:pPr lvl="1"/>
             <a:r>
               <a:rPr lang="en-US" dirty="0" smtClean="0"/>
-              <a:t>Optional – If </a:t>
-            </a:r>
-            <a:r>
-              <a:rPr lang="en-US" dirty="0" smtClean="0"/>
-              <a:t>the </a:t>
+              <a:t>Optional – If the </a:t>
             </a:r>
             <a:br>
               <a:rPr lang="en-US" dirty="0" smtClean="0"/>
             </a:br>
             <a:r>
               <a:rPr lang="en-US" dirty="0" smtClean="0"/>
-              <a:t>central server</a:t>
-            </a:r>
-            <a:r>
-              <a:rPr lang="en-US" dirty="0" smtClean="0"/>
-              <a:t> </a:t>
-            </a:r>
-            <a:r>
-              <a:rPr lang="en-US" dirty="0" smtClean="0"/>
-              <a:t>can’t</a:t>
+              <a:t>central server can’t</a:t>
             </a:r>
             <a:br>
               <a:rPr lang="en-US" dirty="0" smtClean="0"/>
             </a:br>
             <a:r>
               <a:rPr lang="en-US" dirty="0" smtClean="0"/>
-              <a:t>handle all game </a:t>
-            </a:r>
-            <a:r>
-              <a:rPr lang="en-US" dirty="0" smtClean="0"/>
-              <a:t>A.I.</a:t>
+              <a:t>handle all game A.I.</a:t>
             </a:r>
           </a:p>
           <a:p>
@@ -7468,11 +7427,7 @@
             <a:pPr lvl="1"/>
             <a:r>
               <a:rPr lang="en-US" dirty="0" smtClean="0"/>
-              <a:t>Low </a:t>
-            </a:r>
-            <a:r>
-              <a:rPr lang="en-US" dirty="0" smtClean="0"/>
-              <a:t>memory (128MB total, </a:t>
+              <a:t>Low memory (128MB total, </a:t>
             </a:r>
             <a:r>
               <a:rPr lang="en-US" smtClean="0"/>
@@ -7491,13 +7446,8 @@
             <a:pPr lvl="1"/>
             <a:r>
               <a:rPr lang="en-US" dirty="0" smtClean="0"/>
-              <a:t>Low powered </a:t>
-            </a:r>
-            <a:r>
-              <a:rPr lang="en-US" dirty="0" smtClean="0"/>
-              <a:t>processor (800Mhz)</a:t>
-            </a:r>
-            <a:endParaRPr lang="en-US" dirty="0" smtClean="0"/>
+              <a:t>Low powered processor (800Mhz)</a:t>
+            </a:r>
           </a:p>
           <a:p>
             <a:pPr lvl="1"/>
@@ -7671,13 +7621,8 @@
             <a:pPr lvl="2"/>
             <a:r>
               <a:rPr lang="en-US" dirty="0" smtClean="0"/>
-              <a:t>Send crash reports to the </a:t>
-            </a:r>
-            <a:r>
-              <a:rPr lang="en-US" dirty="0" smtClean="0"/>
-              <a:t>server</a:t>
-            </a:r>
-            <a:endParaRPr lang="en-US" dirty="0" smtClean="0"/>
+              <a:t>Send crash reports to the server</a:t>
+            </a:r>
           </a:p>
         </p:txBody>
       </p:sp>
@@ -7873,11 +7818,7 @@
             <a:pPr lvl="1"/>
             <a:r>
               <a:rPr lang="en-US" dirty="0" smtClean="0"/>
-              <a:t>Initial </a:t>
-            </a:r>
-            <a:r>
-              <a:rPr lang="en-US" dirty="0" smtClean="0"/>
-              <a:t>development</a:t>
+              <a:t>Initial development</a:t>
             </a:r>
           </a:p>
         </p:txBody>
@@ -8264,7 +8205,11 @@
           <a:p>
             <a:r>
               <a:rPr lang="en-US" dirty="0" smtClean="0"/>
-              <a:t>Convert games to proof-of-concept multiplayer games.</a:t>
+              <a:t>Convert currently existing </a:t>
+            </a:r>
+            <a:r>
+              <a:rPr lang="en-US" dirty="0" smtClean="0"/>
+              <a:t>games to proof-of-concept multiplayer games.</a:t>
             </a:r>
           </a:p>
         </p:txBody>
@@ -8354,6 +8299,17 @@
           <a:p>
             <a:r>
               <a:rPr lang="en-US" dirty="0" smtClean="0"/>
+              <a:t>Deliver two </a:t>
+            </a:r>
+            <a:r>
+              <a:rPr lang="en-US" smtClean="0"/>
+              <a:t>working games</a:t>
+            </a:r>
+            <a:endParaRPr lang="en-US" dirty="0" smtClean="0"/>
+          </a:p>
+          <a:p>
+            <a:r>
+              <a:rPr lang="en-US" dirty="0" smtClean="0"/>
               <a:t>In house</a:t>
             </a:r>
           </a:p>
@@ -8451,11 +8407,7 @@
           <a:p>
             <a:r>
               <a:rPr lang="en-US" dirty="0" smtClean="0"/>
-              <a:t>Client-server </a:t>
-            </a:r>
-            <a:r>
-              <a:rPr lang="en-US" dirty="0" smtClean="0"/>
-              <a:t>architecture to host and deliver “plug-in” games</a:t>
+              <a:t>Client-server architecture to host and deliver “plug-in” games</a:t>
             </a:r>
           </a:p>
           <a:p>
@@ -8479,7 +8431,6 @@
               <a:rPr lang="en-US" dirty="0" smtClean="0"/>
               <a:t>layer</a:t>
             </a:r>
-            <a:endParaRPr lang="en-US" dirty="0" smtClean="0"/>
           </a:p>
           <a:p>
             <a:r>
@@ -9172,11 +9123,7 @@
             <a:pPr lvl="1"/>
             <a:r>
               <a:rPr lang="en-US" dirty="0" smtClean="0"/>
-              <a:t>Two generic </a:t>
-            </a:r>
-            <a:r>
-              <a:rPr lang="en-US" dirty="0" smtClean="0"/>
-              <a:t>game UI engines</a:t>
+              <a:t>Two generic game UI engines</a:t>
             </a:r>
           </a:p>
           <a:p>
@@ -9190,11 +9137,7 @@
             <a:pPr lvl="2"/>
             <a:r>
               <a:rPr lang="en-US" dirty="0" smtClean="0"/>
-              <a:t>Card games </a:t>
-            </a:r>
-            <a:r>
-              <a:rPr lang="en-US" dirty="0" smtClean="0"/>
-              <a:t>UI</a:t>
+              <a:t>Card games UI</a:t>
             </a:r>
           </a:p>
           <a:p>
@@ -9435,15 +9378,7 @@
             <a:pPr lvl="1"/>
             <a:r>
               <a:rPr lang="en-US" dirty="0" smtClean="0"/>
-              <a:t>Ideally m</a:t>
-            </a:r>
-            <a:r>
-              <a:rPr lang="en-US" dirty="0" smtClean="0"/>
-              <a:t>ore </a:t>
-            </a:r>
-            <a:r>
-              <a:rPr lang="en-US" dirty="0" smtClean="0"/>
-              <a:t>stable per game</a:t>
+              <a:t>Ideally more stable per game</a:t>
             </a:r>
           </a:p>
           <a:p>
@@ -9488,7 +9423,7 @@
           <a:graphicData uri="http://schemas.openxmlformats.org/presentationml/2006/ole">
             <mc:AlternateContent xmlns:mc="http://schemas.openxmlformats.org/markup-compatibility/2006">
               <mc:Choice xmlns:v="urn:schemas-microsoft-com:vml" Requires="v">
-                <p:oleObj spid="_x0000_s1084" name="Worksheet" r:id="rId4" imgW="6134179" imgH="1181100" progId="Excel.Sheet.12">
+                <p:oleObj spid="_x0000_s1087" name="Worksheet" r:id="rId4" imgW="6134179" imgH="1181100" progId="Excel.Sheet.12">
                   <p:embed/>
                 </p:oleObj>
               </mc:Choice>
@@ -9727,11 +9662,7 @@
           <a:p>
             <a:r>
               <a:rPr lang="en-US" dirty="0" smtClean="0"/>
-              <a:t>Manages logic for each multiplayer game </a:t>
-            </a:r>
-            <a:r>
-              <a:rPr lang="en-US" dirty="0" smtClean="0"/>
-              <a:t>instance</a:t>
+              <a:t>Manages logic for each multiplayer game instance</a:t>
             </a:r>
           </a:p>
           <a:p>

</xml_diff>